<commit_message>
Localize deliverables into Korean
</commit_message>
<xml_diff>
--- a/deliverables/presentation_draft.pptx
+++ b/deliverables/presentation_draft.pptx
@@ -1641,34 +1641,34 @@
               <a:buNone/>
             </a:pPr>
             <a:r>
-              <a:rPr lang="en-US" sz="2800" b="1" dirty="0">
+              <a:rPr lang="en-US" sz="2600" b="1" dirty="0">
                 <a:solidFill>
                   <a:srgbClr val="F6F2E8"/>
                 </a:solidFill>
-                <a:latin typeface="Aptos Display" pitchFamily="34" charset="0"/>
-                <a:ea typeface="Aptos Display" pitchFamily="34" charset="-122"/>
-                <a:cs typeface="Aptos Display" pitchFamily="34" charset="-120"/>
-              </a:rPr>
-              <a:t>LNG Cold-Energy</a:t>
-            </a:r>
-            <a:endParaRPr lang="en-US" sz="2800" dirty="0"/>
-          </a:p>
-          <a:p>
-            <a:pPr indent="0" marL="0">
-              <a:buNone/>
-            </a:pPr>
-            <a:r>
-              <a:rPr lang="en-US" sz="2800" b="1" dirty="0">
+                <a:latin typeface="Malgun Gothic" pitchFamily="34" charset="0"/>
+                <a:ea typeface="Malgun Gothic" pitchFamily="34" charset="-122"/>
+                <a:cs typeface="Malgun Gothic" pitchFamily="34" charset="-120"/>
+              </a:rPr>
+              <a:t>LNG 냉열 활용</a:t>
+            </a:r>
+            <a:endParaRPr lang="en-US" sz="2600" dirty="0"/>
+          </a:p>
+          <a:p>
+            <a:pPr indent="0" marL="0">
+              <a:buNone/>
+            </a:pPr>
+            <a:r>
+              <a:rPr lang="en-US" sz="2600" b="1" dirty="0">
                 <a:solidFill>
                   <a:srgbClr val="F6F2E8"/>
                 </a:solidFill>
-                <a:latin typeface="Aptos Display" pitchFamily="34" charset="0"/>
-                <a:ea typeface="Aptos Display" pitchFamily="34" charset="-122"/>
-                <a:cs typeface="Aptos Display" pitchFamily="34" charset="-120"/>
-              </a:rPr>
-              <a:t>IDC Cooling System</a:t>
-            </a:r>
-            <a:endParaRPr lang="en-US" sz="2800" dirty="0"/>
+                <a:latin typeface="Malgun Gothic" pitchFamily="34" charset="0"/>
+                <a:ea typeface="Malgun Gothic" pitchFamily="34" charset="-122"/>
+                <a:cs typeface="Malgun Gothic" pitchFamily="34" charset="-120"/>
+              </a:rPr>
+              <a:t>IDC 냉각시스템</a:t>
+            </a:r>
+            <a:endParaRPr lang="en-US" sz="2600" dirty="0"/>
           </a:p>
         </p:txBody>
       </p:sp>
@@ -1697,17 +1697,17 @@
               <a:buNone/>
             </a:pPr>
             <a:r>
-              <a:rPr lang="en-US" sz="1400" dirty="0">
+              <a:rPr lang="en-US" sz="1300" dirty="0">
                 <a:solidFill>
                   <a:srgbClr val="D8E1E8"/>
                 </a:solidFill>
-                <a:latin typeface="Aptos" pitchFamily="34" charset="0"/>
-                <a:ea typeface="Aptos" pitchFamily="34" charset="-122"/>
-                <a:cs typeface="Aptos" pitchFamily="34" charset="-120"/>
-              </a:rPr>
-              <a:t>Reproducible thermal-system design study with scenario, economics, and source traceability.</a:t>
-            </a:r>
-            <a:endParaRPr lang="en-US" sz="1400" dirty="0"/>
+                <a:latin typeface="Malgun Gothic" pitchFamily="34" charset="0"/>
+                <a:ea typeface="Malgun Gothic" pitchFamily="34" charset="-122"/>
+                <a:cs typeface="Malgun Gothic" pitchFamily="34" charset="-120"/>
+              </a:rPr>
+              <a:t>시나리오 분석, 경제성 평가, 출처 추적을 포함한 재현 가능한 코드 기반 설계 연구</a:t>
+            </a:r>
+            <a:endParaRPr lang="en-US" sz="1300" dirty="0"/>
           </a:p>
         </p:txBody>
       </p:sp>
@@ -1801,11 +1801,11 @@
                 <a:solidFill>
                   <a:srgbClr val="5A6675"/>
                 </a:solidFill>
-                <a:latin typeface="Aptos" pitchFamily="34" charset="0"/>
-                <a:ea typeface="Aptos" pitchFamily="34" charset="-122"/>
-                <a:cs typeface="Aptos" pitchFamily="34" charset="-120"/>
-              </a:rPr>
-              <a:t>Cooling load</a:t>
+                <a:latin typeface="Malgun Gothic" pitchFamily="34" charset="0"/>
+                <a:ea typeface="Malgun Gothic" pitchFamily="34" charset="-122"/>
+                <a:cs typeface="Malgun Gothic" pitchFamily="34" charset="-120"/>
+              </a:rPr>
+              <a:t>냉방부하</a:t>
             </a:r>
             <a:endParaRPr lang="en-US" sz="1000" dirty="0"/>
           </a:p>
@@ -1840,9 +1840,9 @@
                 <a:solidFill>
                   <a:srgbClr val="10243D"/>
                 </a:solidFill>
-                <a:latin typeface="Aptos Display" pitchFamily="34" charset="0"/>
-                <a:ea typeface="Aptos Display" pitchFamily="34" charset="-122"/>
-                <a:cs typeface="Aptos Display" pitchFamily="34" charset="-120"/>
+                <a:latin typeface="Malgun Gothic" pitchFamily="34" charset="0"/>
+                <a:ea typeface="Malgun Gothic" pitchFamily="34" charset="-122"/>
+                <a:cs typeface="Malgun Gothic" pitchFamily="34" charset="-120"/>
               </a:rPr>
               <a:t>13.48 MW</a:t>
             </a:r>
@@ -1879,11 +1879,11 @@
                 <a:solidFill>
                   <a:srgbClr val="5A6675"/>
                 </a:solidFill>
-                <a:latin typeface="Aptos" pitchFamily="34" charset="0"/>
-                <a:ea typeface="Aptos" pitchFamily="34" charset="-122"/>
-                <a:cs typeface="Aptos" pitchFamily="34" charset="-120"/>
-              </a:rPr>
-              <a:t>Modeled IDC duty</a:t>
+                <a:latin typeface="Malgun Gothic" pitchFamily="34" charset="0"/>
+                <a:ea typeface="Malgun Gothic" pitchFamily="34" charset="-122"/>
+                <a:cs typeface="Malgun Gothic" pitchFamily="34" charset="-120"/>
+              </a:rPr>
+              <a:t>모델링된 IDC 부하</a:t>
             </a:r>
             <a:endParaRPr lang="en-US" sz="850" dirty="0"/>
           </a:p>
@@ -1979,11 +1979,11 @@
                 <a:solidFill>
                   <a:srgbClr val="5A6675"/>
                 </a:solidFill>
-                <a:latin typeface="Aptos" pitchFamily="34" charset="0"/>
-                <a:ea typeface="Aptos" pitchFamily="34" charset="-122"/>
-                <a:cs typeface="Aptos" pitchFamily="34" charset="-120"/>
-              </a:rPr>
-              <a:t>Base case</a:t>
+                <a:latin typeface="Malgun Gothic" pitchFamily="34" charset="0"/>
+                <a:ea typeface="Malgun Gothic" pitchFamily="34" charset="-122"/>
+                <a:cs typeface="Malgun Gothic" pitchFamily="34" charset="-120"/>
+              </a:rPr>
+              <a:t>기본 조건</a:t>
             </a:r>
             <a:endParaRPr lang="en-US" sz="1000" dirty="0"/>
           </a:p>
@@ -2018,9 +2018,9 @@
                 <a:solidFill>
                   <a:srgbClr val="10243D"/>
                 </a:solidFill>
-                <a:latin typeface="Aptos Display" pitchFamily="34" charset="0"/>
-                <a:ea typeface="Aptos Display" pitchFamily="34" charset="-122"/>
-                <a:cs typeface="Aptos Display" pitchFamily="34" charset="-120"/>
+                <a:latin typeface="Malgun Gothic" pitchFamily="34" charset="0"/>
+                <a:ea typeface="Malgun Gothic" pitchFamily="34" charset="-122"/>
+                <a:cs typeface="Malgun Gothic" pitchFamily="34" charset="-120"/>
               </a:rPr>
               <a:t>10 km</a:t>
             </a:r>
@@ -2057,11 +2057,11 @@
                 <a:solidFill>
                   <a:srgbClr val="5A6675"/>
                 </a:solidFill>
-                <a:latin typeface="Aptos" pitchFamily="34" charset="0"/>
-                <a:ea typeface="Aptos" pitchFamily="34" charset="-122"/>
-                <a:cs typeface="Aptos" pitchFamily="34" charset="-120"/>
-              </a:rPr>
-              <a:t>One-way transport distance</a:t>
+                <a:latin typeface="Malgun Gothic" pitchFamily="34" charset="0"/>
+                <a:ea typeface="Malgun Gothic" pitchFamily="34" charset="-122"/>
+                <a:cs typeface="Malgun Gothic" pitchFamily="34" charset="-120"/>
+              </a:rPr>
+              <a:t>편도 이송거리</a:t>
             </a:r>
             <a:endParaRPr lang="en-US" sz="850" dirty="0"/>
           </a:p>
@@ -2157,11 +2157,11 @@
                 <a:solidFill>
                   <a:srgbClr val="5A6675"/>
                 </a:solidFill>
-                <a:latin typeface="Aptos" pitchFamily="34" charset="0"/>
-                <a:ea typeface="Aptos" pitchFamily="34" charset="-122"/>
-                <a:cs typeface="Aptos" pitchFamily="34" charset="-120"/>
-              </a:rPr>
-              <a:t>Power saving</a:t>
+                <a:latin typeface="Malgun Gothic" pitchFamily="34" charset="0"/>
+                <a:ea typeface="Malgun Gothic" pitchFamily="34" charset="-122"/>
+                <a:cs typeface="Malgun Gothic" pitchFamily="34" charset="-120"/>
+              </a:rPr>
+              <a:t>전력 절감</a:t>
             </a:r>
             <a:endParaRPr lang="en-US" sz="1000" dirty="0"/>
           </a:p>
@@ -2196,9 +2196,9 @@
                 <a:solidFill>
                   <a:srgbClr val="10243D"/>
                 </a:solidFill>
-                <a:latin typeface="Aptos Display" pitchFamily="34" charset="0"/>
-                <a:ea typeface="Aptos Display" pitchFamily="34" charset="-122"/>
-                <a:cs typeface="Aptos Display" pitchFamily="34" charset="-120"/>
+                <a:latin typeface="Malgun Gothic" pitchFamily="34" charset="0"/>
+                <a:ea typeface="Malgun Gothic" pitchFamily="34" charset="-122"/>
+                <a:cs typeface="Malgun Gothic" pitchFamily="34" charset="-120"/>
               </a:rPr>
               <a:t>4.17 MW</a:t>
             </a:r>
@@ -2235,11 +2235,11 @@
                 <a:solidFill>
                   <a:srgbClr val="5A6675"/>
                 </a:solidFill>
-                <a:latin typeface="Aptos" pitchFamily="34" charset="0"/>
-                <a:ea typeface="Aptos" pitchFamily="34" charset="-122"/>
-                <a:cs typeface="Aptos" pitchFamily="34" charset="-120"/>
-              </a:rPr>
-              <a:t>Baseline compressor minus LNG loop</a:t>
+                <a:latin typeface="Malgun Gothic" pitchFamily="34" charset="0"/>
+                <a:ea typeface="Malgun Gothic" pitchFamily="34" charset="-122"/>
+                <a:cs typeface="Malgun Gothic" pitchFamily="34" charset="-120"/>
+              </a:rPr>
+              <a:t>기준 압축기 대비</a:t>
             </a:r>
             <a:endParaRPr lang="en-US" sz="850" dirty="0"/>
           </a:p>
@@ -2301,11 +2301,11 @@
                 <a:solidFill>
                   <a:srgbClr val="10243D"/>
                 </a:solidFill>
-                <a:latin typeface="Aptos Display" pitchFamily="34" charset="0"/>
-                <a:ea typeface="Aptos Display" pitchFamily="34" charset="-122"/>
-                <a:cs typeface="Aptos Display" pitchFamily="34" charset="-120"/>
-              </a:rPr>
-              <a:t>What changed from the old project</a:t>
+                <a:latin typeface="Malgun Gothic" pitchFamily="34" charset="0"/>
+                <a:ea typeface="Malgun Gothic" pitchFamily="34" charset="-122"/>
+                <a:cs typeface="Malgun Gothic" pitchFamily="34" charset="-120"/>
+              </a:rPr>
+              <a:t>이번 재구축에서 달라진 점</a:t>
             </a:r>
             <a:endParaRPr lang="en-US" sz="1500" dirty="0"/>
           </a:p>
@@ -2341,11 +2341,11 @@
                 <a:solidFill>
                   <a:srgbClr val="28323F"/>
                 </a:solidFill>
-                <a:latin typeface="Aptos" pitchFamily="34" charset="0"/>
-                <a:ea typeface="Aptos" pitchFamily="34" charset="-122"/>
-                <a:cs typeface="Aptos" pitchFamily="34" charset="-120"/>
-              </a:rPr>
-              <a:t>Full code reproduction instead of spreadsheet-only work</a:t>
+                <a:latin typeface="Malgun Gothic" pitchFamily="34" charset="0"/>
+                <a:ea typeface="Malgun Gothic" pitchFamily="34" charset="-122"/>
+                <a:cs typeface="Malgun Gothic" pitchFamily="34" charset="-120"/>
+              </a:rPr>
+              <a:t>스프레드시트가 아닌 코드 중심 재구축</a:t>
             </a:r>
             <a:endParaRPr lang="en-US" sz="1250" dirty="0"/>
           </a:p>
@@ -2359,11 +2359,11 @@
                 <a:solidFill>
                   <a:srgbClr val="28323F"/>
                 </a:solidFill>
-                <a:latin typeface="Aptos" pitchFamily="34" charset="0"/>
-                <a:ea typeface="Aptos" pitchFamily="34" charset="-122"/>
-                <a:cs typeface="Aptos" pitchFamily="34" charset="-120"/>
-              </a:rPr>
-              <a:t>Explicit source and assumption registry</a:t>
+                <a:latin typeface="Malgun Gothic" pitchFamily="34" charset="0"/>
+                <a:ea typeface="Malgun Gothic" pitchFamily="34" charset="-122"/>
+                <a:cs typeface="Malgun Gothic" pitchFamily="34" charset="-120"/>
+              </a:rPr>
+              <a:t>출처와 가정을 명시적으로 기록</a:t>
             </a:r>
             <a:endParaRPr lang="en-US" sz="1250" dirty="0"/>
           </a:p>
@@ -2377,11 +2377,11 @@
                 <a:solidFill>
                   <a:srgbClr val="28323F"/>
                 </a:solidFill>
-                <a:latin typeface="Aptos" pitchFamily="34" charset="0"/>
-                <a:ea typeface="Aptos" pitchFamily="34" charset="-122"/>
-                <a:cs typeface="Aptos" pitchFamily="34" charset="-120"/>
-              </a:rPr>
-              <a:t>Distance, fluid, and temperature sensitivity studies</a:t>
+                <a:latin typeface="Malgun Gothic" pitchFamily="34" charset="0"/>
+                <a:ea typeface="Malgun Gothic" pitchFamily="34" charset="-122"/>
+                <a:cs typeface="Malgun Gothic" pitchFamily="34" charset="-120"/>
+              </a:rPr>
+              <a:t>거리, 유체, 온도 민감도까지 분석</a:t>
             </a:r>
             <a:endParaRPr lang="en-US" sz="1250" dirty="0"/>
           </a:p>
@@ -2416,11 +2416,11 @@
                 <a:solidFill>
                   <a:srgbClr val="5A6675"/>
                 </a:solidFill>
-                <a:latin typeface="Aptos" pitchFamily="34" charset="0"/>
-                <a:ea typeface="Aptos" pitchFamily="34" charset="-122"/>
-                <a:cs typeface="Aptos" pitchFamily="34" charset="-120"/>
-              </a:rPr>
-              <a:t>Course project | Generated from deliverables/slides_src/presentation_draft.js</a:t>
+                <a:latin typeface="Malgun Gothic" pitchFamily="34" charset="0"/>
+                <a:ea typeface="Malgun Gothic" pitchFamily="34" charset="-122"/>
+                <a:cs typeface="Malgun Gothic" pitchFamily="34" charset="-120"/>
+              </a:rPr>
+              <a:t>열시스템디자인 프로젝트 | slides_src/presentation_draft.js에서 생성</a:t>
             </a:r>
             <a:endParaRPr lang="en-US" sz="800" dirty="0"/>
           </a:p>
@@ -2487,11 +2487,11 @@
                 <a:solidFill>
                   <a:srgbClr val="5AA7A4"/>
                 </a:solidFill>
-                <a:latin typeface="Aptos" pitchFamily="34" charset="0"/>
-                <a:ea typeface="Aptos" pitchFamily="34" charset="-122"/>
-                <a:cs typeface="Aptos" pitchFamily="34" charset="-120"/>
-              </a:rPr>
-              <a:t>PROJECT FRAME</a:t>
+                <a:latin typeface="Malgun Gothic" pitchFamily="34" charset="0"/>
+                <a:ea typeface="Malgun Gothic" pitchFamily="34" charset="-122"/>
+                <a:cs typeface="Malgun Gothic" pitchFamily="34" charset="-120"/>
+              </a:rPr>
+              <a:t>프로젝트 개요</a:t>
             </a:r>
             <a:endParaRPr lang="en-US" sz="1000" dirty="0"/>
           </a:p>
@@ -2522,17 +2522,17 @@
               <a:buNone/>
             </a:pPr>
             <a:r>
-              <a:rPr lang="en-US" sz="2400" b="1" dirty="0">
+              <a:rPr lang="en-US" sz="2200" b="1" dirty="0">
                 <a:solidFill>
                   <a:srgbClr val="F6F2E8"/>
                 </a:solidFill>
-                <a:latin typeface="Aptos Display" pitchFamily="34" charset="0"/>
-                <a:ea typeface="Aptos Display" pitchFamily="34" charset="-122"/>
-                <a:cs typeface="Aptos Display" pitchFamily="34" charset="-120"/>
-              </a:rPr>
-              <a:t>Design Question and Basis</a:t>
-            </a:r>
-            <a:endParaRPr lang="en-US" sz="2400" dirty="0"/>
+                <a:latin typeface="Malgun Gothic" pitchFamily="34" charset="0"/>
+                <a:ea typeface="Malgun Gothic" pitchFamily="34" charset="-122"/>
+                <a:cs typeface="Malgun Gothic" pitchFamily="34" charset="-120"/>
+              </a:rPr>
+              <a:t>설계 질문과 기준</a:t>
+            </a:r>
+            <a:endParaRPr lang="en-US" sz="2200" dirty="0"/>
           </a:p>
         </p:txBody>
       </p:sp>
@@ -2592,11 +2592,11 @@
                 <a:solidFill>
                   <a:srgbClr val="10243D"/>
                 </a:solidFill>
-                <a:latin typeface="Aptos Display" pitchFamily="34" charset="0"/>
-                <a:ea typeface="Aptos Display" pitchFamily="34" charset="-122"/>
-                <a:cs typeface="Aptos Display" pitchFamily="34" charset="-120"/>
-              </a:rPr>
-              <a:t>Design question</a:t>
+                <a:latin typeface="Malgun Gothic" pitchFamily="34" charset="0"/>
+                <a:ea typeface="Malgun Gothic" pitchFamily="34" charset="-122"/>
+                <a:cs typeface="Malgun Gothic" pitchFamily="34" charset="-120"/>
+              </a:rPr>
+              <a:t>핵심 질문</a:t>
             </a:r>
             <a:endParaRPr lang="en-US" sz="1500" dirty="0"/>
           </a:p>
@@ -2632,11 +2632,11 @@
                 <a:solidFill>
                   <a:srgbClr val="28323F"/>
                 </a:solidFill>
-                <a:latin typeface="Aptos" pitchFamily="34" charset="0"/>
-                <a:ea typeface="Aptos" pitchFamily="34" charset="-122"/>
-                <a:cs typeface="Aptos" pitchFamily="34" charset="-120"/>
-              </a:rPr>
-              <a:t>Can LNG cold energy replace the reference R-134a cooling load for a large IDC?</a:t>
+                <a:latin typeface="Malgun Gothic" pitchFamily="34" charset="0"/>
+                <a:ea typeface="Malgun Gothic" pitchFamily="34" charset="-122"/>
+                <a:cs typeface="Malgun Gothic" pitchFamily="34" charset="-120"/>
+              </a:rPr>
+              <a:t>LNG 냉열로 대형 IDC의 기준 R-134a 냉방부하를 대체할 수 있는가?</a:t>
             </a:r>
             <a:endParaRPr lang="en-US" sz="1250" dirty="0"/>
           </a:p>
@@ -2650,11 +2650,11 @@
                 <a:solidFill>
                   <a:srgbClr val="28323F"/>
                 </a:solidFill>
-                <a:latin typeface="Aptos" pitchFamily="34" charset="0"/>
-                <a:ea typeface="Aptos" pitchFamily="34" charset="-122"/>
-                <a:cs typeface="Aptos" pitchFamily="34" charset="-120"/>
-              </a:rPr>
-              <a:t>Can the concept survive the transport-distance penalty between the LNG terminal and the site?</a:t>
+                <a:latin typeface="Malgun Gothic" pitchFamily="34" charset="0"/>
+                <a:ea typeface="Malgun Gothic" pitchFamily="34" charset="-122"/>
+                <a:cs typeface="Malgun Gothic" pitchFamily="34" charset="-120"/>
+              </a:rPr>
+              <a:t>LNG 기지와 부지 사이 장거리 이송 페널티를 견딜 수 있는가?</a:t>
             </a:r>
             <a:endParaRPr lang="en-US" sz="1250" dirty="0"/>
           </a:p>
@@ -2668,11 +2668,11 @@
                 <a:solidFill>
                   <a:srgbClr val="28323F"/>
                 </a:solidFill>
-                <a:latin typeface="Aptos" pitchFamily="34" charset="0"/>
-                <a:ea typeface="Aptos" pitchFamily="34" charset="-122"/>
-                <a:cs typeface="Aptos" pitchFamily="34" charset="-120"/>
-              </a:rPr>
-              <a:t>What is the economic value if the modeled cooling power reduction is sustained year-round?</a:t>
+                <a:latin typeface="Malgun Gothic" pitchFamily="34" charset="0"/>
+                <a:ea typeface="Malgun Gothic" pitchFamily="34" charset="-122"/>
+                <a:cs typeface="Malgun Gothic" pitchFamily="34" charset="-120"/>
+              </a:rPr>
+              <a:t>이 전력 절감이 지속될 때 경제적 가치는 어느 정도인가?</a:t>
             </a:r>
             <a:endParaRPr lang="en-US" sz="1250" dirty="0"/>
           </a:p>
@@ -2768,11 +2768,11 @@
                 <a:solidFill>
                   <a:srgbClr val="5A6675"/>
                 </a:solidFill>
-                <a:latin typeface="Aptos" pitchFamily="34" charset="0"/>
-                <a:ea typeface="Aptos" pitchFamily="34" charset="-122"/>
-                <a:cs typeface="Aptos" pitchFamily="34" charset="-120"/>
-              </a:rPr>
-              <a:t>Modeled load</a:t>
+                <a:latin typeface="Malgun Gothic" pitchFamily="34" charset="0"/>
+                <a:ea typeface="Malgun Gothic" pitchFamily="34" charset="-122"/>
+                <a:cs typeface="Malgun Gothic" pitchFamily="34" charset="-120"/>
+              </a:rPr>
+              <a:t>모델 부하</a:t>
             </a:r>
             <a:endParaRPr lang="en-US" sz="1000" dirty="0"/>
           </a:p>
@@ -2807,9 +2807,9 @@
                 <a:solidFill>
                   <a:srgbClr val="10243D"/>
                 </a:solidFill>
-                <a:latin typeface="Aptos Display" pitchFamily="34" charset="0"/>
-                <a:ea typeface="Aptos Display" pitchFamily="34" charset="-122"/>
-                <a:cs typeface="Aptos Display" pitchFamily="34" charset="-120"/>
+                <a:latin typeface="Malgun Gothic" pitchFamily="34" charset="0"/>
+                <a:ea typeface="Malgun Gothic" pitchFamily="34" charset="-122"/>
+                <a:cs typeface="Malgun Gothic" pitchFamily="34" charset="-120"/>
               </a:rPr>
               <a:t>13.48 MW</a:t>
             </a:r>
@@ -2846,11 +2846,11 @@
                 <a:solidFill>
                   <a:srgbClr val="5A6675"/>
                 </a:solidFill>
-                <a:latin typeface="Aptos" pitchFamily="34" charset="0"/>
-                <a:ea typeface="Aptos" pitchFamily="34" charset="-122"/>
-                <a:cs typeface="Aptos" pitchFamily="34" charset="-120"/>
-              </a:rPr>
-              <a:t>IDC cooling duty</a:t>
+                <a:latin typeface="Malgun Gothic" pitchFamily="34" charset="0"/>
+                <a:ea typeface="Malgun Gothic" pitchFamily="34" charset="-122"/>
+                <a:cs typeface="Malgun Gothic" pitchFamily="34" charset="-120"/>
+              </a:rPr>
+              <a:t>IDC 냉방부하</a:t>
             </a:r>
             <a:endParaRPr lang="en-US" sz="850" dirty="0"/>
           </a:p>
@@ -2946,11 +2946,11 @@
                 <a:solidFill>
                   <a:srgbClr val="5A6675"/>
                 </a:solidFill>
-                <a:latin typeface="Aptos" pitchFamily="34" charset="0"/>
-                <a:ea typeface="Aptos" pitchFamily="34" charset="-122"/>
-                <a:cs typeface="Aptos" pitchFamily="34" charset="-120"/>
-              </a:rPr>
-              <a:t>Challenge case</a:t>
+                <a:latin typeface="Malgun Gothic" pitchFamily="34" charset="0"/>
+                <a:ea typeface="Malgun Gothic" pitchFamily="34" charset="-122"/>
+                <a:cs typeface="Malgun Gothic" pitchFamily="34" charset="-120"/>
+              </a:rPr>
+              <a:t>도전 조건</a:t>
             </a:r>
             <a:endParaRPr lang="en-US" sz="1000" dirty="0"/>
           </a:p>
@@ -2985,9 +2985,9 @@
                 <a:solidFill>
                   <a:srgbClr val="10243D"/>
                 </a:solidFill>
-                <a:latin typeface="Aptos Display" pitchFamily="34" charset="0"/>
-                <a:ea typeface="Aptos Display" pitchFamily="34" charset="-122"/>
-                <a:cs typeface="Aptos Display" pitchFamily="34" charset="-120"/>
+                <a:latin typeface="Malgun Gothic" pitchFamily="34" charset="0"/>
+                <a:ea typeface="Malgun Gothic" pitchFamily="34" charset="-122"/>
+                <a:cs typeface="Malgun Gothic" pitchFamily="34" charset="-120"/>
               </a:rPr>
               <a:t>35 km</a:t>
             </a:r>
@@ -3024,11 +3024,11 @@
                 <a:solidFill>
                   <a:srgbClr val="5A6675"/>
                 </a:solidFill>
-                <a:latin typeface="Aptos" pitchFamily="34" charset="0"/>
-                <a:ea typeface="Aptos" pitchFamily="34" charset="-122"/>
-                <a:cs typeface="Aptos" pitchFamily="34" charset="-120"/>
-              </a:rPr>
-              <a:t>Long-distance test</a:t>
+                <a:latin typeface="Malgun Gothic" pitchFamily="34" charset="0"/>
+                <a:ea typeface="Malgun Gothic" pitchFamily="34" charset="-122"/>
+                <a:cs typeface="Malgun Gothic" pitchFamily="34" charset="-120"/>
+              </a:rPr>
+              <a:t>장거리 검토</a:t>
             </a:r>
             <a:endParaRPr lang="en-US" sz="850" dirty="0"/>
           </a:p>
@@ -3124,11 +3124,11 @@
                 <a:solidFill>
                   <a:srgbClr val="5A6675"/>
                 </a:solidFill>
-                <a:latin typeface="Aptos" pitchFamily="34" charset="0"/>
-                <a:ea typeface="Aptos" pitchFamily="34" charset="-122"/>
-                <a:cs typeface="Aptos" pitchFamily="34" charset="-120"/>
-              </a:rPr>
-              <a:t>Reference power</a:t>
+                <a:latin typeface="Malgun Gothic" pitchFamily="34" charset="0"/>
+                <a:ea typeface="Malgun Gothic" pitchFamily="34" charset="-122"/>
+                <a:cs typeface="Malgun Gothic" pitchFamily="34" charset="-120"/>
+              </a:rPr>
+              <a:t>기준 전력</a:t>
             </a:r>
             <a:endParaRPr lang="en-US" sz="1000" dirty="0"/>
           </a:p>
@@ -3163,9 +3163,9 @@
                 <a:solidFill>
                   <a:srgbClr val="10243D"/>
                 </a:solidFill>
-                <a:latin typeface="Aptos Display" pitchFamily="34" charset="0"/>
-                <a:ea typeface="Aptos Display" pitchFamily="34" charset="-122"/>
-                <a:cs typeface="Aptos Display" pitchFamily="34" charset="-120"/>
+                <a:latin typeface="Malgun Gothic" pitchFamily="34" charset="0"/>
+                <a:ea typeface="Malgun Gothic" pitchFamily="34" charset="-122"/>
+                <a:cs typeface="Malgun Gothic" pitchFamily="34" charset="-120"/>
               </a:rPr>
               <a:t>4.19 MW</a:t>
             </a:r>
@@ -3202,11 +3202,11 @@
                 <a:solidFill>
                   <a:srgbClr val="5A6675"/>
                 </a:solidFill>
-                <a:latin typeface="Aptos" pitchFamily="34" charset="0"/>
-                <a:ea typeface="Aptos" pitchFamily="34" charset="-122"/>
-                <a:cs typeface="Aptos" pitchFamily="34" charset="-120"/>
-              </a:rPr>
-              <a:t>R-134a compressor</a:t>
+                <a:latin typeface="Malgun Gothic" pitchFamily="34" charset="0"/>
+                <a:ea typeface="Malgun Gothic" pitchFamily="34" charset="-122"/>
+                <a:cs typeface="Malgun Gothic" pitchFamily="34" charset="-120"/>
+              </a:rPr>
+              <a:t>R-134a 압축기</a:t>
             </a:r>
             <a:endParaRPr lang="en-US" sz="850" dirty="0"/>
           </a:p>
@@ -3289,11 +3289,11 @@
                 <a:solidFill>
                   <a:srgbClr val="10243D"/>
                 </a:solidFill>
-                <a:latin typeface="Aptos Display" pitchFamily="34" charset="0"/>
-                <a:ea typeface="Aptos Display" pitchFamily="34" charset="-122"/>
-                <a:cs typeface="Aptos Display" pitchFamily="34" charset="-120"/>
-              </a:rPr>
-              <a:t>LNG terminal</a:t>
+                <a:latin typeface="Malgun Gothic" pitchFamily="34" charset="0"/>
+                <a:ea typeface="Malgun Gothic" pitchFamily="34" charset="-122"/>
+                <a:cs typeface="Malgun Gothic" pitchFamily="34" charset="-120"/>
+              </a:rPr>
+              <a:t>LNG 기지</a:t>
             </a:r>
             <a:endParaRPr lang="en-US" sz="1150" dirty="0"/>
           </a:p>
@@ -3328,11 +3328,11 @@
                 <a:solidFill>
                   <a:srgbClr val="5A6675"/>
                 </a:solidFill>
-                <a:latin typeface="Aptos" pitchFamily="34" charset="0"/>
-                <a:ea typeface="Aptos" pitchFamily="34" charset="-122"/>
-                <a:cs typeface="Aptos" pitchFamily="34" charset="-120"/>
-              </a:rPr>
-              <a:t>112 K methane stream</a:t>
+                <a:latin typeface="Malgun Gothic" pitchFamily="34" charset="0"/>
+                <a:ea typeface="Malgun Gothic" pitchFamily="34" charset="-122"/>
+                <a:cs typeface="Malgun Gothic" pitchFamily="34" charset="-120"/>
+              </a:rPr>
+              <a:t>112 K 메탄 유입</a:t>
             </a:r>
             <a:endParaRPr lang="en-US" sz="820" dirty="0"/>
           </a:p>
@@ -3367,9 +3367,9 @@
                 <a:solidFill>
                   <a:srgbClr val="1C6E73"/>
                 </a:solidFill>
-                <a:latin typeface="Aptos Display" pitchFamily="34" charset="0"/>
-                <a:ea typeface="Aptos Display" pitchFamily="34" charset="-122"/>
-                <a:cs typeface="Aptos Display" pitchFamily="34" charset="-120"/>
+                <a:latin typeface="Malgun Gothic" pitchFamily="34" charset="0"/>
+                <a:ea typeface="Malgun Gothic" pitchFamily="34" charset="-122"/>
+                <a:cs typeface="Malgun Gothic" pitchFamily="34" charset="-120"/>
               </a:rPr>
               <a:t>→</a:t>
             </a:r>
@@ -3431,11 +3431,11 @@
                 <a:solidFill>
                   <a:srgbClr val="10243D"/>
                 </a:solidFill>
-                <a:latin typeface="Aptos Display" pitchFamily="34" charset="0"/>
-                <a:ea typeface="Aptos Display" pitchFamily="34" charset="-122"/>
-                <a:cs typeface="Aptos Display" pitchFamily="34" charset="-120"/>
-              </a:rPr>
-              <a:t>Vaporizer</a:t>
+                <a:latin typeface="Malgun Gothic" pitchFamily="34" charset="0"/>
+                <a:ea typeface="Malgun Gothic" pitchFamily="34" charset="-122"/>
+                <a:cs typeface="Malgun Gothic" pitchFamily="34" charset="-120"/>
+              </a:rPr>
+              <a:t>기화기</a:t>
             </a:r>
             <a:endParaRPr lang="en-US" sz="1150" dirty="0"/>
           </a:p>
@@ -3470,11 +3470,11 @@
                 <a:solidFill>
                   <a:srgbClr val="5A6675"/>
                 </a:solidFill>
-                <a:latin typeface="Aptos" pitchFamily="34" charset="0"/>
-                <a:ea typeface="Aptos" pitchFamily="34" charset="-122"/>
-                <a:cs typeface="Aptos" pitchFamily="34" charset="-120"/>
-              </a:rPr>
-              <a:t>Shell-and-tube exchanger</a:t>
+                <a:latin typeface="Malgun Gothic" pitchFamily="34" charset="0"/>
+                <a:ea typeface="Malgun Gothic" pitchFamily="34" charset="-122"/>
+                <a:cs typeface="Malgun Gothic" pitchFamily="34" charset="-120"/>
+              </a:rPr>
+              <a:t>쉘-튜브 열교환기</a:t>
             </a:r>
             <a:endParaRPr lang="en-US" sz="820" dirty="0"/>
           </a:p>
@@ -3509,9 +3509,9 @@
                 <a:solidFill>
                   <a:srgbClr val="1C6E73"/>
                 </a:solidFill>
-                <a:latin typeface="Aptos Display" pitchFamily="34" charset="0"/>
-                <a:ea typeface="Aptos Display" pitchFamily="34" charset="-122"/>
-                <a:cs typeface="Aptos Display" pitchFamily="34" charset="-120"/>
+                <a:latin typeface="Malgun Gothic" pitchFamily="34" charset="0"/>
+                <a:ea typeface="Malgun Gothic" pitchFamily="34" charset="-122"/>
+                <a:cs typeface="Malgun Gothic" pitchFamily="34" charset="-120"/>
               </a:rPr>
               <a:t>→</a:t>
             </a:r>
@@ -3573,11 +3573,11 @@
                 <a:solidFill>
                   <a:srgbClr val="10243D"/>
                 </a:solidFill>
-                <a:latin typeface="Aptos Display" pitchFamily="34" charset="0"/>
-                <a:ea typeface="Aptos Display" pitchFamily="34" charset="-122"/>
-                <a:cs typeface="Aptos Display" pitchFamily="34" charset="-120"/>
-              </a:rPr>
-              <a:t>Secondary loop</a:t>
+                <a:latin typeface="Malgun Gothic" pitchFamily="34" charset="0"/>
+                <a:ea typeface="Malgun Gothic" pitchFamily="34" charset="-122"/>
+                <a:cs typeface="Malgun Gothic" pitchFamily="34" charset="-120"/>
+              </a:rPr>
+              <a:t>2차 루프</a:t>
             </a:r>
             <a:endParaRPr lang="en-US" sz="1150" dirty="0"/>
           </a:p>
@@ -3612,11 +3612,11 @@
                 <a:solidFill>
                   <a:srgbClr val="5A6675"/>
                 </a:solidFill>
-                <a:latin typeface="Aptos" pitchFamily="34" charset="0"/>
-                <a:ea typeface="Aptos" pitchFamily="34" charset="-122"/>
-                <a:cs typeface="Aptos" pitchFamily="34" charset="-120"/>
-              </a:rPr>
-              <a:t>Coolant transport</a:t>
+                <a:latin typeface="Malgun Gothic" pitchFamily="34" charset="0"/>
+                <a:ea typeface="Malgun Gothic" pitchFamily="34" charset="-122"/>
+                <a:cs typeface="Malgun Gothic" pitchFamily="34" charset="-120"/>
+              </a:rPr>
+              <a:t>냉열 이송</a:t>
             </a:r>
             <a:endParaRPr lang="en-US" sz="820" dirty="0"/>
           </a:p>
@@ -3651,9 +3651,9 @@
                 <a:solidFill>
                   <a:srgbClr val="1C6E73"/>
                 </a:solidFill>
-                <a:latin typeface="Aptos Display" pitchFamily="34" charset="0"/>
-                <a:ea typeface="Aptos Display" pitchFamily="34" charset="-122"/>
-                <a:cs typeface="Aptos Display" pitchFamily="34" charset="-120"/>
+                <a:latin typeface="Malgun Gothic" pitchFamily="34" charset="0"/>
+                <a:ea typeface="Malgun Gothic" pitchFamily="34" charset="-122"/>
+                <a:cs typeface="Malgun Gothic" pitchFamily="34" charset="-120"/>
               </a:rPr>
               <a:t>→</a:t>
             </a:r>
@@ -3715,9 +3715,9 @@
                 <a:solidFill>
                   <a:srgbClr val="10243D"/>
                 </a:solidFill>
-                <a:latin typeface="Aptos Display" pitchFamily="34" charset="0"/>
-                <a:ea typeface="Aptos Display" pitchFamily="34" charset="-122"/>
-                <a:cs typeface="Aptos Display" pitchFamily="34" charset="-120"/>
+                <a:latin typeface="Malgun Gothic" pitchFamily="34" charset="0"/>
+                <a:ea typeface="Malgun Gothic" pitchFamily="34" charset="-122"/>
+                <a:cs typeface="Malgun Gothic" pitchFamily="34" charset="-120"/>
               </a:rPr>
               <a:t>IDC</a:t>
             </a:r>
@@ -3754,11 +3754,11 @@
                 <a:solidFill>
                   <a:srgbClr val="5A6675"/>
                 </a:solidFill>
-                <a:latin typeface="Aptos" pitchFamily="34" charset="0"/>
-                <a:ea typeface="Aptos" pitchFamily="34" charset="-122"/>
-                <a:cs typeface="Aptos" pitchFamily="34" charset="-120"/>
-              </a:rPr>
-              <a:t>11-floor cooling load</a:t>
+                <a:latin typeface="Malgun Gothic" pitchFamily="34" charset="0"/>
+                <a:ea typeface="Malgun Gothic" pitchFamily="34" charset="-122"/>
+                <a:cs typeface="Malgun Gothic" pitchFamily="34" charset="-120"/>
+              </a:rPr>
+              <a:t>11층 냉방부하</a:t>
             </a:r>
             <a:endParaRPr lang="en-US" sz="820" dirty="0"/>
           </a:p>
@@ -3793,11 +3793,11 @@
                 <a:solidFill>
                   <a:srgbClr val="5A6675"/>
                 </a:solidFill>
-                <a:latin typeface="Aptos" pitchFamily="34" charset="0"/>
-                <a:ea typeface="Aptos" pitchFamily="34" charset="-122"/>
-                <a:cs typeface="Aptos" pitchFamily="34" charset="-120"/>
-              </a:rPr>
-              <a:t>Sources: SRC-001, SRC-009, ASM-001 to ASM-011</a:t>
+                <a:latin typeface="Malgun Gothic" pitchFamily="34" charset="0"/>
+                <a:ea typeface="Malgun Gothic" pitchFamily="34" charset="-122"/>
+                <a:cs typeface="Malgun Gothic" pitchFamily="34" charset="-120"/>
+              </a:rPr>
+              <a:t>출처: SRC-001, SRC-009, ASM-001 to ASM-011</a:t>
             </a:r>
             <a:endParaRPr lang="en-US" sz="800" dirty="0"/>
           </a:p>
@@ -3864,11 +3864,11 @@
                 <a:solidFill>
                   <a:srgbClr val="5AA7A4"/>
                 </a:solidFill>
-                <a:latin typeface="Aptos" pitchFamily="34" charset="0"/>
-                <a:ea typeface="Aptos" pitchFamily="34" charset="-122"/>
-                <a:cs typeface="Aptos" pitchFamily="34" charset="-120"/>
-              </a:rPr>
-              <a:t>SYSTEM CONCEPT</a:t>
+                <a:latin typeface="Malgun Gothic" pitchFamily="34" charset="0"/>
+                <a:ea typeface="Malgun Gothic" pitchFamily="34" charset="-122"/>
+                <a:cs typeface="Malgun Gothic" pitchFamily="34" charset="-120"/>
+              </a:rPr>
+              <a:t>시스템 개념</a:t>
             </a:r>
             <a:endParaRPr lang="en-US" sz="1000" dirty="0"/>
           </a:p>
@@ -3899,17 +3899,17 @@
               <a:buNone/>
             </a:pPr>
             <a:r>
-              <a:rPr lang="en-US" sz="2400" b="1" dirty="0">
+              <a:rPr lang="en-US" sz="2200" b="1" dirty="0">
                 <a:solidFill>
                   <a:srgbClr val="F6F2E8"/>
                 </a:solidFill>
-                <a:latin typeface="Aptos Display" pitchFamily="34" charset="0"/>
-                <a:ea typeface="Aptos Display" pitchFamily="34" charset="-122"/>
-                <a:cs typeface="Aptos Display" pitchFamily="34" charset="-120"/>
-              </a:rPr>
-              <a:t>How the LNG Cooling Concept Works</a:t>
-            </a:r>
-            <a:endParaRPr lang="en-US" sz="2400" dirty="0"/>
+                <a:latin typeface="Malgun Gothic" pitchFamily="34" charset="0"/>
+                <a:ea typeface="Malgun Gothic" pitchFamily="34" charset="-122"/>
+                <a:cs typeface="Malgun Gothic" pitchFamily="34" charset="-120"/>
+              </a:rPr>
+              <a:t>LNG 냉각 개념과 해석 구조</a:t>
+            </a:r>
+            <a:endParaRPr lang="en-US" sz="2200" dirty="0"/>
           </a:p>
         </p:txBody>
       </p:sp>
@@ -3993,11 +3993,11 @@
                 <a:solidFill>
                   <a:srgbClr val="5A6675"/>
                 </a:solidFill>
-                <a:latin typeface="Aptos" pitchFamily="34" charset="0"/>
-                <a:ea typeface="Aptos" pitchFamily="34" charset="-122"/>
-                <a:cs typeface="Aptos" pitchFamily="34" charset="-120"/>
-              </a:rPr>
-              <a:t>Segmented LNG vaporizer temperature profile</a:t>
+                <a:latin typeface="Malgun Gothic" pitchFamily="34" charset="0"/>
+                <a:ea typeface="Malgun Gothic" pitchFamily="34" charset="-122"/>
+                <a:cs typeface="Malgun Gothic" pitchFamily="34" charset="-120"/>
+              </a:rPr>
+              <a:t>구간 분할 LNG 기화기 온도 프로파일</a:t>
             </a:r>
             <a:endParaRPr lang="en-US" sz="850" dirty="0"/>
           </a:p>
@@ -4059,11 +4059,11 @@
                 <a:solidFill>
                   <a:srgbClr val="10243D"/>
                 </a:solidFill>
-                <a:latin typeface="Aptos Display" pitchFamily="34" charset="0"/>
-                <a:ea typeface="Aptos Display" pitchFamily="34" charset="-122"/>
-                <a:cs typeface="Aptos Display" pitchFamily="34" charset="-120"/>
-              </a:rPr>
-              <a:t>Design choices that matter</a:t>
+                <a:latin typeface="Malgun Gothic" pitchFamily="34" charset="0"/>
+                <a:ea typeface="Malgun Gothic" pitchFamily="34" charset="-122"/>
+                <a:cs typeface="Malgun Gothic" pitchFamily="34" charset="-120"/>
+              </a:rPr>
+              <a:t>설계를 좌우한 선택</a:t>
             </a:r>
             <a:endParaRPr lang="en-US" sz="1500" dirty="0"/>
           </a:p>
@@ -4099,11 +4099,11 @@
                 <a:solidFill>
                   <a:srgbClr val="28323F"/>
                 </a:solidFill>
-                <a:latin typeface="Aptos" pitchFamily="34" charset="0"/>
-                <a:ea typeface="Aptos" pitchFamily="34" charset="-122"/>
-                <a:cs typeface="Aptos" pitchFamily="34" charset="-120"/>
-              </a:rPr>
-              <a:t>Segmented enthalpy model replaces a single constant-cp approximation.</a:t>
+                <a:latin typeface="Malgun Gothic" pitchFamily="34" charset="0"/>
+                <a:ea typeface="Malgun Gothic" pitchFamily="34" charset="-122"/>
+                <a:cs typeface="Malgun Gothic" pitchFamily="34" charset="-120"/>
+              </a:rPr>
+              <a:t>단일 등비열 가정 대신 구간 분할 엔탈피 모델을 사용했다.</a:t>
             </a:r>
             <a:endParaRPr lang="en-US" sz="1250" dirty="0"/>
           </a:p>
@@ -4117,11 +4117,11 @@
                 <a:solidFill>
                   <a:srgbClr val="28323F"/>
                 </a:solidFill>
-                <a:latin typeface="Aptos" pitchFamily="34" charset="0"/>
-                <a:ea typeface="Aptos" pitchFamily="34" charset="-122"/>
-                <a:cs typeface="Aptos" pitchFamily="34" charset="-120"/>
-              </a:rPr>
-              <a:t>Base-case secondary-loop fluid is ammonia at 220 K supply level.</a:t>
+                <a:latin typeface="Malgun Gothic" pitchFamily="34" charset="0"/>
+                <a:ea typeface="Malgun Gothic" pitchFamily="34" charset="-122"/>
+                <a:cs typeface="Malgun Gothic" pitchFamily="34" charset="-120"/>
+              </a:rPr>
+              <a:t>기본 2차 루프 유체는 220 K 공급 조건의 암모니아다.</a:t>
             </a:r>
             <a:endParaRPr lang="en-US" sz="1250" dirty="0"/>
           </a:p>
@@ -4135,11 +4135,11 @@
                 <a:solidFill>
                   <a:srgbClr val="28323F"/>
                 </a:solidFill>
-                <a:latin typeface="Aptos" pitchFamily="34" charset="0"/>
-                <a:ea typeface="Aptos" pitchFamily="34" charset="-122"/>
-                <a:cs typeface="Aptos" pitchFamily="34" charset="-120"/>
-              </a:rPr>
-              <a:t>The selected vaporizer geometry is 500 tubes x 14 m with a 10 K minimum pinch.</a:t>
+                <a:latin typeface="Malgun Gothic" pitchFamily="34" charset="0"/>
+                <a:ea typeface="Malgun Gothic" pitchFamily="34" charset="-122"/>
+                <a:cs typeface="Malgun Gothic" pitchFamily="34" charset="-120"/>
+              </a:rPr>
+              <a:t>선정 기화기 형상은 500본 x 14 m이며 최소 핀치는 10 K다.</a:t>
             </a:r>
             <a:endParaRPr lang="en-US" sz="1250" dirty="0"/>
           </a:p>
@@ -4235,11 +4235,11 @@
                 <a:solidFill>
                   <a:srgbClr val="5A6675"/>
                 </a:solidFill>
-                <a:latin typeface="Aptos" pitchFamily="34" charset="0"/>
-                <a:ea typeface="Aptos" pitchFamily="34" charset="-122"/>
-                <a:cs typeface="Aptos" pitchFamily="34" charset="-120"/>
-              </a:rPr>
-              <a:t>Fluid</a:t>
+                <a:latin typeface="Malgun Gothic" pitchFamily="34" charset="0"/>
+                <a:ea typeface="Malgun Gothic" pitchFamily="34" charset="-122"/>
+                <a:cs typeface="Malgun Gothic" pitchFamily="34" charset="-120"/>
+              </a:rPr>
+              <a:t>유체</a:t>
             </a:r>
             <a:endParaRPr lang="en-US" sz="1000" dirty="0"/>
           </a:p>
@@ -4274,9 +4274,9 @@
                 <a:solidFill>
                   <a:srgbClr val="10243D"/>
                 </a:solidFill>
-                <a:latin typeface="Aptos Display" pitchFamily="34" charset="0"/>
-                <a:ea typeface="Aptos Display" pitchFamily="34" charset="-122"/>
-                <a:cs typeface="Aptos Display" pitchFamily="34" charset="-120"/>
+                <a:latin typeface="Malgun Gothic" pitchFamily="34" charset="0"/>
+                <a:ea typeface="Malgun Gothic" pitchFamily="34" charset="-122"/>
+                <a:cs typeface="Malgun Gothic" pitchFamily="34" charset="-120"/>
               </a:rPr>
               <a:t>R-717</a:t>
             </a:r>
@@ -4313,11 +4313,11 @@
                 <a:solidFill>
                   <a:srgbClr val="5A6675"/>
                 </a:solidFill>
-                <a:latin typeface="Aptos" pitchFamily="34" charset="0"/>
-                <a:ea typeface="Aptos" pitchFamily="34" charset="-122"/>
-                <a:cs typeface="Aptos" pitchFamily="34" charset="-120"/>
-              </a:rPr>
-              <a:t>Ammonia</a:t>
+                <a:latin typeface="Malgun Gothic" pitchFamily="34" charset="0"/>
+                <a:ea typeface="Malgun Gothic" pitchFamily="34" charset="-122"/>
+                <a:cs typeface="Malgun Gothic" pitchFamily="34" charset="-120"/>
+              </a:rPr>
+              <a:t>암모니아</a:t>
             </a:r>
             <a:endParaRPr lang="en-US" sz="850" dirty="0"/>
           </a:p>
@@ -4413,11 +4413,11 @@
                 <a:solidFill>
                   <a:srgbClr val="5A6675"/>
                 </a:solidFill>
-                <a:latin typeface="Aptos" pitchFamily="34" charset="0"/>
-                <a:ea typeface="Aptos" pitchFamily="34" charset="-122"/>
-                <a:cs typeface="Aptos" pitchFamily="34" charset="-120"/>
-              </a:rPr>
-              <a:t>Pinch</a:t>
+                <a:latin typeface="Malgun Gothic" pitchFamily="34" charset="0"/>
+                <a:ea typeface="Malgun Gothic" pitchFamily="34" charset="-122"/>
+                <a:cs typeface="Malgun Gothic" pitchFamily="34" charset="-120"/>
+              </a:rPr>
+              <a:t>핀치</a:t>
             </a:r>
             <a:endParaRPr lang="en-US" sz="1000" dirty="0"/>
           </a:p>
@@ -4452,9 +4452,9 @@
                 <a:solidFill>
                   <a:srgbClr val="10243D"/>
                 </a:solidFill>
-                <a:latin typeface="Aptos Display" pitchFamily="34" charset="0"/>
-                <a:ea typeface="Aptos Display" pitchFamily="34" charset="-122"/>
-                <a:cs typeface="Aptos Display" pitchFamily="34" charset="-120"/>
+                <a:latin typeface="Malgun Gothic" pitchFamily="34" charset="0"/>
+                <a:ea typeface="Malgun Gothic" pitchFamily="34" charset="-122"/>
+                <a:cs typeface="Malgun Gothic" pitchFamily="34" charset="-120"/>
               </a:rPr>
               <a:t>10 K</a:t>
             </a:r>
@@ -4491,11 +4491,11 @@
                 <a:solidFill>
                   <a:srgbClr val="5A6675"/>
                 </a:solidFill>
-                <a:latin typeface="Aptos" pitchFamily="34" charset="0"/>
-                <a:ea typeface="Aptos" pitchFamily="34" charset="-122"/>
-                <a:cs typeface="Aptos" pitchFamily="34" charset="-120"/>
-              </a:rPr>
-              <a:t>Constraint</a:t>
+                <a:latin typeface="Malgun Gothic" pitchFamily="34" charset="0"/>
+                <a:ea typeface="Malgun Gothic" pitchFamily="34" charset="-122"/>
+                <a:cs typeface="Malgun Gothic" pitchFamily="34" charset="-120"/>
+              </a:rPr>
+              <a:t>설계 제약</a:t>
             </a:r>
             <a:endParaRPr lang="en-US" sz="850" dirty="0"/>
           </a:p>
@@ -4591,11 +4591,11 @@
                 <a:solidFill>
                   <a:srgbClr val="5A6675"/>
                 </a:solidFill>
-                <a:latin typeface="Aptos" pitchFamily="34" charset="0"/>
-                <a:ea typeface="Aptos" pitchFamily="34" charset="-122"/>
-                <a:cs typeface="Aptos" pitchFamily="34" charset="-120"/>
-              </a:rPr>
-              <a:t>Shell OD</a:t>
+                <a:latin typeface="Malgun Gothic" pitchFamily="34" charset="0"/>
+                <a:ea typeface="Malgun Gothic" pitchFamily="34" charset="-122"/>
+                <a:cs typeface="Malgun Gothic" pitchFamily="34" charset="-120"/>
+              </a:rPr>
+              <a:t>쉘 직경</a:t>
             </a:r>
             <a:endParaRPr lang="en-US" sz="1000" dirty="0"/>
           </a:p>
@@ -4630,9 +4630,9 @@
                 <a:solidFill>
                   <a:srgbClr val="10243D"/>
                 </a:solidFill>
-                <a:latin typeface="Aptos Display" pitchFamily="34" charset="0"/>
-                <a:ea typeface="Aptos Display" pitchFamily="34" charset="-122"/>
-                <a:cs typeface="Aptos Display" pitchFamily="34" charset="-120"/>
+                <a:latin typeface="Malgun Gothic" pitchFamily="34" charset="0"/>
+                <a:ea typeface="Malgun Gothic" pitchFamily="34" charset="-122"/>
+                <a:cs typeface="Malgun Gothic" pitchFamily="34" charset="-120"/>
               </a:rPr>
               <a:t>0.723 m</a:t>
             </a:r>
@@ -4669,11 +4669,11 @@
                 <a:solidFill>
                   <a:srgbClr val="5A6675"/>
                 </a:solidFill>
-                <a:latin typeface="Aptos" pitchFamily="34" charset="0"/>
-                <a:ea typeface="Aptos" pitchFamily="34" charset="-122"/>
-                <a:cs typeface="Aptos" pitchFamily="34" charset="-120"/>
-              </a:rPr>
-              <a:t>Selected size</a:t>
+                <a:latin typeface="Malgun Gothic" pitchFamily="34" charset="0"/>
+                <a:ea typeface="Malgun Gothic" pitchFamily="34" charset="-122"/>
+                <a:cs typeface="Malgun Gothic" pitchFamily="34" charset="-120"/>
+              </a:rPr>
+              <a:t>선정 크기</a:t>
             </a:r>
             <a:endParaRPr lang="en-US" sz="850" dirty="0"/>
           </a:p>
@@ -4708,11 +4708,11 @@
                 <a:solidFill>
                   <a:srgbClr val="5A6675"/>
                 </a:solidFill>
-                <a:latin typeface="Aptos" pitchFamily="34" charset="0"/>
-                <a:ea typeface="Aptos" pitchFamily="34" charset="-122"/>
-                <a:cs typeface="Aptos" pitchFamily="34" charset="-120"/>
-              </a:rPr>
-              <a:t>Sources: SRC-001, SRC-006, SRC-007</a:t>
+                <a:latin typeface="Malgun Gothic" pitchFamily="34" charset="0"/>
+                <a:ea typeface="Malgun Gothic" pitchFamily="34" charset="-122"/>
+                <a:cs typeface="Malgun Gothic" pitchFamily="34" charset="-120"/>
+              </a:rPr>
+              <a:t>출처: SRC-001, SRC-006, SRC-007</a:t>
             </a:r>
             <a:endParaRPr lang="en-US" sz="800" dirty="0"/>
           </a:p>
@@ -4779,11 +4779,11 @@
                 <a:solidFill>
                   <a:srgbClr val="5AA7A4"/>
                 </a:solidFill>
-                <a:latin typeface="Aptos" pitchFamily="34" charset="0"/>
-                <a:ea typeface="Aptos" pitchFamily="34" charset="-122"/>
-                <a:cs typeface="Aptos" pitchFamily="34" charset="-120"/>
-              </a:rPr>
-              <a:t>PERFORMANCE</a:t>
+                <a:latin typeface="Malgun Gothic" pitchFamily="34" charset="0"/>
+                <a:ea typeface="Malgun Gothic" pitchFamily="34" charset="-122"/>
+                <a:cs typeface="Malgun Gothic" pitchFamily="34" charset="-120"/>
+              </a:rPr>
+              <a:t>성능 비교</a:t>
             </a:r>
             <a:endParaRPr lang="en-US" sz="1000" dirty="0"/>
           </a:p>
@@ -4814,17 +4814,17 @@
               <a:buNone/>
             </a:pPr>
             <a:r>
-              <a:rPr lang="en-US" sz="2400" b="1" dirty="0">
+              <a:rPr lang="en-US" sz="2200" b="1" dirty="0">
                 <a:solidFill>
                   <a:srgbClr val="F6F2E8"/>
                 </a:solidFill>
-                <a:latin typeface="Aptos Display" pitchFamily="34" charset="0"/>
-                <a:ea typeface="Aptos Display" pitchFamily="34" charset="-122"/>
-                <a:cs typeface="Aptos Display" pitchFamily="34" charset="-120"/>
-              </a:rPr>
-              <a:t>Benchmark Against the Reference Cycle</a:t>
-            </a:r>
-            <a:endParaRPr lang="en-US" sz="2400" dirty="0"/>
+                <a:latin typeface="Malgun Gothic" pitchFamily="34" charset="0"/>
+                <a:ea typeface="Malgun Gothic" pitchFamily="34" charset="-122"/>
+                <a:cs typeface="Malgun Gothic" pitchFamily="34" charset="-120"/>
+              </a:rPr>
+              <a:t>기준 사이클 대비 성능</a:t>
+            </a:r>
+            <a:endParaRPr lang="en-US" sz="2200" dirty="0"/>
           </a:p>
         </p:txBody>
       </p:sp>
@@ -4918,11 +4918,11 @@
                 <a:solidFill>
                   <a:srgbClr val="5A6675"/>
                 </a:solidFill>
-                <a:latin typeface="Aptos" pitchFamily="34" charset="0"/>
-                <a:ea typeface="Aptos" pitchFamily="34" charset="-122"/>
-                <a:cs typeface="Aptos" pitchFamily="34" charset="-120"/>
-              </a:rPr>
-              <a:t>Theoretical minimum</a:t>
+                <a:latin typeface="Malgun Gothic" pitchFamily="34" charset="0"/>
+                <a:ea typeface="Malgun Gothic" pitchFamily="34" charset="-122"/>
+                <a:cs typeface="Malgun Gothic" pitchFamily="34" charset="-120"/>
+              </a:rPr>
+              <a:t>이론 최소</a:t>
             </a:r>
             <a:endParaRPr lang="en-US" sz="1000" dirty="0"/>
           </a:p>
@@ -4957,9 +4957,9 @@
                 <a:solidFill>
                   <a:srgbClr val="10243D"/>
                 </a:solidFill>
-                <a:latin typeface="Aptos Display" pitchFamily="34" charset="0"/>
-                <a:ea typeface="Aptos Display" pitchFamily="34" charset="-122"/>
-                <a:cs typeface="Aptos Display" pitchFamily="34" charset="-120"/>
+                <a:latin typeface="Malgun Gothic" pitchFamily="34" charset="0"/>
+                <a:ea typeface="Malgun Gothic" pitchFamily="34" charset="-122"/>
+                <a:cs typeface="Malgun Gothic" pitchFamily="34" charset="-120"/>
               </a:rPr>
               <a:t>1.22 MW</a:t>
             </a:r>
@@ -4996,11 +4996,11 @@
                 <a:solidFill>
                   <a:srgbClr val="5A6675"/>
                 </a:solidFill>
-                <a:latin typeface="Aptos" pitchFamily="34" charset="0"/>
-                <a:ea typeface="Aptos" pitchFamily="34" charset="-122"/>
-                <a:cs typeface="Aptos" pitchFamily="34" charset="-120"/>
-              </a:rPr>
-              <a:t>Carnot lower bound</a:t>
+                <a:latin typeface="Malgun Gothic" pitchFamily="34" charset="0"/>
+                <a:ea typeface="Malgun Gothic" pitchFamily="34" charset="-122"/>
+                <a:cs typeface="Malgun Gothic" pitchFamily="34" charset="-120"/>
+              </a:rPr>
+              <a:t>카르노 하한</a:t>
             </a:r>
             <a:endParaRPr lang="en-US" sz="850" dirty="0"/>
           </a:p>
@@ -5096,11 +5096,11 @@
                 <a:solidFill>
                   <a:srgbClr val="5A6675"/>
                 </a:solidFill>
-                <a:latin typeface="Aptos" pitchFamily="34" charset="0"/>
-                <a:ea typeface="Aptos" pitchFamily="34" charset="-122"/>
-                <a:cs typeface="Aptos" pitchFamily="34" charset="-120"/>
-              </a:rPr>
-              <a:t>Reference cycle</a:t>
+                <a:latin typeface="Malgun Gothic" pitchFamily="34" charset="0"/>
+                <a:ea typeface="Malgun Gothic" pitchFamily="34" charset="-122"/>
+                <a:cs typeface="Malgun Gothic" pitchFamily="34" charset="-120"/>
+              </a:rPr>
+              <a:t>기준 사이클</a:t>
             </a:r>
             <a:endParaRPr lang="en-US" sz="1000" dirty="0"/>
           </a:p>
@@ -5135,9 +5135,9 @@
                 <a:solidFill>
                   <a:srgbClr val="10243D"/>
                 </a:solidFill>
-                <a:latin typeface="Aptos Display" pitchFamily="34" charset="0"/>
-                <a:ea typeface="Aptos Display" pitchFamily="34" charset="-122"/>
-                <a:cs typeface="Aptos Display" pitchFamily="34" charset="-120"/>
+                <a:latin typeface="Malgun Gothic" pitchFamily="34" charset="0"/>
+                <a:ea typeface="Malgun Gothic" pitchFamily="34" charset="-122"/>
+                <a:cs typeface="Malgun Gothic" pitchFamily="34" charset="-120"/>
               </a:rPr>
               <a:t>4.19 MW</a:t>
             </a:r>
@@ -5174,11 +5174,11 @@
                 <a:solidFill>
                   <a:srgbClr val="5A6675"/>
                 </a:solidFill>
-                <a:latin typeface="Aptos" pitchFamily="34" charset="0"/>
-                <a:ea typeface="Aptos" pitchFamily="34" charset="-122"/>
-                <a:cs typeface="Aptos" pitchFamily="34" charset="-120"/>
-              </a:rPr>
-              <a:t>R-134a compressor</a:t>
+                <a:latin typeface="Malgun Gothic" pitchFamily="34" charset="0"/>
+                <a:ea typeface="Malgun Gothic" pitchFamily="34" charset="-122"/>
+                <a:cs typeface="Malgun Gothic" pitchFamily="34" charset="-120"/>
+              </a:rPr>
+              <a:t>R-134a 압축기</a:t>
             </a:r>
             <a:endParaRPr lang="en-US" sz="850" dirty="0"/>
           </a:p>
@@ -5274,11 +5274,11 @@
                 <a:solidFill>
                   <a:srgbClr val="5A6675"/>
                 </a:solidFill>
-                <a:latin typeface="Aptos" pitchFamily="34" charset="0"/>
-                <a:ea typeface="Aptos" pitchFamily="34" charset="-122"/>
-                <a:cs typeface="Aptos" pitchFamily="34" charset="-120"/>
-              </a:rPr>
-              <a:t>LNG loop</a:t>
+                <a:latin typeface="Malgun Gothic" pitchFamily="34" charset="0"/>
+                <a:ea typeface="Malgun Gothic" pitchFamily="34" charset="-122"/>
+                <a:cs typeface="Malgun Gothic" pitchFamily="34" charset="-120"/>
+              </a:rPr>
+              <a:t>LNG 루프</a:t>
             </a:r>
             <a:endParaRPr lang="en-US" sz="1000" dirty="0"/>
           </a:p>
@@ -5313,9 +5313,9 @@
                 <a:solidFill>
                   <a:srgbClr val="10243D"/>
                 </a:solidFill>
-                <a:latin typeface="Aptos Display" pitchFamily="34" charset="0"/>
-                <a:ea typeface="Aptos Display" pitchFamily="34" charset="-122"/>
-                <a:cs typeface="Aptos Display" pitchFamily="34" charset="-120"/>
+                <a:latin typeface="Malgun Gothic" pitchFamily="34" charset="0"/>
+                <a:ea typeface="Malgun Gothic" pitchFamily="34" charset="-122"/>
+                <a:cs typeface="Malgun Gothic" pitchFamily="34" charset="-120"/>
               </a:rPr>
               <a:t>13.1 kW</a:t>
             </a:r>
@@ -5352,11 +5352,11 @@
                 <a:solidFill>
                   <a:srgbClr val="5A6675"/>
                 </a:solidFill>
-                <a:latin typeface="Aptos" pitchFamily="34" charset="0"/>
-                <a:ea typeface="Aptos" pitchFamily="34" charset="-122"/>
-                <a:cs typeface="Aptos" pitchFamily="34" charset="-120"/>
-              </a:rPr>
-              <a:t>Base-case pumping demand</a:t>
+                <a:latin typeface="Malgun Gothic" pitchFamily="34" charset="0"/>
+                <a:ea typeface="Malgun Gothic" pitchFamily="34" charset="-122"/>
+                <a:cs typeface="Malgun Gothic" pitchFamily="34" charset="-120"/>
+              </a:rPr>
+              <a:t>기본안 펌프동력</a:t>
             </a:r>
             <a:endParaRPr lang="en-US" sz="850" dirty="0"/>
           </a:p>
@@ -5442,11 +5442,11 @@
                 <a:solidFill>
                   <a:srgbClr val="5A6675"/>
                 </a:solidFill>
-                <a:latin typeface="Aptos" pitchFamily="34" charset="0"/>
-                <a:ea typeface="Aptos" pitchFamily="34" charset="-122"/>
-                <a:cs typeface="Aptos" pitchFamily="34" charset="-120"/>
-              </a:rPr>
-              <a:t>Modeled electric-power comparison</a:t>
+                <a:latin typeface="Malgun Gothic" pitchFamily="34" charset="0"/>
+                <a:ea typeface="Malgun Gothic" pitchFamily="34" charset="-122"/>
+                <a:cs typeface="Malgun Gothic" pitchFamily="34" charset="-120"/>
+              </a:rPr>
+              <a:t>모델링된 전력 요구 비교</a:t>
             </a:r>
             <a:endParaRPr lang="en-US" sz="850" dirty="0"/>
           </a:p>
@@ -5508,11 +5508,11 @@
                 <a:solidFill>
                   <a:srgbClr val="10243D"/>
                 </a:solidFill>
-                <a:latin typeface="Aptos Display" pitchFamily="34" charset="0"/>
-                <a:ea typeface="Aptos Display" pitchFamily="34" charset="-122"/>
-                <a:cs typeface="Aptos Display" pitchFamily="34" charset="-120"/>
-              </a:rPr>
-              <a:t>Interpretation</a:t>
+                <a:latin typeface="Malgun Gothic" pitchFamily="34" charset="0"/>
+                <a:ea typeface="Malgun Gothic" pitchFamily="34" charset="-122"/>
+                <a:cs typeface="Malgun Gothic" pitchFamily="34" charset="-120"/>
+              </a:rPr>
+              <a:t>해석 포인트</a:t>
             </a:r>
             <a:endParaRPr lang="en-US" sz="1500" dirty="0"/>
           </a:p>
@@ -5548,11 +5548,11 @@
                 <a:solidFill>
                   <a:srgbClr val="28323F"/>
                 </a:solidFill>
-                <a:latin typeface="Aptos" pitchFamily="34" charset="0"/>
-                <a:ea typeface="Aptos" pitchFamily="34" charset="-122"/>
-                <a:cs typeface="Aptos" pitchFamily="34" charset="-120"/>
-              </a:rPr>
-              <a:t>The base concept dramatically reduces modeled cooling-system power draw.</a:t>
+                <a:latin typeface="Malgun Gothic" pitchFamily="34" charset="0"/>
+                <a:ea typeface="Malgun Gothic" pitchFamily="34" charset="-122"/>
+                <a:cs typeface="Malgun Gothic" pitchFamily="34" charset="-120"/>
+              </a:rPr>
+              <a:t>기본 개념은 냉방 시스템의 전력 요구를 크게 낮춘다.</a:t>
             </a:r>
             <a:endParaRPr lang="en-US" sz="1250" dirty="0"/>
           </a:p>
@@ -5566,11 +5566,11 @@
                 <a:solidFill>
                   <a:srgbClr val="28323F"/>
                 </a:solidFill>
-                <a:latin typeface="Aptos" pitchFamily="34" charset="0"/>
-                <a:ea typeface="Aptos" pitchFamily="34" charset="-122"/>
-                <a:cs typeface="Aptos" pitchFamily="34" charset="-120"/>
-              </a:rPr>
-              <a:t>This result is strong because the benchmark already respects the theoretical lower bound ordering.</a:t>
+                <a:latin typeface="Malgun Gothic" pitchFamily="34" charset="0"/>
+                <a:ea typeface="Malgun Gothic" pitchFamily="34" charset="-122"/>
+                <a:cs typeface="Malgun Gothic" pitchFamily="34" charset="-120"/>
+              </a:rPr>
+              <a:t>이 결과는 기준 사이클이 이미 이론 최소동력보다 높은 정상적인 수준이라는 점에서 의미가 있다.</a:t>
             </a:r>
             <a:endParaRPr lang="en-US" sz="1250" dirty="0"/>
           </a:p>
@@ -5584,11 +5584,11 @@
                 <a:solidFill>
                   <a:srgbClr val="28323F"/>
                 </a:solidFill>
-                <a:latin typeface="Aptos" pitchFamily="34" charset="0"/>
-                <a:ea typeface="Aptos" pitchFamily="34" charset="-122"/>
-                <a:cs typeface="Aptos" pitchFamily="34" charset="-120"/>
-              </a:rPr>
-              <a:t>The key question shifts from raw efficiency to transport feasibility and implementation trade-offs.</a:t>
+                <a:latin typeface="Malgun Gothic" pitchFamily="34" charset="0"/>
+                <a:ea typeface="Malgun Gothic" pitchFamily="34" charset="-122"/>
+                <a:cs typeface="Malgun Gothic" pitchFamily="34" charset="-120"/>
+              </a:rPr>
+              <a:t>이후의 핵심 질문은 순수 효율보다 이송 가능 거리와 구현 상충관계로 이동한다.</a:t>
             </a:r>
             <a:endParaRPr lang="en-US" sz="1250" dirty="0"/>
           </a:p>
@@ -5623,11 +5623,11 @@
                 <a:solidFill>
                   <a:srgbClr val="5A6675"/>
                 </a:solidFill>
-                <a:latin typeface="Aptos" pitchFamily="34" charset="0"/>
-                <a:ea typeface="Aptos" pitchFamily="34" charset="-122"/>
-                <a:cs typeface="Aptos" pitchFamily="34" charset="-120"/>
-              </a:rPr>
-              <a:t>Sources: SRC-001, SRC-004, SRC-005</a:t>
+                <a:latin typeface="Malgun Gothic" pitchFamily="34" charset="0"/>
+                <a:ea typeface="Malgun Gothic" pitchFamily="34" charset="-122"/>
+                <a:cs typeface="Malgun Gothic" pitchFamily="34" charset="-120"/>
+              </a:rPr>
+              <a:t>출처: SRC-001, SRC-004, SRC-005</a:t>
             </a:r>
             <a:endParaRPr lang="en-US" sz="800" dirty="0"/>
           </a:p>
@@ -5694,11 +5694,11 @@
                 <a:solidFill>
                   <a:srgbClr val="5AA7A4"/>
                 </a:solidFill>
-                <a:latin typeface="Aptos" pitchFamily="34" charset="0"/>
-                <a:ea typeface="Aptos" pitchFamily="34" charset="-122"/>
-                <a:cs typeface="Aptos" pitchFamily="34" charset="-120"/>
-              </a:rPr>
-              <a:t>SCREENING</a:t>
+                <a:latin typeface="Malgun Gothic" pitchFamily="34" charset="0"/>
+                <a:ea typeface="Malgun Gothic" pitchFamily="34" charset="-122"/>
+                <a:cs typeface="Malgun Gothic" pitchFamily="34" charset="-120"/>
+              </a:rPr>
+              <a:t>유체 스크리닝</a:t>
             </a:r>
             <a:endParaRPr lang="en-US" sz="1000" dirty="0"/>
           </a:p>
@@ -5729,17 +5729,17 @@
               <a:buNone/>
             </a:pPr>
             <a:r>
-              <a:rPr lang="en-US" sz="2400" b="1" dirty="0">
+              <a:rPr lang="en-US" sz="2200" b="1" dirty="0">
                 <a:solidFill>
                   <a:srgbClr val="F6F2E8"/>
                 </a:solidFill>
-                <a:latin typeface="Aptos Display" pitchFamily="34" charset="0"/>
-                <a:ea typeface="Aptos Display" pitchFamily="34" charset="-122"/>
-                <a:cs typeface="Aptos Display" pitchFamily="34" charset="-120"/>
-              </a:rPr>
-              <a:t>Coolant Selection Is a Design Choice, Not a Guess</a:t>
-            </a:r>
-            <a:endParaRPr lang="en-US" sz="2400" dirty="0"/>
+                <a:latin typeface="Malgun Gothic" pitchFamily="34" charset="0"/>
+                <a:ea typeface="Malgun Gothic" pitchFamily="34" charset="-122"/>
+                <a:cs typeface="Malgun Gothic" pitchFamily="34" charset="-120"/>
+              </a:rPr>
+              <a:t>냉각유체 선정은 감이 아니라 설계 결과다</a:t>
+            </a:r>
+            <a:endParaRPr lang="en-US" sz="2200" dirty="0"/>
           </a:p>
         </p:txBody>
       </p:sp>
@@ -5823,11 +5823,11 @@
                 <a:solidFill>
                   <a:srgbClr val="5A6675"/>
                 </a:solidFill>
-                <a:latin typeface="Aptos" pitchFamily="34" charset="0"/>
-                <a:ea typeface="Aptos" pitchFamily="34" charset="-122"/>
-                <a:cs typeface="Aptos" pitchFamily="34" charset="-120"/>
-              </a:rPr>
-              <a:t>Screening score versus required mass flow</a:t>
+                <a:latin typeface="Malgun Gothic" pitchFamily="34" charset="0"/>
+                <a:ea typeface="Malgun Gothic" pitchFamily="34" charset="-122"/>
+                <a:cs typeface="Malgun Gothic" pitchFamily="34" charset="-120"/>
+              </a:rPr>
+              <a:t>스크리닝 점수와 요구 질량유량</a:t>
             </a:r>
             <a:endParaRPr lang="en-US" sz="850" dirty="0"/>
           </a:p>
@@ -5923,11 +5923,11 @@
                 <a:solidFill>
                   <a:srgbClr val="5A6675"/>
                 </a:solidFill>
-                <a:latin typeface="Aptos" pitchFamily="34" charset="0"/>
-                <a:ea typeface="Aptos" pitchFamily="34" charset="-122"/>
-                <a:cs typeface="Aptos" pitchFamily="34" charset="-120"/>
-              </a:rPr>
-              <a:t>1st</a:t>
+                <a:latin typeface="Malgun Gothic" pitchFamily="34" charset="0"/>
+                <a:ea typeface="Malgun Gothic" pitchFamily="34" charset="-122"/>
+                <a:cs typeface="Malgun Gothic" pitchFamily="34" charset="-120"/>
+              </a:rPr>
+              <a:t>1위</a:t>
             </a:r>
             <a:endParaRPr lang="en-US" sz="1000" dirty="0"/>
           </a:p>
@@ -5962,9 +5962,9 @@
                 <a:solidFill>
                   <a:srgbClr val="10243D"/>
                 </a:solidFill>
-                <a:latin typeface="Aptos Display" pitchFamily="34" charset="0"/>
-                <a:ea typeface="Aptos Display" pitchFamily="34" charset="-122"/>
-                <a:cs typeface="Aptos Display" pitchFamily="34" charset="-120"/>
+                <a:latin typeface="Malgun Gothic" pitchFamily="34" charset="0"/>
+                <a:ea typeface="Malgun Gothic" pitchFamily="34" charset="-122"/>
+                <a:cs typeface="Malgun Gothic" pitchFamily="34" charset="-120"/>
               </a:rPr>
               <a:t>R-717</a:t>
             </a:r>
@@ -6001,11 +6001,11 @@
                 <a:solidFill>
                   <a:srgbClr val="5A6675"/>
                 </a:solidFill>
-                <a:latin typeface="Aptos" pitchFamily="34" charset="0"/>
-                <a:ea typeface="Aptos" pitchFamily="34" charset="-122"/>
-                <a:cs typeface="Aptos" pitchFamily="34" charset="-120"/>
-              </a:rPr>
-              <a:t>13.1 kW pump</a:t>
+                <a:latin typeface="Malgun Gothic" pitchFamily="34" charset="0"/>
+                <a:ea typeface="Malgun Gothic" pitchFamily="34" charset="-122"/>
+                <a:cs typeface="Malgun Gothic" pitchFamily="34" charset="-120"/>
+              </a:rPr>
+              <a:t>13.1 kW 펌프</a:t>
             </a:r>
             <a:endParaRPr lang="en-US" sz="850" dirty="0"/>
           </a:p>
@@ -6101,11 +6101,11 @@
                 <a:solidFill>
                   <a:srgbClr val="5A6675"/>
                 </a:solidFill>
-                <a:latin typeface="Aptos" pitchFamily="34" charset="0"/>
-                <a:ea typeface="Aptos" pitchFamily="34" charset="-122"/>
-                <a:cs typeface="Aptos" pitchFamily="34" charset="-120"/>
-              </a:rPr>
-              <a:t>2nd</a:t>
+                <a:latin typeface="Malgun Gothic" pitchFamily="34" charset="0"/>
+                <a:ea typeface="Malgun Gothic" pitchFamily="34" charset="-122"/>
+                <a:cs typeface="Malgun Gothic" pitchFamily="34" charset="-120"/>
+              </a:rPr>
+              <a:t>2위</a:t>
             </a:r>
             <a:endParaRPr lang="en-US" sz="1000" dirty="0"/>
           </a:p>
@@ -6140,9 +6140,9 @@
                 <a:solidFill>
                   <a:srgbClr val="10243D"/>
                 </a:solidFill>
-                <a:latin typeface="Aptos Display" pitchFamily="34" charset="0"/>
-                <a:ea typeface="Aptos Display" pitchFamily="34" charset="-122"/>
-                <a:cs typeface="Aptos Display" pitchFamily="34" charset="-120"/>
+                <a:latin typeface="Malgun Gothic" pitchFamily="34" charset="0"/>
+                <a:ea typeface="Malgun Gothic" pitchFamily="34" charset="-122"/>
+                <a:cs typeface="Malgun Gothic" pitchFamily="34" charset="-120"/>
               </a:rPr>
               <a:t>R-290</a:t>
             </a:r>
@@ -6179,11 +6179,11 @@
                 <a:solidFill>
                   <a:srgbClr val="5A6675"/>
                 </a:solidFill>
-                <a:latin typeface="Aptos" pitchFamily="34" charset="0"/>
-                <a:ea typeface="Aptos" pitchFamily="34" charset="-122"/>
-                <a:cs typeface="Aptos" pitchFamily="34" charset="-120"/>
-              </a:rPr>
-              <a:t>124.9 kW pump</a:t>
+                <a:latin typeface="Malgun Gothic" pitchFamily="34" charset="0"/>
+                <a:ea typeface="Malgun Gothic" pitchFamily="34" charset="-122"/>
+                <a:cs typeface="Malgun Gothic" pitchFamily="34" charset="-120"/>
+              </a:rPr>
+              <a:t>124.9 kW 펌프</a:t>
             </a:r>
             <a:endParaRPr lang="en-US" sz="850" dirty="0"/>
           </a:p>
@@ -6279,11 +6279,11 @@
                 <a:solidFill>
                   <a:srgbClr val="5A6675"/>
                 </a:solidFill>
-                <a:latin typeface="Aptos" pitchFamily="34" charset="0"/>
-                <a:ea typeface="Aptos" pitchFamily="34" charset="-122"/>
-                <a:cs typeface="Aptos" pitchFamily="34" charset="-120"/>
-              </a:rPr>
-              <a:t>3rd</a:t>
+                <a:latin typeface="Malgun Gothic" pitchFamily="34" charset="0"/>
+                <a:ea typeface="Malgun Gothic" pitchFamily="34" charset="-122"/>
+                <a:cs typeface="Malgun Gothic" pitchFamily="34" charset="-120"/>
+              </a:rPr>
+              <a:t>3위</a:t>
             </a:r>
             <a:endParaRPr lang="en-US" sz="1000" dirty="0"/>
           </a:p>
@@ -6318,9 +6318,9 @@
                 <a:solidFill>
                   <a:srgbClr val="10243D"/>
                 </a:solidFill>
-                <a:latin typeface="Aptos Display" pitchFamily="34" charset="0"/>
-                <a:ea typeface="Aptos Display" pitchFamily="34" charset="-122"/>
-                <a:cs typeface="Aptos Display" pitchFamily="34" charset="-120"/>
+                <a:latin typeface="Malgun Gothic" pitchFamily="34" charset="0"/>
+                <a:ea typeface="Malgun Gothic" pitchFamily="34" charset="-122"/>
+                <a:cs typeface="Malgun Gothic" pitchFamily="34" charset="-120"/>
               </a:rPr>
               <a:t>R-600a</a:t>
             </a:r>
@@ -6357,9 +6357,9 @@
                 <a:solidFill>
                   <a:srgbClr val="5A6675"/>
                 </a:solidFill>
-                <a:latin typeface="Aptos" pitchFamily="34" charset="0"/>
-                <a:ea typeface="Aptos" pitchFamily="34" charset="-122"/>
-                <a:cs typeface="Aptos" pitchFamily="34" charset="-120"/>
+                <a:latin typeface="Malgun Gothic" pitchFamily="34" charset="0"/>
+                <a:ea typeface="Malgun Gothic" pitchFamily="34" charset="-122"/>
+                <a:cs typeface="Malgun Gothic" pitchFamily="34" charset="-120"/>
               </a:rPr>
               <a:t>134.5 kW</a:t>
             </a:r>
@@ -6423,11 +6423,11 @@
                 <a:solidFill>
                   <a:srgbClr val="10243D"/>
                 </a:solidFill>
-                <a:latin typeface="Aptos Display" pitchFamily="34" charset="0"/>
-                <a:ea typeface="Aptos Display" pitchFamily="34" charset="-122"/>
-                <a:cs typeface="Aptos Display" pitchFamily="34" charset="-120"/>
-              </a:rPr>
-              <a:t>Why ammonia wins in the base case</a:t>
+                <a:latin typeface="Malgun Gothic" pitchFamily="34" charset="0"/>
+                <a:ea typeface="Malgun Gothic" pitchFamily="34" charset="-122"/>
+                <a:cs typeface="Malgun Gothic" pitchFamily="34" charset="-120"/>
+              </a:rPr>
+              <a:t>기본안에서 암모니아가 앞선 이유</a:t>
             </a:r>
             <a:endParaRPr lang="en-US" sz="1500" dirty="0"/>
           </a:p>
@@ -6463,11 +6463,11 @@
                 <a:solidFill>
                   <a:srgbClr val="28323F"/>
                 </a:solidFill>
-                <a:latin typeface="Aptos" pitchFamily="34" charset="0"/>
-                <a:ea typeface="Aptos" pitchFamily="34" charset="-122"/>
-                <a:cs typeface="Aptos" pitchFamily="34" charset="-120"/>
-              </a:rPr>
-              <a:t>Lowest loop pumping demand among feasible options</a:t>
+                <a:latin typeface="Malgun Gothic" pitchFamily="34" charset="0"/>
+                <a:ea typeface="Malgun Gothic" pitchFamily="34" charset="-122"/>
+                <a:cs typeface="Malgun Gothic" pitchFamily="34" charset="-120"/>
+              </a:rPr>
+              <a:t>실현 가능한 후보 중 루프 펌프동력이 가장 낮다.</a:t>
             </a:r>
             <a:endParaRPr lang="en-US" sz="1250" dirty="0"/>
           </a:p>
@@ -6481,11 +6481,11 @@
                 <a:solidFill>
                   <a:srgbClr val="28323F"/>
                 </a:solidFill>
-                <a:latin typeface="Aptos" pitchFamily="34" charset="0"/>
-                <a:ea typeface="Aptos" pitchFamily="34" charset="-122"/>
-                <a:cs typeface="Aptos" pitchFamily="34" charset="-120"/>
-              </a:rPr>
-              <a:t>Compact vaporizer relative to the hydrocarbon alternatives</a:t>
+                <a:latin typeface="Malgun Gothic" pitchFamily="34" charset="0"/>
+                <a:ea typeface="Malgun Gothic" pitchFamily="34" charset="-122"/>
+                <a:cs typeface="Malgun Gothic" pitchFamily="34" charset="-120"/>
+              </a:rPr>
+              <a:t>탄화수소 대안보다 기화기 규모가 더 작다.</a:t>
             </a:r>
             <a:endParaRPr lang="en-US" sz="1250" dirty="0"/>
           </a:p>
@@ -6499,11 +6499,11 @@
                 <a:solidFill>
                   <a:srgbClr val="28323F"/>
                 </a:solidFill>
-                <a:latin typeface="Aptos" pitchFamily="34" charset="0"/>
-                <a:ea typeface="Aptos" pitchFamily="34" charset="-122"/>
-                <a:cs typeface="Aptos" pitchFamily="34" charset="-120"/>
-              </a:rPr>
-              <a:t>Transparent penalty handling for safety and compatibility trade-offs</a:t>
+                <a:latin typeface="Malgun Gothic" pitchFamily="34" charset="0"/>
+                <a:ea typeface="Malgun Gothic" pitchFamily="34" charset="-122"/>
+                <a:cs typeface="Malgun Gothic" pitchFamily="34" charset="-120"/>
+              </a:rPr>
+              <a:t>안전성과 호환성 페널티를 코드 안에서 명시적으로 반영했다.</a:t>
             </a:r>
             <a:endParaRPr lang="en-US" sz="1250" dirty="0"/>
           </a:p>
@@ -6538,11 +6538,11 @@
                 <a:solidFill>
                   <a:srgbClr val="5A6675"/>
                 </a:solidFill>
-                <a:latin typeface="Aptos" pitchFamily="34" charset="0"/>
-                <a:ea typeface="Aptos" pitchFamily="34" charset="-122"/>
-                <a:cs typeface="Aptos" pitchFamily="34" charset="-120"/>
-              </a:rPr>
-              <a:t>Sources: SRC-003, SRC-008, ASM-017 to ASM-019</a:t>
+                <a:latin typeface="Malgun Gothic" pitchFamily="34" charset="0"/>
+                <a:ea typeface="Malgun Gothic" pitchFamily="34" charset="-122"/>
+                <a:cs typeface="Malgun Gothic" pitchFamily="34" charset="-120"/>
+              </a:rPr>
+              <a:t>출처: SRC-003, SRC-008, ASM-017 to ASM-019</a:t>
             </a:r>
             <a:endParaRPr lang="en-US" sz="800" dirty="0"/>
           </a:p>
@@ -6609,11 +6609,11 @@
                 <a:solidFill>
                   <a:srgbClr val="5AA7A4"/>
                 </a:solidFill>
-                <a:latin typeface="Aptos" pitchFamily="34" charset="0"/>
-                <a:ea typeface="Aptos" pitchFamily="34" charset="-122"/>
-                <a:cs typeface="Aptos" pitchFamily="34" charset="-120"/>
-              </a:rPr>
-              <a:t>PIPELINE</a:t>
+                <a:latin typeface="Malgun Gothic" pitchFamily="34" charset="0"/>
+                <a:ea typeface="Malgun Gothic" pitchFamily="34" charset="-122"/>
+                <a:cs typeface="Malgun Gothic" pitchFamily="34" charset="-120"/>
+              </a:rPr>
+              <a:t>배관 제약</a:t>
             </a:r>
             <a:endParaRPr lang="en-US" sz="1000" dirty="0"/>
           </a:p>
@@ -6644,17 +6644,17 @@
               <a:buNone/>
             </a:pPr>
             <a:r>
-              <a:rPr lang="en-US" sz="2400" b="1" dirty="0">
+              <a:rPr lang="en-US" sz="2200" b="1" dirty="0">
                 <a:solidFill>
                   <a:srgbClr val="F6F2E8"/>
                 </a:solidFill>
-                <a:latin typeface="Aptos Display" pitchFamily="34" charset="0"/>
-                <a:ea typeface="Aptos Display" pitchFamily="34" charset="-122"/>
-                <a:cs typeface="Aptos Display" pitchFamily="34" charset="-120"/>
-              </a:rPr>
-              <a:t>The Real Constraint Is Transport Distance</a:t>
-            </a:r>
-            <a:endParaRPr lang="en-US" sz="2400" dirty="0"/>
+                <a:latin typeface="Malgun Gothic" pitchFamily="34" charset="0"/>
+                <a:ea typeface="Malgun Gothic" pitchFamily="34" charset="-122"/>
+                <a:cs typeface="Malgun Gothic" pitchFamily="34" charset="-120"/>
+              </a:rPr>
+              <a:t>실제 제약은 이송거리다</a:t>
+            </a:r>
+            <a:endParaRPr lang="en-US" sz="2200" dirty="0"/>
           </a:p>
         </p:txBody>
       </p:sp>
@@ -6738,11 +6738,11 @@
                 <a:solidFill>
                   <a:srgbClr val="5A6675"/>
                 </a:solidFill>
-                <a:latin typeface="Aptos" pitchFamily="34" charset="0"/>
-                <a:ea typeface="Aptos" pitchFamily="34" charset="-122"/>
-                <a:cs typeface="Aptos" pitchFamily="34" charset="-120"/>
-              </a:rPr>
-              <a:t>Distance sensitivity for pump power and heat gain</a:t>
+                <a:latin typeface="Malgun Gothic" pitchFamily="34" charset="0"/>
+                <a:ea typeface="Malgun Gothic" pitchFamily="34" charset="-122"/>
+                <a:cs typeface="Malgun Gothic" pitchFamily="34" charset="-120"/>
+              </a:rPr>
+              <a:t>거리 증가에 따른 펌프동력과 열유입</a:t>
             </a:r>
             <a:endParaRPr lang="en-US" sz="850" dirty="0"/>
           </a:p>
@@ -6804,11 +6804,11 @@
                 <a:solidFill>
                   <a:srgbClr val="10243D"/>
                 </a:solidFill>
-                <a:latin typeface="Aptos Display" pitchFamily="34" charset="0"/>
-                <a:ea typeface="Aptos Display" pitchFamily="34" charset="-122"/>
-                <a:cs typeface="Aptos Display" pitchFamily="34" charset="-120"/>
-              </a:rPr>
-              <a:t>Base-case verdict</a:t>
+                <a:latin typeface="Malgun Gothic" pitchFamily="34" charset="0"/>
+                <a:ea typeface="Malgun Gothic" pitchFamily="34" charset="-122"/>
+                <a:cs typeface="Malgun Gothic" pitchFamily="34" charset="-120"/>
+              </a:rPr>
+              <a:t>기본안 판단</a:t>
             </a:r>
             <a:endParaRPr lang="en-US" sz="1500" dirty="0"/>
           </a:p>
@@ -6844,11 +6844,11 @@
                 <a:solidFill>
                   <a:srgbClr val="28323F"/>
                 </a:solidFill>
-                <a:latin typeface="Aptos" pitchFamily="34" charset="0"/>
-                <a:ea typeface="Aptos" pitchFamily="34" charset="-122"/>
-                <a:cs typeface="Aptos" pitchFamily="34" charset="-120"/>
-              </a:rPr>
-              <a:t>10 km is feasible with healthy thermal margin.</a:t>
+                <a:latin typeface="Malgun Gothic" pitchFamily="34" charset="0"/>
+                <a:ea typeface="Malgun Gothic" pitchFamily="34" charset="-122"/>
+                <a:cs typeface="Malgun Gothic" pitchFamily="34" charset="-120"/>
+              </a:rPr>
+              <a:t>10 km는 충분한 열 여유와 함께 성립한다.</a:t>
             </a:r>
             <a:endParaRPr lang="en-US" sz="1250" dirty="0"/>
           </a:p>
@@ -6862,11 +6862,11 @@
                 <a:solidFill>
                   <a:srgbClr val="28323F"/>
                 </a:solidFill>
-                <a:latin typeface="Aptos" pitchFamily="34" charset="0"/>
-                <a:ea typeface="Aptos" pitchFamily="34" charset="-122"/>
-                <a:cs typeface="Aptos" pitchFamily="34" charset="-120"/>
-              </a:rPr>
-              <a:t>The estimated one-way limit is about 29.6 km.</a:t>
+                <a:latin typeface="Malgun Gothic" pitchFamily="34" charset="0"/>
+                <a:ea typeface="Malgun Gothic" pitchFamily="34" charset="-122"/>
+                <a:cs typeface="Malgun Gothic" pitchFamily="34" charset="-120"/>
+              </a:rPr>
+              <a:t>추정된 편도 한계거리는 약 29.6 km다.</a:t>
             </a:r>
             <a:endParaRPr lang="en-US" sz="1250" dirty="0"/>
           </a:p>
@@ -6880,11 +6880,11 @@
                 <a:solidFill>
                   <a:srgbClr val="28323F"/>
                 </a:solidFill>
-                <a:latin typeface="Aptos" pitchFamily="34" charset="0"/>
-                <a:ea typeface="Aptos" pitchFamily="34" charset="-122"/>
-                <a:cs typeface="Aptos" pitchFamily="34" charset="-120"/>
-              </a:rPr>
-              <a:t>The 35 km case fails at the base design point because heat gain outruns the available duty buffer.</a:t>
+                <a:latin typeface="Malgun Gothic" pitchFamily="34" charset="0"/>
+                <a:ea typeface="Malgun Gothic" pitchFamily="34" charset="-122"/>
+                <a:cs typeface="Malgun Gothic" pitchFamily="34" charset="-120"/>
+              </a:rPr>
+              <a:t>35 km에서는 열유입이 사용 가능한 duty 여유를 넘어 기본안이 성립하지 않는다.</a:t>
             </a:r>
             <a:endParaRPr lang="en-US" sz="1250" dirty="0"/>
           </a:p>
@@ -6980,11 +6980,11 @@
                 <a:solidFill>
                   <a:srgbClr val="5A6675"/>
                 </a:solidFill>
-                <a:latin typeface="Aptos" pitchFamily="34" charset="0"/>
-                <a:ea typeface="Aptos" pitchFamily="34" charset="-122"/>
-                <a:cs typeface="Aptos" pitchFamily="34" charset="-120"/>
-              </a:rPr>
-              <a:t>Base case</a:t>
+                <a:latin typeface="Malgun Gothic" pitchFamily="34" charset="0"/>
+                <a:ea typeface="Malgun Gothic" pitchFamily="34" charset="-122"/>
+                <a:cs typeface="Malgun Gothic" pitchFamily="34" charset="-120"/>
+              </a:rPr>
+              <a:t>기본안</a:t>
             </a:r>
             <a:endParaRPr lang="en-US" sz="900" dirty="0"/>
           </a:p>
@@ -7019,9 +7019,9 @@
                 <a:solidFill>
                   <a:srgbClr val="10243D"/>
                 </a:solidFill>
-                <a:latin typeface="Aptos Display" pitchFamily="34" charset="0"/>
-                <a:ea typeface="Aptos Display" pitchFamily="34" charset="-122"/>
-                <a:cs typeface="Aptos Display" pitchFamily="34" charset="-120"/>
+                <a:latin typeface="Malgun Gothic" pitchFamily="34" charset="0"/>
+                <a:ea typeface="Malgun Gothic" pitchFamily="34" charset="-122"/>
+                <a:cs typeface="Malgun Gothic" pitchFamily="34" charset="-120"/>
               </a:rPr>
               <a:t>10 km</a:t>
             </a:r>
@@ -7058,11 +7058,11 @@
                 <a:solidFill>
                   <a:srgbClr val="5A6675"/>
                 </a:solidFill>
-                <a:latin typeface="Aptos" pitchFamily="34" charset="0"/>
-                <a:ea typeface="Aptos" pitchFamily="34" charset="-122"/>
-                <a:cs typeface="Aptos" pitchFamily="34" charset="-120"/>
-              </a:rPr>
-              <a:t>Feasible</a:t>
+                <a:latin typeface="Malgun Gothic" pitchFamily="34" charset="0"/>
+                <a:ea typeface="Malgun Gothic" pitchFamily="34" charset="-122"/>
+                <a:cs typeface="Malgun Gothic" pitchFamily="34" charset="-120"/>
+              </a:rPr>
+              <a:t>성립</a:t>
             </a:r>
             <a:endParaRPr lang="en-US" sz="780" dirty="0"/>
           </a:p>
@@ -7158,11 +7158,11 @@
                 <a:solidFill>
                   <a:srgbClr val="5A6675"/>
                 </a:solidFill>
-                <a:latin typeface="Aptos" pitchFamily="34" charset="0"/>
-                <a:ea typeface="Aptos" pitchFamily="34" charset="-122"/>
-                <a:cs typeface="Aptos" pitchFamily="34" charset="-120"/>
-              </a:rPr>
-              <a:t>Limit</a:t>
+                <a:latin typeface="Malgun Gothic" pitchFamily="34" charset="0"/>
+                <a:ea typeface="Malgun Gothic" pitchFamily="34" charset="-122"/>
+                <a:cs typeface="Malgun Gothic" pitchFamily="34" charset="-120"/>
+              </a:rPr>
+              <a:t>한계</a:t>
             </a:r>
             <a:endParaRPr lang="en-US" sz="900" dirty="0"/>
           </a:p>
@@ -7197,9 +7197,9 @@
                 <a:solidFill>
                   <a:srgbClr val="10243D"/>
                 </a:solidFill>
-                <a:latin typeface="Aptos Display" pitchFamily="34" charset="0"/>
-                <a:ea typeface="Aptos Display" pitchFamily="34" charset="-122"/>
-                <a:cs typeface="Aptos Display" pitchFamily="34" charset="-120"/>
+                <a:latin typeface="Malgun Gothic" pitchFamily="34" charset="0"/>
+                <a:ea typeface="Malgun Gothic" pitchFamily="34" charset="-122"/>
+                <a:cs typeface="Malgun Gothic" pitchFamily="34" charset="-120"/>
               </a:rPr>
               <a:t>29.6 km</a:t>
             </a:r>
@@ -7236,11 +7236,11 @@
                 <a:solidFill>
                   <a:srgbClr val="5A6675"/>
                 </a:solidFill>
-                <a:latin typeface="Aptos" pitchFamily="34" charset="0"/>
-                <a:ea typeface="Aptos" pitchFamily="34" charset="-122"/>
-                <a:cs typeface="Aptos" pitchFamily="34" charset="-120"/>
-              </a:rPr>
-              <a:t>Estimated</a:t>
+                <a:latin typeface="Malgun Gothic" pitchFamily="34" charset="0"/>
+                <a:ea typeface="Malgun Gothic" pitchFamily="34" charset="-122"/>
+                <a:cs typeface="Malgun Gothic" pitchFamily="34" charset="-120"/>
+              </a:rPr>
+              <a:t>추정값</a:t>
             </a:r>
             <a:endParaRPr lang="en-US" sz="780" dirty="0"/>
           </a:p>
@@ -7336,11 +7336,11 @@
                 <a:solidFill>
                   <a:srgbClr val="5A6675"/>
                 </a:solidFill>
-                <a:latin typeface="Aptos" pitchFamily="34" charset="0"/>
-                <a:ea typeface="Aptos" pitchFamily="34" charset="-122"/>
-                <a:cs typeface="Aptos" pitchFamily="34" charset="-120"/>
-              </a:rPr>
-              <a:t>Challenge</a:t>
+                <a:latin typeface="Malgun Gothic" pitchFamily="34" charset="0"/>
+                <a:ea typeface="Malgun Gothic" pitchFamily="34" charset="-122"/>
+                <a:cs typeface="Malgun Gothic" pitchFamily="34" charset="-120"/>
+              </a:rPr>
+              <a:t>도전조건</a:t>
             </a:r>
             <a:endParaRPr lang="en-US" sz="900" dirty="0"/>
           </a:p>
@@ -7375,9 +7375,9 @@
                 <a:solidFill>
                   <a:srgbClr val="10243D"/>
                 </a:solidFill>
-                <a:latin typeface="Aptos Display" pitchFamily="34" charset="0"/>
-                <a:ea typeface="Aptos Display" pitchFamily="34" charset="-122"/>
-                <a:cs typeface="Aptos Display" pitchFamily="34" charset="-120"/>
+                <a:latin typeface="Malgun Gothic" pitchFamily="34" charset="0"/>
+                <a:ea typeface="Malgun Gothic" pitchFamily="34" charset="-122"/>
+                <a:cs typeface="Malgun Gothic" pitchFamily="34" charset="-120"/>
               </a:rPr>
               <a:t>35 km</a:t>
             </a:r>
@@ -7414,11 +7414,11 @@
                 <a:solidFill>
                   <a:srgbClr val="5A6675"/>
                 </a:solidFill>
-                <a:latin typeface="Aptos" pitchFamily="34" charset="0"/>
-                <a:ea typeface="Aptos" pitchFamily="34" charset="-122"/>
-                <a:cs typeface="Aptos" pitchFamily="34" charset="-120"/>
-              </a:rPr>
-              <a:t>Infeasible</a:t>
+                <a:latin typeface="Malgun Gothic" pitchFamily="34" charset="0"/>
+                <a:ea typeface="Malgun Gothic" pitchFamily="34" charset="-122"/>
+                <a:cs typeface="Malgun Gothic" pitchFamily="34" charset="-120"/>
+              </a:rPr>
+              <a:t>불성립</a:t>
             </a:r>
             <a:endParaRPr lang="en-US" sz="780" dirty="0"/>
           </a:p>
@@ -7453,11 +7453,11 @@
                 <a:solidFill>
                   <a:srgbClr val="5A6675"/>
                 </a:solidFill>
-                <a:latin typeface="Aptos" pitchFamily="34" charset="0"/>
-                <a:ea typeface="Aptos" pitchFamily="34" charset="-122"/>
-                <a:cs typeface="Aptos" pitchFamily="34" charset="-120"/>
-              </a:rPr>
-              <a:t>Sources: SRC-001, ASM-014 to ASM-016</a:t>
+                <a:latin typeface="Malgun Gothic" pitchFamily="34" charset="0"/>
+                <a:ea typeface="Malgun Gothic" pitchFamily="34" charset="-122"/>
+                <a:cs typeface="Malgun Gothic" pitchFamily="34" charset="-120"/>
+              </a:rPr>
+              <a:t>출처: SRC-001, ASM-014 to ASM-016</a:t>
             </a:r>
             <a:endParaRPr lang="en-US" sz="800" dirty="0"/>
           </a:p>
@@ -7524,11 +7524,11 @@
                 <a:solidFill>
                   <a:srgbClr val="5AA7A4"/>
                 </a:solidFill>
-                <a:latin typeface="Aptos" pitchFamily="34" charset="0"/>
-                <a:ea typeface="Aptos" pitchFamily="34" charset="-122"/>
-                <a:cs typeface="Aptos" pitchFamily="34" charset="-120"/>
-              </a:rPr>
-              <a:t>SENSITIVITY</a:t>
+                <a:latin typeface="Malgun Gothic" pitchFamily="34" charset="0"/>
+                <a:ea typeface="Malgun Gothic" pitchFamily="34" charset="-122"/>
+                <a:cs typeface="Malgun Gothic" pitchFamily="34" charset="-120"/>
+              </a:rPr>
+              <a:t>민감도</a:t>
             </a:r>
             <a:endParaRPr lang="en-US" sz="1000" dirty="0"/>
           </a:p>
@@ -7559,17 +7559,17 @@
               <a:buNone/>
             </a:pPr>
             <a:r>
-              <a:rPr lang="en-US" sz="2400" b="1" dirty="0">
+              <a:rPr lang="en-US" sz="2200" b="1" dirty="0">
                 <a:solidFill>
                   <a:srgbClr val="F6F2E8"/>
                 </a:solidFill>
-                <a:latin typeface="Aptos Display" pitchFamily="34" charset="0"/>
-                <a:ea typeface="Aptos Display" pitchFamily="34" charset="-122"/>
-                <a:cs typeface="Aptos Display" pitchFamily="34" charset="-120"/>
-              </a:rPr>
-              <a:t>Temperature Level Can Recover Distance, But Not for Free</a:t>
-            </a:r>
-            <a:endParaRPr lang="en-US" sz="2400" dirty="0"/>
+                <a:latin typeface="Malgun Gothic" pitchFamily="34" charset="0"/>
+                <a:ea typeface="Malgun Gothic" pitchFamily="34" charset="-122"/>
+                <a:cs typeface="Malgun Gothic" pitchFamily="34" charset="-120"/>
+              </a:rPr>
+              <a:t>공급온도를 올리면 거리는 늘어나지만 공짜는 아니다</a:t>
+            </a:r>
+            <a:endParaRPr lang="en-US" sz="2200" dirty="0"/>
           </a:p>
         </p:txBody>
       </p:sp>
@@ -7653,11 +7653,11 @@
                 <a:solidFill>
                   <a:srgbClr val="5A6675"/>
                 </a:solidFill>
-                <a:latin typeface="Aptos" pitchFamily="34" charset="0"/>
-                <a:ea typeface="Aptos" pitchFamily="34" charset="-122"/>
-                <a:cs typeface="Aptos" pitchFamily="34" charset="-120"/>
-              </a:rPr>
-              <a:t>Supply-temperature sweep</a:t>
+                <a:latin typeface="Malgun Gothic" pitchFamily="34" charset="0"/>
+                <a:ea typeface="Malgun Gothic" pitchFamily="34" charset="-122"/>
+                <a:cs typeface="Malgun Gothic" pitchFamily="34" charset="-120"/>
+              </a:rPr>
+              <a:t>공급온도 스윕 결과</a:t>
             </a:r>
             <a:endParaRPr lang="en-US" sz="850" dirty="0"/>
           </a:p>
@@ -7719,11 +7719,11 @@
                 <a:solidFill>
                   <a:srgbClr val="10243D"/>
                 </a:solidFill>
-                <a:latin typeface="Aptos Display" pitchFamily="34" charset="0"/>
-                <a:ea typeface="Aptos Display" pitchFamily="34" charset="-122"/>
-                <a:cs typeface="Aptos Display" pitchFamily="34" charset="-120"/>
-              </a:rPr>
-              <a:t>Trade-off</a:t>
+                <a:latin typeface="Malgun Gothic" pitchFamily="34" charset="0"/>
+                <a:ea typeface="Malgun Gothic" pitchFamily="34" charset="-122"/>
+                <a:cs typeface="Malgun Gothic" pitchFamily="34" charset="-120"/>
+              </a:rPr>
+              <a:t>상충관계</a:t>
             </a:r>
             <a:endParaRPr lang="en-US" sz="1500" dirty="0"/>
           </a:p>
@@ -7759,11 +7759,11 @@
                 <a:solidFill>
                   <a:srgbClr val="28323F"/>
                 </a:solidFill>
-                <a:latin typeface="Aptos" pitchFamily="34" charset="0"/>
-                <a:ea typeface="Aptos" pitchFamily="34" charset="-122"/>
-                <a:cs typeface="Aptos" pitchFamily="34" charset="-120"/>
-              </a:rPr>
-              <a:t>The most efficient point remains the 220 K ammonia design.</a:t>
+                <a:latin typeface="Malgun Gothic" pitchFamily="34" charset="0"/>
+                <a:ea typeface="Malgun Gothic" pitchFamily="34" charset="-122"/>
+                <a:cs typeface="Malgun Gothic" pitchFamily="34" charset="-120"/>
+              </a:rPr>
+              <a:t>가장 효율적인 지점은 여전히 220 K 암모니아 기본안이다.</a:t>
             </a:r>
             <a:endParaRPr lang="en-US" sz="1250" dirty="0"/>
           </a:p>
@@ -7777,11 +7777,11 @@
                 <a:solidFill>
                   <a:srgbClr val="28323F"/>
                 </a:solidFill>
-                <a:latin typeface="Aptos" pitchFamily="34" charset="0"/>
-                <a:ea typeface="Aptos" pitchFamily="34" charset="-122"/>
-                <a:cs typeface="Aptos" pitchFamily="34" charset="-120"/>
-              </a:rPr>
-              <a:t>A warmer supply level of 230 K can make the 35 km case feasible.</a:t>
+                <a:latin typeface="Malgun Gothic" pitchFamily="34" charset="0"/>
+                <a:ea typeface="Malgun Gothic" pitchFamily="34" charset="-122"/>
+                <a:cs typeface="Malgun Gothic" pitchFamily="34" charset="-120"/>
+              </a:rPr>
+              <a:t>230 K 수준으로 올리면 35 km 설계를 성립시킬 수 있다.</a:t>
             </a:r>
             <a:endParaRPr lang="en-US" sz="1250" dirty="0"/>
           </a:p>
@@ -7795,11 +7795,11 @@
                 <a:solidFill>
                   <a:srgbClr val="28323F"/>
                 </a:solidFill>
-                <a:latin typeface="Aptos" pitchFamily="34" charset="0"/>
-                <a:ea typeface="Aptos" pitchFamily="34" charset="-122"/>
-                <a:cs typeface="Aptos" pitchFamily="34" charset="-120"/>
-              </a:rPr>
-              <a:t>That recovery requires switching to isobutane and accepting a roughly tenfold pump-power increase.</a:t>
+                <a:latin typeface="Malgun Gothic" pitchFamily="34" charset="0"/>
+                <a:ea typeface="Malgun Gothic" pitchFamily="34" charset="-122"/>
+                <a:cs typeface="Malgun Gothic" pitchFamily="34" charset="-120"/>
+              </a:rPr>
+              <a:t>대신 이소부탄으로 바뀌고 펌프동력이 거의 10배 수준으로 커진다.</a:t>
             </a:r>
             <a:endParaRPr lang="en-US" sz="1250" dirty="0"/>
           </a:p>
@@ -7895,11 +7895,11 @@
                 <a:solidFill>
                   <a:srgbClr val="5A6675"/>
                 </a:solidFill>
-                <a:latin typeface="Aptos" pitchFamily="34" charset="0"/>
-                <a:ea typeface="Aptos" pitchFamily="34" charset="-122"/>
-                <a:cs typeface="Aptos" pitchFamily="34" charset="-120"/>
-              </a:rPr>
-              <a:t>Best power</a:t>
+                <a:latin typeface="Malgun Gothic" pitchFamily="34" charset="0"/>
+                <a:ea typeface="Malgun Gothic" pitchFamily="34" charset="-122"/>
+                <a:cs typeface="Malgun Gothic" pitchFamily="34" charset="-120"/>
+              </a:rPr>
+              <a:t>최적점</a:t>
             </a:r>
             <a:endParaRPr lang="en-US" sz="900" dirty="0"/>
           </a:p>
@@ -7934,9 +7934,9 @@
                 <a:solidFill>
                   <a:srgbClr val="10243D"/>
                 </a:solidFill>
-                <a:latin typeface="Aptos Display" pitchFamily="34" charset="0"/>
-                <a:ea typeface="Aptos Display" pitchFamily="34" charset="-122"/>
-                <a:cs typeface="Aptos Display" pitchFamily="34" charset="-120"/>
+                <a:latin typeface="Malgun Gothic" pitchFamily="34" charset="0"/>
+                <a:ea typeface="Malgun Gothic" pitchFamily="34" charset="-122"/>
+                <a:cs typeface="Malgun Gothic" pitchFamily="34" charset="-120"/>
               </a:rPr>
               <a:t>220 K</a:t>
             </a:r>
@@ -7973,9 +7973,9 @@
                 <a:solidFill>
                   <a:srgbClr val="5A6675"/>
                 </a:solidFill>
-                <a:latin typeface="Aptos" pitchFamily="34" charset="0"/>
-                <a:ea typeface="Aptos" pitchFamily="34" charset="-122"/>
-                <a:cs typeface="Aptos" pitchFamily="34" charset="-120"/>
+                <a:latin typeface="Malgun Gothic" pitchFamily="34" charset="0"/>
+                <a:ea typeface="Malgun Gothic" pitchFamily="34" charset="-122"/>
+                <a:cs typeface="Malgun Gothic" pitchFamily="34" charset="-120"/>
               </a:rPr>
               <a:t>R-717</a:t>
             </a:r>
@@ -8073,11 +8073,11 @@
                 <a:solidFill>
                   <a:srgbClr val="5A6675"/>
                 </a:solidFill>
-                <a:latin typeface="Aptos" pitchFamily="34" charset="0"/>
-                <a:ea typeface="Aptos" pitchFamily="34" charset="-122"/>
-                <a:cs typeface="Aptos" pitchFamily="34" charset="-120"/>
-              </a:rPr>
-              <a:t>35 km fix</a:t>
+                <a:latin typeface="Malgun Gothic" pitchFamily="34" charset="0"/>
+                <a:ea typeface="Malgun Gothic" pitchFamily="34" charset="-122"/>
+                <a:cs typeface="Malgun Gothic" pitchFamily="34" charset="-120"/>
+              </a:rPr>
+              <a:t>35 km 복구</a:t>
             </a:r>
             <a:endParaRPr lang="en-US" sz="900" dirty="0"/>
           </a:p>
@@ -8112,9 +8112,9 @@
                 <a:solidFill>
                   <a:srgbClr val="10243D"/>
                 </a:solidFill>
-                <a:latin typeface="Aptos Display" pitchFamily="34" charset="0"/>
-                <a:ea typeface="Aptos Display" pitchFamily="34" charset="-122"/>
-                <a:cs typeface="Aptos Display" pitchFamily="34" charset="-120"/>
+                <a:latin typeface="Malgun Gothic" pitchFamily="34" charset="0"/>
+                <a:ea typeface="Malgun Gothic" pitchFamily="34" charset="-122"/>
+                <a:cs typeface="Malgun Gothic" pitchFamily="34" charset="-120"/>
               </a:rPr>
               <a:t>230 K</a:t>
             </a:r>
@@ -8151,9 +8151,9 @@
                 <a:solidFill>
                   <a:srgbClr val="5A6675"/>
                 </a:solidFill>
-                <a:latin typeface="Aptos" pitchFamily="34" charset="0"/>
-                <a:ea typeface="Aptos" pitchFamily="34" charset="-122"/>
-                <a:cs typeface="Aptos" pitchFamily="34" charset="-120"/>
+                <a:latin typeface="Malgun Gothic" pitchFamily="34" charset="0"/>
+                <a:ea typeface="Malgun Gothic" pitchFamily="34" charset="-122"/>
+                <a:cs typeface="Malgun Gothic" pitchFamily="34" charset="-120"/>
               </a:rPr>
               <a:t>R-600a</a:t>
             </a:r>
@@ -8251,11 +8251,11 @@
                 <a:solidFill>
                   <a:srgbClr val="5A6675"/>
                 </a:solidFill>
-                <a:latin typeface="Aptos" pitchFamily="34" charset="0"/>
-                <a:ea typeface="Aptos" pitchFamily="34" charset="-122"/>
-                <a:cs typeface="Aptos" pitchFamily="34" charset="-120"/>
-              </a:rPr>
-              <a:t>Cost</a:t>
+                <a:latin typeface="Malgun Gothic" pitchFamily="34" charset="0"/>
+                <a:ea typeface="Malgun Gothic" pitchFamily="34" charset="-122"/>
+                <a:cs typeface="Malgun Gothic" pitchFamily="34" charset="-120"/>
+              </a:rPr>
+              <a:t>대가</a:t>
             </a:r>
             <a:endParaRPr lang="en-US" sz="900" dirty="0"/>
           </a:p>
@@ -8290,9 +8290,9 @@
                 <a:solidFill>
                   <a:srgbClr val="10243D"/>
                 </a:solidFill>
-                <a:latin typeface="Aptos Display" pitchFamily="34" charset="0"/>
-                <a:ea typeface="Aptos Display" pitchFamily="34" charset="-122"/>
-                <a:cs typeface="Aptos Display" pitchFamily="34" charset="-120"/>
+                <a:latin typeface="Malgun Gothic" pitchFamily="34" charset="0"/>
+                <a:ea typeface="Malgun Gothic" pitchFamily="34" charset="-122"/>
+                <a:cs typeface="Malgun Gothic" pitchFamily="34" charset="-120"/>
               </a:rPr>
               <a:t>130 kW</a:t>
             </a:r>
@@ -8329,11 +8329,11 @@
                 <a:solidFill>
                   <a:srgbClr val="5A6675"/>
                 </a:solidFill>
-                <a:latin typeface="Aptos" pitchFamily="34" charset="0"/>
-                <a:ea typeface="Aptos" pitchFamily="34" charset="-122"/>
-                <a:cs typeface="Aptos" pitchFamily="34" charset="-120"/>
-              </a:rPr>
-              <a:t>Loop pump</a:t>
+                <a:latin typeface="Malgun Gothic" pitchFamily="34" charset="0"/>
+                <a:ea typeface="Malgun Gothic" pitchFamily="34" charset="-122"/>
+                <a:cs typeface="Malgun Gothic" pitchFamily="34" charset="-120"/>
+              </a:rPr>
+              <a:t>루프 펌프</a:t>
             </a:r>
             <a:endParaRPr lang="en-US" sz="780" dirty="0"/>
           </a:p>
@@ -8368,11 +8368,11 @@
                 <a:solidFill>
                   <a:srgbClr val="5A6675"/>
                 </a:solidFill>
-                <a:latin typeface="Aptos" pitchFamily="34" charset="0"/>
-                <a:ea typeface="Aptos" pitchFamily="34" charset="-122"/>
-                <a:cs typeface="Aptos" pitchFamily="34" charset="-120"/>
-              </a:rPr>
-              <a:t>Sources: ASM-028, ASM-029</a:t>
+                <a:latin typeface="Malgun Gothic" pitchFamily="34" charset="0"/>
+                <a:ea typeface="Malgun Gothic" pitchFamily="34" charset="-122"/>
+                <a:cs typeface="Malgun Gothic" pitchFamily="34" charset="-120"/>
+              </a:rPr>
+              <a:t>출처: ASM-028, ASM-029</a:t>
             </a:r>
             <a:endParaRPr lang="en-US" sz="800" dirty="0"/>
           </a:p>
@@ -8439,11 +8439,11 @@
                 <a:solidFill>
                   <a:srgbClr val="5AA7A4"/>
                 </a:solidFill>
-                <a:latin typeface="Aptos" pitchFamily="34" charset="0"/>
-                <a:ea typeface="Aptos" pitchFamily="34" charset="-122"/>
-                <a:cs typeface="Aptos" pitchFamily="34" charset="-120"/>
-              </a:rPr>
-              <a:t>ECONOMICS</a:t>
+                <a:latin typeface="Malgun Gothic" pitchFamily="34" charset="0"/>
+                <a:ea typeface="Malgun Gothic" pitchFamily="34" charset="-122"/>
+                <a:cs typeface="Malgun Gothic" pitchFamily="34" charset="-120"/>
+              </a:rPr>
+              <a:t>경제성</a:t>
             </a:r>
             <a:endParaRPr lang="en-US" sz="1000" dirty="0"/>
           </a:p>
@@ -8474,17 +8474,17 @@
               <a:buNone/>
             </a:pPr>
             <a:r>
-              <a:rPr lang="en-US" sz="2400" b="1" dirty="0">
+              <a:rPr lang="en-US" sz="2200" b="1" dirty="0">
                 <a:solidFill>
                   <a:srgbClr val="F6F2E8"/>
                 </a:solidFill>
-                <a:latin typeface="Aptos Display" pitchFamily="34" charset="0"/>
-                <a:ea typeface="Aptos Display" pitchFamily="34" charset="-122"/>
-                <a:cs typeface="Aptos Display" pitchFamily="34" charset="-120"/>
-              </a:rPr>
-              <a:t>Annual Impact Makes the Design Decision Tangible</a:t>
-            </a:r>
-            <a:endParaRPr lang="en-US" sz="2400" dirty="0"/>
+                <a:latin typeface="Malgun Gothic" pitchFamily="34" charset="0"/>
+                <a:ea typeface="Malgun Gothic" pitchFamily="34" charset="-122"/>
+                <a:cs typeface="Malgun Gothic" pitchFamily="34" charset="-120"/>
+              </a:rPr>
+              <a:t>연간 효과를 보면 의사결정이 선명해진다</a:t>
+            </a:r>
+            <a:endParaRPr lang="en-US" sz="2200" dirty="0"/>
           </a:p>
         </p:txBody>
       </p:sp>
@@ -8568,11 +8568,11 @@
                 <a:solidFill>
                   <a:srgbClr val="5A6675"/>
                 </a:solidFill>
-                <a:latin typeface="Aptos" pitchFamily="34" charset="0"/>
-                <a:ea typeface="Aptos" pitchFamily="34" charset="-122"/>
-                <a:cs typeface="Aptos" pitchFamily="34" charset="-120"/>
-              </a:rPr>
-              <a:t>Annualized energy, cost, and carbon comparison</a:t>
+                <a:latin typeface="Malgun Gothic" pitchFamily="34" charset="0"/>
+                <a:ea typeface="Malgun Gothic" pitchFamily="34" charset="-122"/>
+                <a:cs typeface="Malgun Gothic" pitchFamily="34" charset="-120"/>
+              </a:rPr>
+              <a:t>연간 전력, 비용, 탄소 비교</a:t>
             </a:r>
             <a:endParaRPr lang="en-US" sz="850" dirty="0"/>
           </a:p>
@@ -8668,11 +8668,11 @@
                 <a:solidFill>
                   <a:srgbClr val="5A6675"/>
                 </a:solidFill>
-                <a:latin typeface="Aptos" pitchFamily="34" charset="0"/>
-                <a:ea typeface="Aptos" pitchFamily="34" charset="-122"/>
-                <a:cs typeface="Aptos" pitchFamily="34" charset="-120"/>
-              </a:rPr>
-              <a:t>Electricity saving</a:t>
+                <a:latin typeface="Malgun Gothic" pitchFamily="34" charset="0"/>
+                <a:ea typeface="Malgun Gothic" pitchFamily="34" charset="-122"/>
+                <a:cs typeface="Malgun Gothic" pitchFamily="34" charset="-120"/>
+              </a:rPr>
+              <a:t>전력 절감</a:t>
             </a:r>
             <a:endParaRPr lang="en-US" sz="1000" dirty="0"/>
           </a:p>
@@ -8707,11 +8707,11 @@
                 <a:solidFill>
                   <a:srgbClr val="10243D"/>
                 </a:solidFill>
-                <a:latin typeface="Aptos Display" pitchFamily="34" charset="0"/>
-                <a:ea typeface="Aptos Display" pitchFamily="34" charset="-122"/>
-                <a:cs typeface="Aptos Display" pitchFamily="34" charset="-120"/>
-              </a:rPr>
-              <a:t>36,549 MWh/yr</a:t>
+                <a:latin typeface="Malgun Gothic" pitchFamily="34" charset="0"/>
+                <a:ea typeface="Malgun Gothic" pitchFamily="34" charset="-122"/>
+                <a:cs typeface="Malgun Gothic" pitchFamily="34" charset="-120"/>
+              </a:rPr>
+              <a:t>36,549</a:t>
             </a:r>
             <a:endParaRPr lang="en-US" sz="2300" dirty="0"/>
           </a:p>
@@ -8746,11 +8746,11 @@
                 <a:solidFill>
                   <a:srgbClr val="5A6675"/>
                 </a:solidFill>
-                <a:latin typeface="Aptos" pitchFamily="34" charset="0"/>
-                <a:ea typeface="Aptos" pitchFamily="34" charset="-122"/>
-                <a:cs typeface="Aptos" pitchFamily="34" charset="-120"/>
-              </a:rPr>
-              <a:t>Modeled boundary</a:t>
+                <a:latin typeface="Malgun Gothic" pitchFamily="34" charset="0"/>
+                <a:ea typeface="Malgun Gothic" pitchFamily="34" charset="-122"/>
+                <a:cs typeface="Malgun Gothic" pitchFamily="34" charset="-120"/>
+              </a:rPr>
+              <a:t>MWh/년</a:t>
             </a:r>
             <a:endParaRPr lang="en-US" sz="850" dirty="0"/>
           </a:p>
@@ -8846,11 +8846,11 @@
                 <a:solidFill>
                   <a:srgbClr val="5A6675"/>
                 </a:solidFill>
-                <a:latin typeface="Aptos" pitchFamily="34" charset="0"/>
-                <a:ea typeface="Aptos" pitchFamily="34" charset="-122"/>
-                <a:cs typeface="Aptos" pitchFamily="34" charset="-120"/>
-              </a:rPr>
-              <a:t>Cost saving</a:t>
+                <a:latin typeface="Malgun Gothic" pitchFamily="34" charset="0"/>
+                <a:ea typeface="Malgun Gothic" pitchFamily="34" charset="-122"/>
+                <a:cs typeface="Malgun Gothic" pitchFamily="34" charset="-120"/>
+              </a:rPr>
+              <a:t>비용 절감</a:t>
             </a:r>
             <a:endParaRPr lang="en-US" sz="1000" dirty="0"/>
           </a:p>
@@ -8885,11 +8885,11 @@
                 <a:solidFill>
                   <a:srgbClr val="10243D"/>
                 </a:solidFill>
-                <a:latin typeface="Aptos Display" pitchFamily="34" charset="0"/>
-                <a:ea typeface="Aptos Display" pitchFamily="34" charset="-122"/>
-                <a:cs typeface="Aptos Display" pitchFamily="34" charset="-120"/>
-              </a:rPr>
-              <a:t>3,839.5 M KRW/yr</a:t>
+                <a:latin typeface="Malgun Gothic" pitchFamily="34" charset="0"/>
+                <a:ea typeface="Malgun Gothic" pitchFamily="34" charset="-122"/>
+                <a:cs typeface="Malgun Gothic" pitchFamily="34" charset="-120"/>
+              </a:rPr>
+              <a:t>3,839.5</a:t>
             </a:r>
             <a:endParaRPr lang="en-US" sz="2300" dirty="0"/>
           </a:p>
@@ -8924,11 +8924,11 @@
                 <a:solidFill>
                   <a:srgbClr val="5A6675"/>
                 </a:solidFill>
-                <a:latin typeface="Aptos" pitchFamily="34" charset="0"/>
-                <a:ea typeface="Aptos" pitchFamily="34" charset="-122"/>
-                <a:cs typeface="Aptos" pitchFamily="34" charset="-120"/>
-              </a:rPr>
-              <a:t>At 105.05 KRW/kWh</a:t>
+                <a:latin typeface="Malgun Gothic" pitchFamily="34" charset="0"/>
+                <a:ea typeface="Malgun Gothic" pitchFamily="34" charset="-122"/>
+                <a:cs typeface="Malgun Gothic" pitchFamily="34" charset="-120"/>
+              </a:rPr>
+              <a:t>백만원/년</a:t>
             </a:r>
             <a:endParaRPr lang="en-US" sz="850" dirty="0"/>
           </a:p>
@@ -9024,11 +9024,11 @@
                 <a:solidFill>
                   <a:srgbClr val="5A6675"/>
                 </a:solidFill>
-                <a:latin typeface="Aptos" pitchFamily="34" charset="0"/>
-                <a:ea typeface="Aptos" pitchFamily="34" charset="-122"/>
-                <a:cs typeface="Aptos" pitchFamily="34" charset="-120"/>
-              </a:rPr>
-              <a:t>Avoided emissions</a:t>
+                <a:latin typeface="Malgun Gothic" pitchFamily="34" charset="0"/>
+                <a:ea typeface="Malgun Gothic" pitchFamily="34" charset="-122"/>
+                <a:cs typeface="Malgun Gothic" pitchFamily="34" charset="-120"/>
+              </a:rPr>
+              <a:t>회피 배출</a:t>
             </a:r>
             <a:endParaRPr lang="en-US" sz="1000" dirty="0"/>
           </a:p>
@@ -9063,11 +9063,11 @@
                 <a:solidFill>
                   <a:srgbClr val="10243D"/>
                 </a:solidFill>
-                <a:latin typeface="Aptos Display" pitchFamily="34" charset="0"/>
-                <a:ea typeface="Aptos Display" pitchFamily="34" charset="-122"/>
-                <a:cs typeface="Aptos Display" pitchFamily="34" charset="-120"/>
-              </a:rPr>
-              <a:t>16,757.7 tCO2/yr</a:t>
+                <a:latin typeface="Malgun Gothic" pitchFamily="34" charset="0"/>
+                <a:ea typeface="Malgun Gothic" pitchFamily="34" charset="-122"/>
+                <a:cs typeface="Malgun Gothic" pitchFamily="34" charset="-120"/>
+              </a:rPr>
+              <a:t>16,757.7</a:t>
             </a:r>
             <a:endParaRPr lang="en-US" sz="2300" dirty="0"/>
           </a:p>
@@ -9102,11 +9102,11 @@
                 <a:solidFill>
                   <a:srgbClr val="5A6675"/>
                 </a:solidFill>
-                <a:latin typeface="Aptos" pitchFamily="34" charset="0"/>
-                <a:ea typeface="Aptos" pitchFamily="34" charset="-122"/>
-                <a:cs typeface="Aptos" pitchFamily="34" charset="-120"/>
-              </a:rPr>
-              <a:t>Indirect emissions</a:t>
+                <a:latin typeface="Malgun Gothic" pitchFamily="34" charset="0"/>
+                <a:ea typeface="Malgun Gothic" pitchFamily="34" charset="-122"/>
+                <a:cs typeface="Malgun Gothic" pitchFamily="34" charset="-120"/>
+              </a:rPr>
+              <a:t>tCO2/년</a:t>
             </a:r>
             <a:endParaRPr lang="en-US" sz="850" dirty="0"/>
           </a:p>
@@ -9202,11 +9202,11 @@
                 <a:solidFill>
                   <a:srgbClr val="5A6675"/>
                 </a:solidFill>
-                <a:latin typeface="Aptos" pitchFamily="34" charset="0"/>
-                <a:ea typeface="Aptos" pitchFamily="34" charset="-122"/>
-                <a:cs typeface="Aptos" pitchFamily="34" charset="-120"/>
-              </a:rPr>
-              <a:t>5-yr CAPEX room</a:t>
+                <a:latin typeface="Malgun Gothic" pitchFamily="34" charset="0"/>
+                <a:ea typeface="Malgun Gothic" pitchFamily="34" charset="-122"/>
+                <a:cs typeface="Malgun Gothic" pitchFamily="34" charset="-120"/>
+              </a:rPr>
+              <a:t>5년 허용 CAPEX</a:t>
             </a:r>
             <a:endParaRPr lang="en-US" sz="1000" dirty="0"/>
           </a:p>
@@ -9241,11 +9241,11 @@
                 <a:solidFill>
                   <a:srgbClr val="10243D"/>
                 </a:solidFill>
-                <a:latin typeface="Aptos Display" pitchFamily="34" charset="0"/>
-                <a:ea typeface="Aptos Display" pitchFamily="34" charset="-122"/>
-                <a:cs typeface="Aptos Display" pitchFamily="34" charset="-120"/>
-              </a:rPr>
-              <a:t>19,197.4 M KRW</a:t>
+                <a:latin typeface="Malgun Gothic" pitchFamily="34" charset="0"/>
+                <a:ea typeface="Malgun Gothic" pitchFamily="34" charset="-122"/>
+                <a:cs typeface="Malgun Gothic" pitchFamily="34" charset="-120"/>
+              </a:rPr>
+              <a:t>19,197.4</a:t>
             </a:r>
             <a:endParaRPr lang="en-US" sz="2300" dirty="0"/>
           </a:p>
@@ -9280,11 +9280,11 @@
                 <a:solidFill>
                   <a:srgbClr val="5A6675"/>
                 </a:solidFill>
-                <a:latin typeface="Aptos" pitchFamily="34" charset="0"/>
-                <a:ea typeface="Aptos" pitchFamily="34" charset="-122"/>
-                <a:cs typeface="Aptos" pitchFamily="34" charset="-120"/>
-              </a:rPr>
-              <a:t>Simple payback</a:t>
+                <a:latin typeface="Malgun Gothic" pitchFamily="34" charset="0"/>
+                <a:ea typeface="Malgun Gothic" pitchFamily="34" charset="-122"/>
+                <a:cs typeface="Malgun Gothic" pitchFamily="34" charset="-120"/>
+              </a:rPr>
+              <a:t>백만원</a:t>
             </a:r>
             <a:endParaRPr lang="en-US" sz="850" dirty="0"/>
           </a:p>
@@ -9342,17 +9342,17 @@
               <a:buNone/>
             </a:pPr>
             <a:r>
-              <a:rPr lang="en-US" sz="1100" dirty="0">
+              <a:rPr lang="en-US" sz="1050" dirty="0">
                 <a:solidFill>
                   <a:srgbClr val="28323F"/>
                 </a:solidFill>
-                <a:latin typeface="Aptos" pitchFamily="34" charset="0"/>
-                <a:ea typeface="Aptos" pitchFamily="34" charset="-122"/>
-                <a:cs typeface="Aptos" pitchFamily="34" charset="-120"/>
-              </a:rPr>
-              <a:t>Boundary note: these annual metrics compare the reference compressor power against the LNG loop pumping power only.</a:t>
-            </a:r>
-            <a:endParaRPr lang="en-US" sz="1100" dirty="0"/>
+                <a:latin typeface="Malgun Gothic" pitchFamily="34" charset="0"/>
+                <a:ea typeface="Malgun Gothic" pitchFamily="34" charset="-122"/>
+                <a:cs typeface="Malgun Gothic" pitchFamily="34" charset="-120"/>
+              </a:rPr>
+              <a:t>경계조건 메모: 연간 지표는 기준 압축기 전력과 LNG 루프 펌프동력만 비교한 결과다.</a:t>
+            </a:r>
+            <a:endParaRPr lang="en-US" sz="1050" dirty="0"/>
           </a:p>
         </p:txBody>
       </p:sp>
@@ -9385,11 +9385,11 @@
                 <a:solidFill>
                   <a:srgbClr val="5A6675"/>
                 </a:solidFill>
-                <a:latin typeface="Aptos" pitchFamily="34" charset="0"/>
-                <a:ea typeface="Aptos" pitchFamily="34" charset="-122"/>
-                <a:cs typeface="Aptos" pitchFamily="34" charset="-120"/>
-              </a:rPr>
-              <a:t>Sources: SRC-013, SRC-014, ASM-030 to ASM-032</a:t>
+                <a:latin typeface="Malgun Gothic" pitchFamily="34" charset="0"/>
+                <a:ea typeface="Malgun Gothic" pitchFamily="34" charset="-122"/>
+                <a:cs typeface="Malgun Gothic" pitchFamily="34" charset="-120"/>
+              </a:rPr>
+              <a:t>출처: SRC-013, SRC-014, ASM-030 to ASM-032</a:t>
             </a:r>
             <a:endParaRPr lang="en-US" sz="800" dirty="0"/>
           </a:p>
@@ -9456,11 +9456,11 @@
                 <a:solidFill>
                   <a:srgbClr val="5AA7A4"/>
                 </a:solidFill>
-                <a:latin typeface="Aptos" pitchFamily="34" charset="0"/>
-                <a:ea typeface="Aptos" pitchFamily="34" charset="-122"/>
-                <a:cs typeface="Aptos" pitchFamily="34" charset="-120"/>
-              </a:rPr>
-              <a:t>CLOSING</a:t>
+                <a:latin typeface="Malgun Gothic" pitchFamily="34" charset="0"/>
+                <a:ea typeface="Malgun Gothic" pitchFamily="34" charset="-122"/>
+                <a:cs typeface="Malgun Gothic" pitchFamily="34" charset="-120"/>
+              </a:rPr>
+              <a:t>결론</a:t>
             </a:r>
             <a:endParaRPr lang="en-US" sz="1000" dirty="0"/>
           </a:p>
@@ -9491,17 +9491,17 @@
               <a:buNone/>
             </a:pPr>
             <a:r>
-              <a:rPr lang="en-US" sz="2400" b="1" dirty="0">
+              <a:rPr lang="en-US" sz="2200" b="1" dirty="0">
                 <a:solidFill>
                   <a:srgbClr val="F6F2E8"/>
                 </a:solidFill>
-                <a:latin typeface="Aptos Display" pitchFamily="34" charset="0"/>
-                <a:ea typeface="Aptos Display" pitchFamily="34" charset="-122"/>
-                <a:cs typeface="Aptos Display" pitchFamily="34" charset="-120"/>
-              </a:rPr>
-              <a:t>Recommendation</a:t>
-            </a:r>
-            <a:endParaRPr lang="en-US" sz="2400" dirty="0"/>
+                <a:latin typeface="Malgun Gothic" pitchFamily="34" charset="0"/>
+                <a:ea typeface="Malgun Gothic" pitchFamily="34" charset="-122"/>
+                <a:cs typeface="Malgun Gothic" pitchFamily="34" charset="-120"/>
+              </a:rPr>
+              <a:t>최종 제안</a:t>
+            </a:r>
+            <a:endParaRPr lang="en-US" sz="2200" dirty="0"/>
           </a:p>
         </p:txBody>
       </p:sp>
@@ -9561,11 +9561,11 @@
                 <a:solidFill>
                   <a:srgbClr val="10243D"/>
                 </a:solidFill>
-                <a:latin typeface="Aptos Display" pitchFamily="34" charset="0"/>
-                <a:ea typeface="Aptos Display" pitchFamily="34" charset="-122"/>
-                <a:cs typeface="Aptos Display" pitchFamily="34" charset="-120"/>
-              </a:rPr>
-              <a:t>What we can say confidently</a:t>
+                <a:latin typeface="Malgun Gothic" pitchFamily="34" charset="0"/>
+                <a:ea typeface="Malgun Gothic" pitchFamily="34" charset="-122"/>
+                <a:cs typeface="Malgun Gothic" pitchFamily="34" charset="-120"/>
+              </a:rPr>
+              <a:t>확실히 말할 수 있는 점</a:t>
             </a:r>
             <a:endParaRPr lang="en-US" sz="1500" dirty="0"/>
           </a:p>
@@ -9601,11 +9601,11 @@
                 <a:solidFill>
                   <a:srgbClr val="28323F"/>
                 </a:solidFill>
-                <a:latin typeface="Aptos" pitchFamily="34" charset="0"/>
-                <a:ea typeface="Aptos" pitchFamily="34" charset="-122"/>
-                <a:cs typeface="Aptos" pitchFamily="34" charset="-120"/>
-              </a:rPr>
-              <a:t>The LNG cold-energy concept is technically feasible at the 10 km design point.</a:t>
+                <a:latin typeface="Malgun Gothic" pitchFamily="34" charset="0"/>
+                <a:ea typeface="Malgun Gothic" pitchFamily="34" charset="-122"/>
+                <a:cs typeface="Malgun Gothic" pitchFamily="34" charset="-120"/>
+              </a:rPr>
+              <a:t>LNG 냉열 개념은 10 km 설계점에서 기술적으로 성립한다.</a:t>
             </a:r>
             <a:endParaRPr lang="en-US" sz="1250" dirty="0"/>
           </a:p>
@@ -9619,11 +9619,11 @@
                 <a:solidFill>
                   <a:srgbClr val="28323F"/>
                 </a:solidFill>
-                <a:latin typeface="Aptos" pitchFamily="34" charset="0"/>
-                <a:ea typeface="Aptos" pitchFamily="34" charset="-122"/>
-                <a:cs typeface="Aptos" pitchFamily="34" charset="-120"/>
-              </a:rPr>
-              <a:t>The base-case design is far better than the reference compressor benchmark in modeled power demand.</a:t>
+                <a:latin typeface="Malgun Gothic" pitchFamily="34" charset="0"/>
+                <a:ea typeface="Malgun Gothic" pitchFamily="34" charset="-122"/>
+                <a:cs typeface="Malgun Gothic" pitchFamily="34" charset="-120"/>
+              </a:rPr>
+              <a:t>기본안은 기준 압축기 대비 전력 요구가 매우 낮다.</a:t>
             </a:r>
             <a:endParaRPr lang="en-US" sz="1250" dirty="0"/>
           </a:p>
@@ -9637,11 +9637,11 @@
                 <a:solidFill>
                   <a:srgbClr val="28323F"/>
                 </a:solidFill>
-                <a:latin typeface="Aptos" pitchFamily="34" charset="0"/>
-                <a:ea typeface="Aptos" pitchFamily="34" charset="-122"/>
-                <a:cs typeface="Aptos" pitchFamily="34" charset="-120"/>
-              </a:rPr>
-              <a:t>The real story is the boundary between feasible transport and infeasible transport, not just a single best number.</a:t>
+                <a:latin typeface="Malgun Gothic" pitchFamily="34" charset="0"/>
+                <a:ea typeface="Malgun Gothic" pitchFamily="34" charset="-122"/>
+                <a:cs typeface="Malgun Gothic" pitchFamily="34" charset="-120"/>
+              </a:rPr>
+              <a:t>핵심은 단일 최적값보다 성립 거리와 불성립 거리의 경계다.</a:t>
             </a:r>
             <a:endParaRPr lang="en-US" sz="1250" dirty="0"/>
           </a:p>
@@ -9703,11 +9703,11 @@
                 <a:solidFill>
                   <a:srgbClr val="10243D"/>
                 </a:solidFill>
-                <a:latin typeface="Aptos Display" pitchFamily="34" charset="0"/>
-                <a:ea typeface="Aptos Display" pitchFamily="34" charset="-122"/>
-                <a:cs typeface="Aptos Display" pitchFamily="34" charset="-120"/>
-              </a:rPr>
-              <a:t>Recommended message in the presentation</a:t>
+                <a:latin typeface="Malgun Gothic" pitchFamily="34" charset="0"/>
+                <a:ea typeface="Malgun Gothic" pitchFamily="34" charset="-122"/>
+                <a:cs typeface="Malgun Gothic" pitchFamily="34" charset="-120"/>
+              </a:rPr>
+              <a:t>발표에서 강조할 메시지</a:t>
             </a:r>
             <a:endParaRPr lang="en-US" sz="1500" dirty="0"/>
           </a:p>
@@ -9743,11 +9743,11 @@
                 <a:solidFill>
                   <a:srgbClr val="28323F"/>
                 </a:solidFill>
-                <a:latin typeface="Aptos" pitchFamily="34" charset="0"/>
-                <a:ea typeface="Aptos" pitchFamily="34" charset="-122"/>
-                <a:cs typeface="Aptos" pitchFamily="34" charset="-120"/>
-              </a:rPr>
-              <a:t>10 km works.</a:t>
+                <a:latin typeface="Malgun Gothic" pitchFamily="34" charset="0"/>
+                <a:ea typeface="Malgun Gothic" pitchFamily="34" charset="-122"/>
+                <a:cs typeface="Malgun Gothic" pitchFamily="34" charset="-120"/>
+              </a:rPr>
+              <a:t>10 km는 된다.</a:t>
             </a:r>
             <a:endParaRPr lang="en-US" sz="1250" dirty="0"/>
           </a:p>
@@ -9761,11 +9761,11 @@
                 <a:solidFill>
                   <a:srgbClr val="28323F"/>
                 </a:solidFill>
-                <a:latin typeface="Aptos" pitchFamily="34" charset="0"/>
-                <a:ea typeface="Aptos" pitchFamily="34" charset="-122"/>
-                <a:cs typeface="Aptos" pitchFamily="34" charset="-120"/>
-              </a:rPr>
-              <a:t>35 km does not work at the base point.</a:t>
+                <a:latin typeface="Malgun Gothic" pitchFamily="34" charset="0"/>
+                <a:ea typeface="Malgun Gothic" pitchFamily="34" charset="-122"/>
+                <a:cs typeface="Malgun Gothic" pitchFamily="34" charset="-120"/>
+              </a:rPr>
+              <a:t>35 km는 기본점에서 안 된다.</a:t>
             </a:r>
             <a:endParaRPr lang="en-US" sz="1250" dirty="0"/>
           </a:p>
@@ -9779,11 +9779,11 @@
                 <a:solidFill>
                   <a:srgbClr val="28323F"/>
                 </a:solidFill>
-                <a:latin typeface="Aptos" pitchFamily="34" charset="0"/>
-                <a:ea typeface="Aptos" pitchFamily="34" charset="-122"/>
-                <a:cs typeface="Aptos" pitchFamily="34" charset="-120"/>
-              </a:rPr>
-              <a:t>35 km can be recovered only by accepting a different operating trade-off.</a:t>
+                <a:latin typeface="Malgun Gothic" pitchFamily="34" charset="0"/>
+                <a:ea typeface="Malgun Gothic" pitchFamily="34" charset="-122"/>
+                <a:cs typeface="Malgun Gothic" pitchFamily="34" charset="-120"/>
+              </a:rPr>
+              <a:t>35 km는 다른 운전조건을 받아들일 때만 복구된다.</a:t>
             </a:r>
             <a:endParaRPr lang="en-US" sz="1250" dirty="0"/>
           </a:p>
@@ -9845,11 +9845,11 @@
                 <a:solidFill>
                   <a:srgbClr val="10243D"/>
                 </a:solidFill>
-                <a:latin typeface="Aptos Display" pitchFamily="34" charset="0"/>
-                <a:ea typeface="Aptos Display" pitchFamily="34" charset="-122"/>
-                <a:cs typeface="Aptos Display" pitchFamily="34" charset="-120"/>
-              </a:rPr>
-              <a:t>Next refinement after this deck</a:t>
+                <a:latin typeface="Malgun Gothic" pitchFamily="34" charset="0"/>
+                <a:ea typeface="Malgun Gothic" pitchFamily="34" charset="-122"/>
+                <a:cs typeface="Malgun Gothic" pitchFamily="34" charset="-120"/>
+              </a:rPr>
+              <a:t>다음 정교화 단계</a:t>
             </a:r>
             <a:endParaRPr lang="en-US" sz="1500" dirty="0"/>
           </a:p>
@@ -9885,11 +9885,11 @@
                 <a:solidFill>
                   <a:srgbClr val="28323F"/>
                 </a:solidFill>
-                <a:latin typeface="Aptos" pitchFamily="34" charset="0"/>
-                <a:ea typeface="Aptos" pitchFamily="34" charset="-122"/>
-                <a:cs typeface="Aptos" pitchFamily="34" charset="-120"/>
-              </a:rPr>
-              <a:t>Tighten the fluid-safety narrative for ammonia versus hydrocarbons.</a:t>
+                <a:latin typeface="Malgun Gothic" pitchFamily="34" charset="0"/>
+                <a:ea typeface="Malgun Gothic" pitchFamily="34" charset="-122"/>
+                <a:cs typeface="Malgun Gothic" pitchFamily="34" charset="-120"/>
+              </a:rPr>
+              <a:t>암모니아와 탄화수소 유체의 안전성 서술 보강</a:t>
             </a:r>
             <a:endParaRPr lang="en-US" sz="1250" dirty="0"/>
           </a:p>
@@ -9903,11 +9903,11 @@
                 <a:solidFill>
                   <a:srgbClr val="28323F"/>
                 </a:solidFill>
-                <a:latin typeface="Aptos" pitchFamily="34" charset="0"/>
-                <a:ea typeface="Aptos" pitchFamily="34" charset="-122"/>
-                <a:cs typeface="Aptos" pitchFamily="34" charset="-120"/>
-              </a:rPr>
-              <a:t>Add implementation risks and controls strategy.</a:t>
+                <a:latin typeface="Malgun Gothic" pitchFamily="34" charset="0"/>
+                <a:ea typeface="Malgun Gothic" pitchFamily="34" charset="-122"/>
+                <a:cs typeface="Malgun Gothic" pitchFamily="34" charset="-120"/>
+              </a:rPr>
+              <a:t>구현 리스크와 제어 전략 추가</a:t>
             </a:r>
             <a:endParaRPr lang="en-US" sz="1250" dirty="0"/>
           </a:p>
@@ -9921,11 +9921,11 @@
                 <a:solidFill>
                   <a:srgbClr val="28323F"/>
                 </a:solidFill>
-                <a:latin typeface="Aptos" pitchFamily="34" charset="0"/>
-                <a:ea typeface="Aptos" pitchFamily="34" charset="-122"/>
-                <a:cs typeface="Aptos" pitchFamily="34" charset="-120"/>
-              </a:rPr>
-              <a:t>Convert the markdown report into the final submission format.</a:t>
+                <a:latin typeface="Malgun Gothic" pitchFamily="34" charset="0"/>
+                <a:ea typeface="Malgun Gothic" pitchFamily="34" charset="-122"/>
+                <a:cs typeface="Malgun Gothic" pitchFamily="34" charset="-120"/>
+              </a:rPr>
+              <a:t>마크다운 보고서를 최종 제출 형식으로 변환</a:t>
             </a:r>
             <a:endParaRPr lang="en-US" sz="1250" dirty="0"/>
           </a:p>
@@ -10021,11 +10021,11 @@
                 <a:solidFill>
                   <a:srgbClr val="5A6675"/>
                 </a:solidFill>
-                <a:latin typeface="Aptos" pitchFamily="34" charset="0"/>
-                <a:ea typeface="Aptos" pitchFamily="34" charset="-122"/>
-                <a:cs typeface="Aptos" pitchFamily="34" charset="-120"/>
-              </a:rPr>
-              <a:t>Base-case answer</a:t>
+                <a:latin typeface="Malgun Gothic" pitchFamily="34" charset="0"/>
+                <a:ea typeface="Malgun Gothic" pitchFamily="34" charset="-122"/>
+                <a:cs typeface="Malgun Gothic" pitchFamily="34" charset="-120"/>
+              </a:rPr>
+              <a:t>기본안 결론</a:t>
             </a:r>
             <a:endParaRPr lang="en-US" sz="900" dirty="0"/>
           </a:p>
@@ -10060,11 +10060,11 @@
                 <a:solidFill>
                   <a:srgbClr val="10243D"/>
                 </a:solidFill>
-                <a:latin typeface="Aptos Display" pitchFamily="34" charset="0"/>
-                <a:ea typeface="Aptos Display" pitchFamily="34" charset="-122"/>
-                <a:cs typeface="Aptos Display" pitchFamily="34" charset="-120"/>
-              </a:rPr>
-              <a:t>Use LNG cold energy</a:t>
+                <a:latin typeface="Malgun Gothic" pitchFamily="34" charset="0"/>
+                <a:ea typeface="Malgun Gothic" pitchFamily="34" charset="-122"/>
+                <a:cs typeface="Malgun Gothic" pitchFamily="34" charset="-120"/>
+              </a:rPr>
+              <a:t>10 km 가능</a:t>
             </a:r>
             <a:endParaRPr lang="en-US" sz="1800" dirty="0"/>
           </a:p>
@@ -10099,11 +10099,11 @@
                 <a:solidFill>
                   <a:srgbClr val="5A6675"/>
                 </a:solidFill>
-                <a:latin typeface="Aptos" pitchFamily="34" charset="0"/>
-                <a:ea typeface="Aptos" pitchFamily="34" charset="-122"/>
-                <a:cs typeface="Aptos" pitchFamily="34" charset="-120"/>
-              </a:rPr>
-              <a:t>at 10 km</a:t>
+                <a:latin typeface="Malgun Gothic" pitchFamily="34" charset="0"/>
+                <a:ea typeface="Malgun Gothic" pitchFamily="34" charset="-122"/>
+                <a:cs typeface="Malgun Gothic" pitchFamily="34" charset="-120"/>
+              </a:rPr>
+              <a:t>LNG 냉열 적용</a:t>
             </a:r>
             <a:endParaRPr lang="en-US" sz="780" dirty="0"/>
           </a:p>
@@ -10199,11 +10199,11 @@
                 <a:solidFill>
                   <a:srgbClr val="5A6675"/>
                 </a:solidFill>
-                <a:latin typeface="Aptos" pitchFamily="34" charset="0"/>
-                <a:ea typeface="Aptos" pitchFamily="34" charset="-122"/>
-                <a:cs typeface="Aptos" pitchFamily="34" charset="-120"/>
-              </a:rPr>
-              <a:t>Boundary insight</a:t>
+                <a:latin typeface="Malgun Gothic" pitchFamily="34" charset="0"/>
+                <a:ea typeface="Malgun Gothic" pitchFamily="34" charset="-122"/>
+                <a:cs typeface="Malgun Gothic" pitchFamily="34" charset="-120"/>
+              </a:rPr>
+              <a:t>경계 통찰</a:t>
             </a:r>
             <a:endParaRPr lang="en-US" sz="900" dirty="0"/>
           </a:p>
@@ -10238,11 +10238,11 @@
                 <a:solidFill>
                   <a:srgbClr val="10243D"/>
                 </a:solidFill>
-                <a:latin typeface="Aptos Display" pitchFamily="34" charset="0"/>
-                <a:ea typeface="Aptos Display" pitchFamily="34" charset="-122"/>
-                <a:cs typeface="Aptos Display" pitchFamily="34" charset="-120"/>
-              </a:rPr>
-              <a:t>29.6 km limit</a:t>
+                <a:latin typeface="Malgun Gothic" pitchFamily="34" charset="0"/>
+                <a:ea typeface="Malgun Gothic" pitchFamily="34" charset="-122"/>
+                <a:cs typeface="Malgun Gothic" pitchFamily="34" charset="-120"/>
+              </a:rPr>
+              <a:t>29.6 km 한계</a:t>
             </a:r>
             <a:endParaRPr lang="en-US" sz="1800" dirty="0"/>
           </a:p>
@@ -10277,11 +10277,11 @@
                 <a:solidFill>
                   <a:srgbClr val="5A6675"/>
                 </a:solidFill>
-                <a:latin typeface="Aptos" pitchFamily="34" charset="0"/>
-                <a:ea typeface="Aptos" pitchFamily="34" charset="-122"/>
-                <a:cs typeface="Aptos" pitchFamily="34" charset="-120"/>
-              </a:rPr>
-              <a:t>estimated one-way</a:t>
+                <a:latin typeface="Malgun Gothic" pitchFamily="34" charset="0"/>
+                <a:ea typeface="Malgun Gothic" pitchFamily="34" charset="-122"/>
+                <a:cs typeface="Malgun Gothic" pitchFamily="34" charset="-120"/>
+              </a:rPr>
+              <a:t>편도 기준 추정</a:t>
             </a:r>
             <a:endParaRPr lang="en-US" sz="780" dirty="0"/>
           </a:p>
@@ -10377,11 +10377,11 @@
                 <a:solidFill>
                   <a:srgbClr val="5A6675"/>
                 </a:solidFill>
-                <a:latin typeface="Aptos" pitchFamily="34" charset="0"/>
-                <a:ea typeface="Aptos" pitchFamily="34" charset="-122"/>
-                <a:cs typeface="Aptos" pitchFamily="34" charset="-120"/>
-              </a:rPr>
-              <a:t>Decision posture</a:t>
+                <a:latin typeface="Malgun Gothic" pitchFamily="34" charset="0"/>
+                <a:ea typeface="Malgun Gothic" pitchFamily="34" charset="-122"/>
+                <a:cs typeface="Malgun Gothic" pitchFamily="34" charset="-120"/>
+              </a:rPr>
+              <a:t>의사결정</a:t>
             </a:r>
             <a:endParaRPr lang="en-US" sz="900" dirty="0"/>
           </a:p>
@@ -10416,11 +10416,11 @@
                 <a:solidFill>
                   <a:srgbClr val="10243D"/>
                 </a:solidFill>
-                <a:latin typeface="Aptos Display" pitchFamily="34" charset="0"/>
-                <a:ea typeface="Aptos Display" pitchFamily="34" charset="-122"/>
-                <a:cs typeface="Aptos Display" pitchFamily="34" charset="-120"/>
-              </a:rPr>
-              <a:t>Feasible, but distance-sensitive</a:t>
+                <a:latin typeface="Malgun Gothic" pitchFamily="34" charset="0"/>
+                <a:ea typeface="Malgun Gothic" pitchFamily="34" charset="-122"/>
+                <a:cs typeface="Malgun Gothic" pitchFamily="34" charset="-120"/>
+              </a:rPr>
+              <a:t>가능하지만 거리 민감</a:t>
             </a:r>
             <a:endParaRPr lang="en-US" sz="1800" dirty="0"/>
           </a:p>
@@ -10455,11 +10455,11 @@
                 <a:solidFill>
                   <a:srgbClr val="5A6675"/>
                 </a:solidFill>
-                <a:latin typeface="Aptos" pitchFamily="34" charset="0"/>
-                <a:ea typeface="Aptos" pitchFamily="34" charset="-122"/>
-                <a:cs typeface="Aptos" pitchFamily="34" charset="-120"/>
-              </a:rPr>
-              <a:t>not a universal win</a:t>
+                <a:latin typeface="Malgun Gothic" pitchFamily="34" charset="0"/>
+                <a:ea typeface="Malgun Gothic" pitchFamily="34" charset="-122"/>
+                <a:cs typeface="Malgun Gothic" pitchFamily="34" charset="-120"/>
+              </a:rPr>
+              <a:t>보편 해법은 아님</a:t>
             </a:r>
             <a:endParaRPr lang="en-US" sz="780" dirty="0"/>
           </a:p>
@@ -10494,11 +10494,11 @@
                 <a:solidFill>
                   <a:srgbClr val="5A6675"/>
                 </a:solidFill>
-                <a:latin typeface="Aptos" pitchFamily="34" charset="0"/>
-                <a:ea typeface="Aptos" pitchFamily="34" charset="-122"/>
-                <a:cs typeface="Aptos" pitchFamily="34" charset="-120"/>
-              </a:rPr>
-              <a:t>Generated with PptxGenJS source for editable follow-up</a:t>
+                <a:latin typeface="Malgun Gothic" pitchFamily="34" charset="0"/>
+                <a:ea typeface="Malgun Gothic" pitchFamily="34" charset="-122"/>
+                <a:cs typeface="Malgun Gothic" pitchFamily="34" charset="-120"/>
+              </a:rPr>
+              <a:t>수정 가능한 후속 작업을 위해 PptxGenJS 원본에서 생성</a:t>
             </a:r>
             <a:endParaRPr lang="en-US" sz="800" dirty="0"/>
           </a:p>
@@ -10555,7 +10555,7 @@
     </a:clrScheme>
     <a:fontScheme name="Office">
       <a:majorFont>
-        <a:latin typeface="Aptos Display"/>
+        <a:latin typeface="Malgun Gothic"/>
         <a:ea typeface=""/>
         <a:cs typeface=""/>
         <a:font script="Jpan" typeface="游ゴシック Light"/>
@@ -10607,7 +10607,7 @@
         <a:font script="Tfng" typeface="Ebrima"/>
       </a:majorFont>
       <a:minorFont>
-        <a:latin typeface="Aptos"/>
+        <a:latin typeface="Malgun Gothic"/>
         <a:ea typeface=""/>
         <a:cs typeface=""/>
         <a:font script="Jpan" typeface="游ゴシック"/>

</xml_diff>

<commit_message>
Tighten thermal coupling and sync deliverables
</commit_message>
<xml_diff>
--- a/deliverables/presentation_draft.pptx
+++ b/deliverables/presentation_draft.pptx
@@ -3363,7 +3363,7 @@
                 <a:ea typeface="Malgun Gothic" pitchFamily="34" charset="-122"/>
                 <a:cs typeface="Malgun Gothic" pitchFamily="34" charset="-120"/>
               </a:rPr>
-              <a:t>500</a:t>
+              <a:t>600</a:t>
             </a:r>
             <a:endParaRPr lang="en-US" sz="2000" dirty="0"/>
           </a:p>
@@ -3402,7 +3402,7 @@
                 <a:ea typeface="Malgun Gothic" pitchFamily="34" charset="-122"/>
                 <a:cs typeface="Malgun Gothic" pitchFamily="34" charset="-120"/>
               </a:rPr>
-              <a:t>기본안</a:t>
+              <a:t>현재 결과</a:t>
             </a:r>
             <a:endParaRPr lang="en-US" sz="950" dirty="0"/>
           </a:p>
@@ -3505,7 +3505,7 @@
                 <a:ea typeface="Malgun Gothic" pitchFamily="34" charset="-122"/>
                 <a:cs typeface="Malgun Gothic" pitchFamily="34" charset="-120"/>
               </a:rPr>
-              <a:t>14 m</a:t>
+              <a:t>14.0 m</a:t>
             </a:r>
             <a:endParaRPr lang="en-US" sz="2000" dirty="0"/>
           </a:p>
@@ -3544,7 +3544,7 @@
                 <a:ea typeface="Malgun Gothic" pitchFamily="34" charset="-122"/>
                 <a:cs typeface="Malgun Gothic" pitchFamily="34" charset="-120"/>
               </a:rPr>
-              <a:t>기본안</a:t>
+              <a:t>현재 결과</a:t>
             </a:r>
             <a:endParaRPr lang="en-US" sz="950" dirty="0"/>
           </a:p>
@@ -3647,7 +3647,7 @@
                 <a:ea typeface="Malgun Gothic" pitchFamily="34" charset="-122"/>
                 <a:cs typeface="Malgun Gothic" pitchFamily="34" charset="-120"/>
               </a:rPr>
-              <a:t>0.723 m</a:t>
+              <a:t>0.792 m</a:t>
             </a:r>
             <a:endParaRPr lang="en-US" sz="2000" dirty="0"/>
           </a:p>
@@ -5572,7 +5572,7 @@
         <p:spPr>
           <a:xfrm>
             <a:off x="6903720" y="1417320"/>
-            <a:ext cx="4480560" cy="1810512"/>
+            <a:ext cx="4480560" cy="2194560"/>
           </a:xfrm>
           <a:prstGeom prst="rect">
             <a:avLst/>
@@ -5615,7 +5615,7 @@
                 <a:ea typeface="Malgun Gothic" pitchFamily="34" charset="-122"/>
                 <a:cs typeface="Malgun Gothic" pitchFamily="34" charset="-120"/>
               </a:rPr>
-              <a:t>거리 증가와 함께 열유입이 누적되며, 30 km를 넘기면 여유가 사라진다.</a:t>
+              <a:t>거리 증가와 함께 열유입이 누적되며, 35 km에서는 아직 IDC 부하를 만족한다.</a:t>
             </a:r>
             <a:endParaRPr lang="en-US" sz="1580" dirty="0"/>
           </a:p>
@@ -5633,7 +5633,7 @@
                 <a:ea typeface="Malgun Gothic" pitchFamily="34" charset="-122"/>
                 <a:cs typeface="Malgun Gothic" pitchFamily="34" charset="-120"/>
               </a:rPr>
-              <a:t>현재 코드 기준 최대 편도 성립거리는 약 29.6 km다.</a:t>
+              <a:t>다만 현재 모델은 부족한 hot-end 환수온도를 supplemental warm-up으로 메우는 부분까지 같이 계산한다.</a:t>
             </a:r>
             <a:endParaRPr lang="en-US" sz="1580" dirty="0"/>
           </a:p>
@@ -5651,7 +5651,25 @@
                 <a:ea typeface="Malgun Gothic" pitchFamily="34" charset="-122"/>
                 <a:cs typeface="Malgun Gothic" pitchFamily="34" charset="-120"/>
               </a:rPr>
-              <a:t>즉 35 km는 기본안의 단순 확장으로는 성립하지 않는다.</a:t>
+              <a:t>현재 코드 기준 최대 편도 성립거리는 약 103.8 km다.</a:t>
+            </a:r>
+            <a:endParaRPr lang="en-US" sz="1580" dirty="0"/>
+          </a:p>
+          <a:p>
+            <a:pPr marL="177800" indent="-177800">
+              <a:buSzPct val="100000"/>
+              <a:buChar char="•"/>
+            </a:pPr>
+            <a:r>
+              <a:rPr lang="en-US" sz="1580" dirty="0">
+                <a:solidFill>
+                  <a:srgbClr val="2C3842"/>
+                </a:solidFill>
+                <a:latin typeface="Malgun Gothic" pitchFamily="34" charset="0"/>
+                <a:ea typeface="Malgun Gothic" pitchFamily="34" charset="-122"/>
+                <a:cs typeface="Malgun Gothic" pitchFamily="34" charset="-120"/>
+              </a:rPr>
+              <a:t>즉 35 km 조건은 현재 기본안에서 성립한다.</a:t>
             </a:r>
             <a:endParaRPr lang="en-US" sz="1580" dirty="0"/>
           </a:p>
@@ -5896,7 +5914,7 @@
                 <a:ea typeface="Malgun Gothic" pitchFamily="34" charset="-122"/>
                 <a:cs typeface="Malgun Gothic" pitchFamily="34" charset="-120"/>
               </a:rPr>
-              <a:t>29.6 km</a:t>
+              <a:t>103.8 km</a:t>
             </a:r>
             <a:endParaRPr lang="en-US" sz="2000" dirty="0"/>
           </a:p>
@@ -5949,8 +5967,8 @@
         </p:nvSpPr>
         <p:spPr>
           <a:xfrm>
-            <a:off x="10469880" y="4572000"/>
-            <a:ext cx="1051560" cy="868680"/>
+            <a:off x="10241280" y="4572000"/>
+            <a:ext cx="1280160" cy="868680"/>
           </a:xfrm>
           <a:prstGeom prst="rect">
             <a:avLst/>
@@ -5960,7 +5978,7 @@
           </a:solidFill>
           <a:ln w="12700">
             <a:solidFill>
-              <a:srgbClr val="A55349"/>
+              <a:srgbClr val="2F7D58"/>
             </a:solidFill>
             <a:prstDash val="solid"/>
           </a:ln>
@@ -5974,8 +5992,8 @@
         </p:nvSpPr>
         <p:spPr>
           <a:xfrm>
-            <a:off x="10597896" y="4663440"/>
-            <a:ext cx="795528" cy="164592"/>
+            <a:off x="10369296" y="4663440"/>
+            <a:ext cx="1024128" cy="164592"/>
           </a:xfrm>
           <a:prstGeom prst="rect">
             <a:avLst/>
@@ -6013,8 +6031,8 @@
         </p:nvSpPr>
         <p:spPr>
           <a:xfrm>
-            <a:off x="10597896" y="4882896"/>
-            <a:ext cx="795528" cy="256032"/>
+            <a:off x="10369296" y="4882896"/>
+            <a:ext cx="1024128" cy="256032"/>
           </a:xfrm>
           <a:prstGeom prst="rect">
             <a:avLst/>
@@ -6038,7 +6056,7 @@
                 <a:ea typeface="Malgun Gothic" pitchFamily="34" charset="-122"/>
                 <a:cs typeface="Malgun Gothic" pitchFamily="34" charset="-120"/>
               </a:rPr>
-              <a:t>불가</a:t>
+              <a:t>성립</a:t>
             </a:r>
             <a:endParaRPr lang="en-US" sz="2000" dirty="0"/>
           </a:p>
@@ -6052,8 +6070,8 @@
         </p:nvSpPr>
         <p:spPr>
           <a:xfrm>
-            <a:off x="10597896" y="5239512"/>
-            <a:ext cx="795528" cy="146304"/>
+            <a:off x="10369296" y="5239512"/>
+            <a:ext cx="1024128" cy="146304"/>
           </a:xfrm>
           <a:prstGeom prst="rect">
             <a:avLst/>
@@ -6418,7 +6436,7 @@
                 <a:ea typeface="Malgun Gothic" pitchFamily="34" charset="-122"/>
                 <a:cs typeface="Malgun Gothic" pitchFamily="34" charset="-120"/>
               </a:rPr>
-              <a:t>가장 효율적인 지점은 220 K 암모니아 기본안이다.</a:t>
+              <a:t>가장 효율적인 지점은 215 K, R-717 (Ammonia) 기본안이다.</a:t>
             </a:r>
             <a:endParaRPr lang="en-US" sz="1580" dirty="0"/>
           </a:p>
@@ -6436,7 +6454,7 @@
                 <a:ea typeface="Malgun Gothic" pitchFamily="34" charset="-122"/>
                 <a:cs typeface="Malgun Gothic" pitchFamily="34" charset="-120"/>
               </a:rPr>
-              <a:t>공급온도를 230 K까지 높이면 35 km 조건을 회복할 수 있다.</a:t>
+              <a:t>현재 기본안만으로도 35 km 조건이 성립한다.</a:t>
             </a:r>
             <a:endParaRPr lang="en-US" sz="1580" dirty="0"/>
           </a:p>
@@ -6454,7 +6472,7 @@
                 <a:ea typeface="Malgun Gothic" pitchFamily="34" charset="-122"/>
                 <a:cs typeface="Malgun Gothic" pitchFamily="34" charset="-120"/>
               </a:rPr>
-              <a:t>하지만 그 과정에서 우선 유체가 R-600a로 바뀌고 펌프동력은 크게 증가한다.</a:t>
+              <a:t>따라서 공급온도 스윕은 거리 복구보다 여유와 펌프동력 변화의 trade-off를 읽는 도구가 된다.</a:t>
             </a:r>
             <a:endParaRPr lang="en-US" sz="1580" dirty="0"/>
           </a:p>
@@ -6472,7 +6490,7 @@
                 <a:ea typeface="Malgun Gothic" pitchFamily="34" charset="-122"/>
                 <a:cs typeface="Malgun Gothic" pitchFamily="34" charset="-120"/>
               </a:rPr>
-              <a:t>즉 거리 회복은 가능하지만 공짜는 아니다.</a:t>
+              <a:t>온도 수준이 바뀌면 유체 선택과 최적 거리 여유도 함께 바뀐다.</a:t>
             </a:r>
             <a:endParaRPr lang="en-US" sz="1580" dirty="0"/>
           </a:p>
@@ -6575,7 +6593,7 @@
                 <a:ea typeface="Malgun Gothic" pitchFamily="34" charset="-122"/>
                 <a:cs typeface="Malgun Gothic" pitchFamily="34" charset="-120"/>
               </a:rPr>
-              <a:t>220 K</a:t>
+              <a:t>215 K</a:t>
             </a:r>
             <a:endParaRPr lang="en-US" sz="2000" dirty="0"/>
           </a:p>
@@ -6628,8 +6646,8 @@
         </p:nvSpPr>
         <p:spPr>
           <a:xfrm>
-            <a:off x="8869680" y="4572000"/>
-            <a:ext cx="1554480" cy="868680"/>
+            <a:off x="8732520" y="4572000"/>
+            <a:ext cx="1691640" cy="868680"/>
           </a:xfrm>
           <a:prstGeom prst="rect">
             <a:avLst/>
@@ -6639,7 +6657,7 @@
           </a:solidFill>
           <a:ln w="12700">
             <a:solidFill>
-              <a:srgbClr val="C89B3C"/>
+              <a:srgbClr val="2F7D58"/>
             </a:solidFill>
             <a:prstDash val="solid"/>
           </a:ln>
@@ -6653,8 +6671,8 @@
         </p:nvSpPr>
         <p:spPr>
           <a:xfrm>
-            <a:off x="8997696" y="4663440"/>
-            <a:ext cx="1298448" cy="164592"/>
+            <a:off x="8860536" y="4663440"/>
+            <a:ext cx="1435608" cy="164592"/>
           </a:xfrm>
           <a:prstGeom prst="rect">
             <a:avLst/>
@@ -6678,7 +6696,7 @@
                 <a:ea typeface="Malgun Gothic" pitchFamily="34" charset="-122"/>
                 <a:cs typeface="Malgun Gothic" pitchFamily="34" charset="-120"/>
               </a:rPr>
-              <a:t>35 km 복구</a:t>
+              <a:t>35 km</a:t>
             </a:r>
             <a:endParaRPr lang="en-US" sz="1050" dirty="0"/>
           </a:p>
@@ -6692,8 +6710,8 @@
         </p:nvSpPr>
         <p:spPr>
           <a:xfrm>
-            <a:off x="8997696" y="4882896"/>
-            <a:ext cx="1298448" cy="256032"/>
+            <a:off x="8860536" y="4882896"/>
+            <a:ext cx="1435608" cy="256032"/>
           </a:xfrm>
           <a:prstGeom prst="rect">
             <a:avLst/>
@@ -6717,7 +6735,7 @@
                 <a:ea typeface="Malgun Gothic" pitchFamily="34" charset="-122"/>
                 <a:cs typeface="Malgun Gothic" pitchFamily="34" charset="-120"/>
               </a:rPr>
-              <a:t>230 K</a:t>
+              <a:t>현재 성립</a:t>
             </a:r>
             <a:endParaRPr lang="en-US" sz="2000" dirty="0"/>
           </a:p>
@@ -6731,8 +6749,8 @@
         </p:nvSpPr>
         <p:spPr>
           <a:xfrm>
-            <a:off x="8997696" y="5239512"/>
-            <a:ext cx="1298448" cy="146304"/>
+            <a:off x="8860536" y="5239512"/>
+            <a:ext cx="1435608" cy="146304"/>
           </a:xfrm>
           <a:prstGeom prst="rect">
             <a:avLst/>
@@ -6756,7 +6774,7 @@
                 <a:ea typeface="Malgun Gothic" pitchFamily="34" charset="-122"/>
                 <a:cs typeface="Malgun Gothic" pitchFamily="34" charset="-120"/>
               </a:rPr>
-              <a:t>R-600a</a:t>
+              <a:t>R-717</a:t>
             </a:r>
             <a:endParaRPr lang="en-US" sz="950" dirty="0"/>
           </a:p>
@@ -6770,7 +6788,7 @@
         </p:nvSpPr>
         <p:spPr>
           <a:xfrm>
-            <a:off x="10698480" y="4572000"/>
+            <a:off x="10652760" y="4572000"/>
             <a:ext cx="868680" cy="868680"/>
           </a:xfrm>
           <a:prstGeom prst="rect">
@@ -6795,7 +6813,7 @@
         </p:nvSpPr>
         <p:spPr>
           <a:xfrm>
-            <a:off x="10826496" y="4663440"/>
+            <a:off x="10780776" y="4663440"/>
             <a:ext cx="612648" cy="164592"/>
           </a:xfrm>
           <a:prstGeom prst="rect">
@@ -6834,7 +6852,7 @@
         </p:nvSpPr>
         <p:spPr>
           <a:xfrm>
-            <a:off x="10826496" y="4882896"/>
+            <a:off x="10780776" y="4882896"/>
             <a:ext cx="612648" cy="256032"/>
           </a:xfrm>
           <a:prstGeom prst="rect">
@@ -6859,7 +6877,7 @@
                 <a:ea typeface="Malgun Gothic" pitchFamily="34" charset="-122"/>
                 <a:cs typeface="Malgun Gothic" pitchFamily="34" charset="-120"/>
               </a:rPr>
-              <a:t>130 kW</a:t>
+              <a:t>17 kW</a:t>
             </a:r>
             <a:endParaRPr lang="en-US" sz="2000" dirty="0"/>
           </a:p>
@@ -6873,7 +6891,7 @@
         </p:nvSpPr>
         <p:spPr>
           <a:xfrm>
-            <a:off x="10826496" y="5239512"/>
+            <a:off x="10780776" y="5239512"/>
             <a:ext cx="612648" cy="146304"/>
           </a:xfrm>
           <a:prstGeom prst="rect">
@@ -6898,7 +6916,7 @@
                 <a:ea typeface="Malgun Gothic" pitchFamily="34" charset="-122"/>
                 <a:cs typeface="Malgun Gothic" pitchFamily="34" charset="-120"/>
               </a:rPr>
-              <a:t>수준</a:t>
+              <a:t>최적점</a:t>
             </a:r>
             <a:endParaRPr lang="en-US" sz="950" dirty="0"/>
           </a:p>
@@ -7257,7 +7275,7 @@
                 <a:ea typeface="Malgun Gothic" pitchFamily="34" charset="-122"/>
                 <a:cs typeface="Malgun Gothic" pitchFamily="34" charset="-120"/>
               </a:rPr>
-              <a:t>LNG 시스템의 직접적 전력 소모는 루프 펌프 13.1 kW 수준이다.</a:t>
+              <a:t>LNG 시스템의 직접적 전력 소모는 루프 펌프 22.2 kW 수준이다.</a:t>
             </a:r>
             <a:endParaRPr lang="en-US" sz="1600" dirty="0"/>
           </a:p>
@@ -7662,7 +7680,7 @@
                 <a:ea typeface="Malgun Gothic" pitchFamily="34" charset="-122"/>
                 <a:cs typeface="Malgun Gothic" pitchFamily="34" charset="-120"/>
               </a:rPr>
-              <a:t>13.1 kW</a:t>
+              <a:t>22.2 kW</a:t>
             </a:r>
             <a:endParaRPr lang="en-US" sz="2000" dirty="0"/>
           </a:p>
@@ -8105,7 +8123,7 @@
                 <a:ea typeface="Malgun Gothic" pitchFamily="34" charset="-122"/>
                 <a:cs typeface="Malgun Gothic" pitchFamily="34" charset="-120"/>
               </a:rPr>
-              <a:t>36,549</a:t>
+              <a:t>36,470.0</a:t>
             </a:r>
             <a:endParaRPr lang="en-US" sz="2000" dirty="0"/>
           </a:p>
@@ -8247,7 +8265,7 @@
                 <a:ea typeface="Malgun Gothic" pitchFamily="34" charset="-122"/>
                 <a:cs typeface="Malgun Gothic" pitchFamily="34" charset="-120"/>
               </a:rPr>
-              <a:t>3,839.5</a:t>
+              <a:t>3,831.2</a:t>
             </a:r>
             <a:endParaRPr lang="en-US" sz="2000" dirty="0"/>
           </a:p>
@@ -8389,7 +8407,7 @@
                 <a:ea typeface="Malgun Gothic" pitchFamily="34" charset="-122"/>
                 <a:cs typeface="Malgun Gothic" pitchFamily="34" charset="-120"/>
               </a:rPr>
-              <a:t>16,757.7</a:t>
+              <a:t>16,721.5</a:t>
             </a:r>
             <a:endParaRPr lang="en-US" sz="2000" dirty="0"/>
           </a:p>
@@ -8531,7 +8549,7 @@
                 <a:ea typeface="Malgun Gothic" pitchFamily="34" charset="-122"/>
                 <a:cs typeface="Malgun Gothic" pitchFamily="34" charset="-120"/>
               </a:rPr>
-              <a:t>19,197.4</a:t>
+              <a:t>19,155.8</a:t>
             </a:r>
             <a:endParaRPr lang="en-US" sz="2000" dirty="0"/>
           </a:p>
@@ -9174,7 +9192,7 @@
                 <a:ea typeface="Malgun Gothic" pitchFamily="34" charset="-122"/>
                 <a:cs typeface="Malgun Gothic" pitchFamily="34" charset="-120"/>
               </a:rPr>
-              <a:t>공급온도 수준 조정</a:t>
+              <a:t>현재 기본안으로도 35 km가 이미 성립한다.</a:t>
             </a:r>
             <a:endParaRPr lang="en-US" sz="1400" dirty="0"/>
           </a:p>
@@ -9191,7 +9209,7 @@
                 <a:ea typeface="Malgun Gothic" pitchFamily="34" charset="-122"/>
                 <a:cs typeface="Malgun Gothic" pitchFamily="34" charset="-120"/>
               </a:rPr>
-              <a:t>유체 변경(R-600a 방향)</a:t>
+              <a:t>다만 추가 거리 여유 확보는 별도 최적화 문제다.</a:t>
             </a:r>
             <a:endParaRPr lang="en-US" sz="1400" dirty="0"/>
           </a:p>
@@ -9208,7 +9226,7 @@
                 <a:ea typeface="Malgun Gothic" pitchFamily="34" charset="-122"/>
                 <a:cs typeface="Malgun Gothic" pitchFamily="34" charset="-120"/>
               </a:rPr>
-              <a:t>펌프동력 증가 수용</a:t>
+              <a:t>열유입 여유와 펌프동력 증가는 계속 trade-off다.</a:t>
             </a:r>
             <a:endParaRPr lang="en-US" sz="1400" dirty="0"/>
           </a:p>
@@ -9248,7 +9266,7 @@
                 <a:ea typeface="Malgun Gothic" pitchFamily="34" charset="-122"/>
                 <a:cs typeface="Malgun Gothic" pitchFamily="34" charset="-120"/>
               </a:rPr>
-              <a:t>즉 35 km는 기본안이 아니라 별도 설계 과제로 보는 편이 타당하다.</a:t>
+              <a:t>즉 35 km는 이제 기준안의 성립 영역 안에 들어오지만, 그 이상 확장은 여전히 설계 과제다.</a:t>
             </a:r>
             <a:endParaRPr lang="en-US" sz="1400" dirty="0"/>
           </a:p>
@@ -10676,7 +10694,7 @@
                 <a:ea typeface="Malgun Gothic" pitchFamily="34" charset="-122"/>
                 <a:cs typeface="Malgun Gothic" pitchFamily="34" charset="-120"/>
               </a:rPr>
-              <a:t>35 km는 기본안의 단순 연장이 아니라 별도 최적화가 필요한 확장 조건이다.</a:t>
+              <a:t>IDC 측 HX와 LNG hot-end 제약을 함께 풀면 35 km도 현재 기본안에서 성립한다.</a:t>
             </a:r>
             <a:endParaRPr lang="en-US" sz="1400" dirty="0"/>
           </a:p>
@@ -10693,7 +10711,7 @@
                 <a:ea typeface="Malgun Gothic" pitchFamily="34" charset="-122"/>
                 <a:cs typeface="Malgun Gothic" pitchFamily="34" charset="-120"/>
               </a:rPr>
-              <a:t>따라서 이번 프로젝트의 진짜 메시지는 ‘가능/불가능의 경계’를 찾았다는 데 있다.</a:t>
+              <a:t>따라서 이번 재구축의 메시지는 기존보다 완화된 실제 성립영역을 재계산했다는 데 있다.</a:t>
             </a:r>
             <a:endParaRPr lang="en-US" sz="1400" dirty="0"/>
           </a:p>
@@ -10938,7 +10956,7 @@
                 <a:ea typeface="Malgun Gothic" pitchFamily="34" charset="-122"/>
                 <a:cs typeface="Malgun Gothic" pitchFamily="34" charset="-120"/>
               </a:rPr>
-              <a:t>29.6 km</a:t>
+              <a:t>103.8 km</a:t>
             </a:r>
             <a:endParaRPr lang="en-US" sz="2000" dirty="0"/>
           </a:p>
@@ -11002,7 +11020,7 @@
           </a:solidFill>
           <a:ln w="12700">
             <a:solidFill>
-              <a:srgbClr val="A55349"/>
+              <a:srgbClr val="2F7D58"/>
             </a:solidFill>
             <a:prstDash val="solid"/>
           </a:ln>
@@ -11080,7 +11098,7 @@
                 <a:ea typeface="Malgun Gothic" pitchFamily="34" charset="-122"/>
                 <a:cs typeface="Malgun Gothic" pitchFamily="34" charset="-120"/>
               </a:rPr>
-              <a:t>35 km는 운전점 변경 필요</a:t>
+              <a:t>35 km 기본안 성립</a:t>
             </a:r>
             <a:endParaRPr lang="en-US" sz="2000" dirty="0"/>
           </a:p>
@@ -11119,7 +11137,7 @@
                 <a:ea typeface="Malgun Gothic" pitchFamily="34" charset="-122"/>
                 <a:cs typeface="Malgun Gothic" pitchFamily="34" charset="-120"/>
               </a:rPr>
-              <a:t>기본안 불성립</a:t>
+              <a:t>현재 설계 가능</a:t>
             </a:r>
             <a:endParaRPr lang="en-US" sz="950" dirty="0"/>
           </a:p>
@@ -15042,7 +15060,7 @@
         <p:spPr>
           <a:xfrm>
             <a:off x="6903720" y="1463040"/>
-            <a:ext cx="4480560" cy="1426464"/>
+            <a:ext cx="4480560" cy="1810512"/>
           </a:xfrm>
           <a:prstGeom prst="rect">
             <a:avLst/>
@@ -15104,6 +15122,24 @@
                 <a:cs typeface="Malgun Gothic" pitchFamily="34" charset="-120"/>
               </a:rPr>
               <a:t>프로판과 이소부탄도 후보로 남지만, 펌프동력과 전체 설계성에서 밀린다.</a:t>
+            </a:r>
+            <a:endParaRPr lang="en-US" sz="1650" dirty="0"/>
+          </a:p>
+          <a:p>
+            <a:pPr marL="177800" indent="-177800">
+              <a:buSzPct val="100000"/>
+              <a:buChar char="•"/>
+            </a:pPr>
+            <a:r>
+              <a:rPr lang="en-US" sz="1650" dirty="0">
+                <a:solidFill>
+                  <a:srgbClr val="2C3842"/>
+                </a:solidFill>
+                <a:latin typeface="Malgun Gothic" pitchFamily="34" charset="0"/>
+                <a:ea typeface="Malgun Gothic" pitchFamily="34" charset="-122"/>
+                <a:cs typeface="Malgun Gothic" pitchFamily="34" charset="-120"/>
+              </a:rPr>
+              <a:t>또한 현재 기준점에서는 상위 3개 유체 모두 LNG hot-end 조건 때문에 추가 warm-up 요구량이 남는다.</a:t>
             </a:r>
             <a:endParaRPr lang="en-US" sz="1650" dirty="0"/>
           </a:p>
@@ -15206,7 +15242,7 @@
                 <a:ea typeface="Malgun Gothic" pitchFamily="34" charset="-122"/>
                 <a:cs typeface="Malgun Gothic" pitchFamily="34" charset="-120"/>
               </a:rPr>
-              <a:t>R-717</a:t>
+              <a:t>R-717 (Ammonia)</a:t>
             </a:r>
             <a:endParaRPr lang="en-US" sz="2000" dirty="0"/>
           </a:p>
@@ -15245,7 +15281,7 @@
                 <a:ea typeface="Malgun Gothic" pitchFamily="34" charset="-122"/>
                 <a:cs typeface="Malgun Gothic" pitchFamily="34" charset="-120"/>
               </a:rPr>
-              <a:t>13.1 kW</a:t>
+              <a:t>22.2 kW</a:t>
             </a:r>
             <a:endParaRPr lang="en-US" sz="950" dirty="0"/>
           </a:p>
@@ -15348,7 +15384,7 @@
                 <a:ea typeface="Malgun Gothic" pitchFamily="34" charset="-122"/>
                 <a:cs typeface="Malgun Gothic" pitchFamily="34" charset="-120"/>
               </a:rPr>
-              <a:t>R-290</a:t>
+              <a:t>R-290 (Propane)</a:t>
             </a:r>
             <a:endParaRPr lang="en-US" sz="2000" dirty="0"/>
           </a:p>
@@ -15387,7 +15423,7 @@
                 <a:ea typeface="Malgun Gothic" pitchFamily="34" charset="-122"/>
                 <a:cs typeface="Malgun Gothic" pitchFamily="34" charset="-120"/>
               </a:rPr>
-              <a:t>124.9 kW</a:t>
+              <a:t>220.5 kW</a:t>
             </a:r>
             <a:endParaRPr lang="en-US" sz="950" dirty="0"/>
           </a:p>
@@ -15490,7 +15526,7 @@
                 <a:ea typeface="Malgun Gothic" pitchFamily="34" charset="-122"/>
                 <a:cs typeface="Malgun Gothic" pitchFamily="34" charset="-120"/>
               </a:rPr>
-              <a:t>R-600a</a:t>
+              <a:t>R-600a (Isobutane)</a:t>
             </a:r>
             <a:endParaRPr lang="en-US" sz="2000" dirty="0"/>
           </a:p>
@@ -15529,7 +15565,7 @@
                 <a:ea typeface="Malgun Gothic" pitchFamily="34" charset="-122"/>
                 <a:cs typeface="Malgun Gothic" pitchFamily="34" charset="-120"/>
               </a:rPr>
-              <a:t>134.5 kW</a:t>
+              <a:t>235.2 kW</a:t>
             </a:r>
             <a:endParaRPr lang="en-US" sz="950" dirty="0"/>
           </a:p>
@@ -15870,7 +15906,7 @@
                 <a:ea typeface="Malgun Gothic" pitchFamily="34" charset="-122"/>
                 <a:cs typeface="Malgun Gothic" pitchFamily="34" charset="-120"/>
               </a:rPr>
-              <a:t>R-717</a:t>
+              <a:t>R-717 (Ammonia)</a:t>
             </a:r>
             <a:endParaRPr lang="en-US" sz="2000" dirty="0"/>
           </a:p>
@@ -15909,7 +15945,7 @@
                 <a:ea typeface="Malgun Gothic" pitchFamily="34" charset="-122"/>
                 <a:cs typeface="Malgun Gothic" pitchFamily="34" charset="-120"/>
               </a:rPr>
-              <a:t>암모니아</a:t>
+              <a:t>기본안</a:t>
             </a:r>
             <a:endParaRPr lang="en-US" sz="950" dirty="0"/>
           </a:p>
@@ -16012,7 +16048,7 @@
                 <a:ea typeface="Malgun Gothic" pitchFamily="34" charset="-122"/>
                 <a:cs typeface="Malgun Gothic" pitchFamily="34" charset="-120"/>
               </a:rPr>
-              <a:t>220 K</a:t>
+              <a:t>215 K</a:t>
             </a:r>
             <a:endParaRPr lang="en-US" sz="2000" dirty="0"/>
           </a:p>
@@ -16051,7 +16087,7 @@
                 <a:ea typeface="Malgun Gothic" pitchFamily="34" charset="-122"/>
                 <a:cs typeface="Malgun Gothic" pitchFamily="34" charset="-120"/>
               </a:rPr>
-              <a:t>코드 기준</a:t>
+              <a:t>스윕 최적점</a:t>
             </a:r>
             <a:endParaRPr lang="en-US" sz="950" dirty="0"/>
           </a:p>
@@ -16154,7 +16190,7 @@
                 <a:ea typeface="Malgun Gothic" pitchFamily="34" charset="-122"/>
                 <a:cs typeface="Malgun Gothic" pitchFamily="34" charset="-120"/>
               </a:rPr>
-              <a:t>13.1 kW</a:t>
+              <a:t>22.2 kW</a:t>
             </a:r>
             <a:endParaRPr lang="en-US" sz="2000" dirty="0"/>
           </a:p>
@@ -16193,7 +16229,7 @@
                 <a:ea typeface="Malgun Gothic" pitchFamily="34" charset="-122"/>
                 <a:cs typeface="Malgun Gothic" pitchFamily="34" charset="-120"/>
               </a:rPr>
-              <a:t>최저 수준</a:t>
+              <a:t>현재 결과</a:t>
             </a:r>
             <a:endParaRPr lang="en-US" sz="950" dirty="0"/>
           </a:p>
@@ -16450,6 +16486,23 @@
                 <a:ea typeface="Malgun Gothic" pitchFamily="34" charset="-122"/>
                 <a:cs typeface="Malgun Gothic" pitchFamily="34" charset="-120"/>
               </a:rPr>
+              <a:t>현재 기준점에서는 LNG hot-end를 맞추기 위해 3,954.0 kW의 추가 warm-up 모델이 필요하다.</a:t>
+            </a:r>
+            <a:endParaRPr lang="en-US" sz="1400" dirty="0"/>
+          </a:p>
+          <a:p>
+            <a:pPr indent="0" marL="0">
+              <a:buNone/>
+            </a:pPr>
+            <a:r>
+              <a:rPr lang="en-US" sz="1400" dirty="0">
+                <a:solidFill>
+                  <a:srgbClr val="2C3842"/>
+                </a:solidFill>
+                <a:latin typeface="Malgun Gothic" pitchFamily="34" charset="0"/>
+                <a:ea typeface="Malgun Gothic" pitchFamily="34" charset="-122"/>
+                <a:cs typeface="Malgun Gothic" pitchFamily="34" charset="-120"/>
+              </a:rPr>
               <a:t>따라서 최종 설계에서는 성능 우위와 안전/운전 서술을 함께 가져가야 한다.</a:t>
             </a:r>
             <a:endParaRPr lang="en-US" sz="1400" dirty="0"/>
@@ -16467,7 +16520,7 @@
                 <a:ea typeface="Malgun Gothic" pitchFamily="34" charset="-122"/>
                 <a:cs typeface="Malgun Gothic" pitchFamily="34" charset="-120"/>
               </a:rPr>
-              <a:t>즉 성능은 암모니아가, 커뮤니케이션 난이도는 탄화수소가 낮다.</a:t>
+              <a:t>즉 성능은 암모니아가, 시스템 단순성은 추가 검토가 더 필요하다.</a:t>
             </a:r>
             <a:endParaRPr lang="en-US" sz="1400" dirty="0"/>
           </a:p>
@@ -16965,7 +17018,7 @@
                 <a:ea typeface="Malgun Gothic" pitchFamily="34" charset="-122"/>
                 <a:cs typeface="Malgun Gothic" pitchFamily="34" charset="-120"/>
               </a:rPr>
-              <a:t>14.97 MW</a:t>
+              <a:t>18,010.5 kW</a:t>
             </a:r>
             <a:endParaRPr lang="en-US" sz="2000" dirty="0"/>
           </a:p>

</xml_diff>

<commit_message>
Add ambient-only closure analysis
</commit_message>
<xml_diff>
--- a/deliverables/presentation_draft.pptx
+++ b/deliverables/presentation_draft.pptx
@@ -6436,7 +6436,7 @@
                 <a:ea typeface="Malgun Gothic" pitchFamily="34" charset="-122"/>
                 <a:cs typeface="Malgun Gothic" pitchFamily="34" charset="-120"/>
               </a:rPr>
-              <a:t>가장 효율적인 지점은 215 K, R-717 (Ammonia) 기본안이다.</a:t>
+              <a:t>가장 효율적인 지점은 210 K, R-717 (Ammonia) 기본안이다.</a:t>
             </a:r>
             <a:endParaRPr lang="en-US" sz="1580" dirty="0"/>
           </a:p>
@@ -6593,7 +6593,7 @@
                 <a:ea typeface="Malgun Gothic" pitchFamily="34" charset="-122"/>
                 <a:cs typeface="Malgun Gothic" pitchFamily="34" charset="-120"/>
               </a:rPr>
-              <a:t>215 K</a:t>
+              <a:t>210 K</a:t>
             </a:r>
             <a:endParaRPr lang="en-US" sz="2000" dirty="0"/>
           </a:p>
@@ -6877,7 +6877,7 @@
                 <a:ea typeface="Malgun Gothic" pitchFamily="34" charset="-122"/>
                 <a:cs typeface="Malgun Gothic" pitchFamily="34" charset="-120"/>
               </a:rPr>
-              <a:t>17 kW</a:t>
+              <a:t>14 kW</a:t>
             </a:r>
             <a:endParaRPr lang="en-US" sz="2000" dirty="0"/>
           </a:p>
@@ -16048,7 +16048,7 @@
                 <a:ea typeface="Malgun Gothic" pitchFamily="34" charset="-122"/>
                 <a:cs typeface="Malgun Gothic" pitchFamily="34" charset="-120"/>
               </a:rPr>
-              <a:t>215 K</a:t>
+              <a:t>210 K</a:t>
             </a:r>
             <a:endParaRPr lang="en-US" sz="2000" dirty="0"/>
           </a:p>

</xml_diff>

<commit_message>
Sync deliverables with hybrid and practical findings
</commit_message>
<xml_diff>
--- a/deliverables/presentation_draft.pptx
+++ b/deliverables/presentation_draft.pptx
@@ -6411,7 +6411,7 @@
         <p:spPr>
           <a:xfrm>
             <a:off x="6903720" y="1417320"/>
-            <a:ext cx="4480560" cy="1810512"/>
+            <a:ext cx="4480560" cy="2194560"/>
           </a:xfrm>
           <a:prstGeom prst="rect">
             <a:avLst/>
@@ -6473,6 +6473,24 @@
                 <a:cs typeface="Malgun Gothic" pitchFamily="34" charset="-120"/>
               </a:rPr>
               <a:t>따라서 공급온도 스윕은 거리 복구보다 여유와 펌프동력 변화의 trade-off를 읽는 도구가 된다.</a:t>
+            </a:r>
+            <a:endParaRPr lang="en-US" sz="1580" dirty="0"/>
+          </a:p>
+          <a:p>
+            <a:pPr marL="177800" indent="-177800">
+              <a:buSzPct val="100000"/>
+              <a:buChar char="•"/>
+            </a:pPr>
+            <a:r>
+              <a:rPr lang="en-US" sz="1580" dirty="0">
+                <a:solidFill>
+                  <a:srgbClr val="2C3842"/>
+                </a:solidFill>
+                <a:latin typeface="Malgun Gothic" pitchFamily="34" charset="0"/>
+                <a:ea typeface="Malgun Gothic" pitchFamily="34" charset="-122"/>
+                <a:cs typeface="Malgun Gothic" pitchFamily="34" charset="-120"/>
+              </a:rPr>
+              <a:t>다만 현실성 필터를 거치면 현재는 채택 가능한 무보조 해가 남지 않는다.</a:t>
             </a:r>
             <a:endParaRPr lang="en-US" sz="1580" dirty="0"/>
           </a:p>
@@ -7232,7 +7250,7 @@
         <p:spPr>
           <a:xfrm>
             <a:off x="6858000" y="1417320"/>
-            <a:ext cx="4572000" cy="1426464"/>
+            <a:ext cx="4572000" cy="1810512"/>
           </a:xfrm>
           <a:prstGeom prst="rect">
             <a:avLst/>
@@ -7276,6 +7294,24 @@
                 <a:cs typeface="Malgun Gothic" pitchFamily="34" charset="-120"/>
               </a:rPr>
               <a:t>LNG 시스템의 직접적 전력 소모는 루프 펌프 22.2 kW 수준이다.</a:t>
+            </a:r>
+            <a:endParaRPr lang="en-US" sz="1600" dirty="0"/>
+          </a:p>
+          <a:p>
+            <a:pPr marL="177800" indent="-177800">
+              <a:buSzPct val="100000"/>
+              <a:buChar char="•"/>
+            </a:pPr>
+            <a:r>
+              <a:rPr lang="en-US" sz="1600" dirty="0">
+                <a:solidFill>
+                  <a:srgbClr val="2C3842"/>
+                </a:solidFill>
+                <a:latin typeface="Malgun Gothic" pitchFamily="34" charset="0"/>
+                <a:ea typeface="Malgun Gothic" pitchFamily="34" charset="-122"/>
+                <a:cs typeface="Malgun Gothic" pitchFamily="34" charset="-120"/>
+              </a:rPr>
+              <a:t>보조 열원이 남는다면 현재 시나리오 중 최선은 Waste-heat recovery loop이며 총 시스템 동력은 71.7 kW다.</a:t>
             </a:r>
             <a:endParaRPr lang="en-US" sz="1600" dirty="0"/>
           </a:p>
@@ -8692,6 +8728,23 @@
                 <a:cs typeface="Malgun Gothic" pitchFamily="34" charset="-120"/>
               </a:rPr>
               <a:t>현재 연간 효과는 기준 압축기 동력과 LNG 루프 펌프동력만 비교한 경계조건 결과다.</a:t>
+            </a:r>
+            <a:endParaRPr lang="en-US" sz="1400" dirty="0"/>
+          </a:p>
+          <a:p>
+            <a:pPr indent="0" marL="0">
+              <a:buNone/>
+            </a:pPr>
+            <a:r>
+              <a:rPr lang="en-US" sz="1400" dirty="0">
+                <a:solidFill>
+                  <a:srgbClr val="2C3842"/>
+                </a:solidFill>
+                <a:latin typeface="Malgun Gothic" pitchFamily="34" charset="0"/>
+                <a:ea typeface="Malgun Gothic" pitchFamily="34" charset="-122"/>
+                <a:cs typeface="Malgun Gothic" pitchFamily="34" charset="-120"/>
+              </a:rPr>
+              <a:t>하이브리드 보조 열원은 별도 시나리오 테이블로 해석한다.</a:t>
             </a:r>
             <a:endParaRPr lang="en-US" sz="1400" dirty="0"/>
           </a:p>

</xml_diff>

<commit_message>
Sync deliverables with mixed LNG and project economics
</commit_message>
<xml_diff>
--- a/deliverables/presentation_draft.pptx
+++ b/deliverables/presentation_draft.pptx
@@ -7293,7 +7293,7 @@
                 <a:ea typeface="Malgun Gothic" pitchFamily="34" charset="-122"/>
                 <a:cs typeface="Malgun Gothic" pitchFamily="34" charset="-120"/>
               </a:rPr>
-              <a:t>LNG 시스템의 직접적 전력 소모는 루프 펌프 22.2 kW 수준이다.</a:t>
+              <a:t>LNG 시스템의 핵심 전동부하는 외부 루프 22.2 kW와 IDC 2차 루프 123.7 kW를 합한 145.9 kW 수준이다.</a:t>
             </a:r>
             <a:endParaRPr lang="en-US" sz="1600" dirty="0"/>
           </a:p>
@@ -7311,7 +7311,7 @@
                 <a:ea typeface="Malgun Gothic" pitchFamily="34" charset="-122"/>
                 <a:cs typeface="Malgun Gothic" pitchFamily="34" charset="-120"/>
               </a:rPr>
-              <a:t>보조 열원이 남는다면 현재 시나리오 중 최선은 Waste-heat recovery loop이며 총 시스템 동력은 71.7 kW다.</a:t>
+              <a:t>보조 열원이 남는다면 현재 시나리오 중 최선은 Waste-heat recovery loop이며 총 시스템 동력은 195.4 kW다.</a:t>
             </a:r>
             <a:endParaRPr lang="en-US" sz="1600" dirty="0"/>
           </a:p>
@@ -7627,8 +7627,8 @@
         </p:nvSpPr>
         <p:spPr>
           <a:xfrm>
-            <a:off x="10607040" y="4526280"/>
-            <a:ext cx="868680" cy="868680"/>
+            <a:off x="10378440" y="4526280"/>
+            <a:ext cx="1097280" cy="868680"/>
           </a:xfrm>
           <a:prstGeom prst="rect">
             <a:avLst/>
@@ -7652,8 +7652,8 @@
         </p:nvSpPr>
         <p:spPr>
           <a:xfrm>
-            <a:off x="10735056" y="4617720"/>
-            <a:ext cx="612648" cy="164592"/>
+            <a:off x="10506456" y="4617720"/>
+            <a:ext cx="841248" cy="164592"/>
           </a:xfrm>
           <a:prstGeom prst="rect">
             <a:avLst/>
@@ -7691,8 +7691,8 @@
         </p:nvSpPr>
         <p:spPr>
           <a:xfrm>
-            <a:off x="10735056" y="4837176"/>
-            <a:ext cx="612648" cy="256032"/>
+            <a:off x="10506456" y="4837176"/>
+            <a:ext cx="841248" cy="256032"/>
           </a:xfrm>
           <a:prstGeom prst="rect">
             <a:avLst/>
@@ -7716,7 +7716,7 @@
                 <a:ea typeface="Malgun Gothic" pitchFamily="34" charset="-122"/>
                 <a:cs typeface="Malgun Gothic" pitchFamily="34" charset="-120"/>
               </a:rPr>
-              <a:t>22.2 kW</a:t>
+              <a:t>145.9 kW</a:t>
             </a:r>
             <a:endParaRPr lang="en-US" sz="2000" dirty="0"/>
           </a:p>
@@ -7730,8 +7730,8 @@
         </p:nvSpPr>
         <p:spPr>
           <a:xfrm>
-            <a:off x="10735056" y="5193792"/>
-            <a:ext cx="612648" cy="146304"/>
+            <a:off x="10506456" y="5193792"/>
+            <a:ext cx="841248" cy="146304"/>
           </a:xfrm>
           <a:prstGeom prst="rect">
             <a:avLst/>
@@ -7755,7 +7755,7 @@
                 <a:ea typeface="Malgun Gothic" pitchFamily="34" charset="-122"/>
                 <a:cs typeface="Malgun Gothic" pitchFamily="34" charset="-120"/>
               </a:rPr>
-              <a:t>루프</a:t>
+              <a:t>core</a:t>
             </a:r>
             <a:endParaRPr lang="en-US" sz="950" dirty="0"/>
           </a:p>
@@ -7794,7 +7794,7 @@
                 <a:ea typeface="Malgun Gothic" pitchFamily="34" charset="-122"/>
                 <a:cs typeface="Malgun Gothic" pitchFamily="34" charset="-120"/>
               </a:rPr>
-              <a:t>비교 경계는 기준 압축기 대비 LNG 루프 펌프동력</a:t>
+              <a:t>비교 경계는 기준 압축기 대비 core LNG system power</a:t>
             </a:r>
             <a:endParaRPr lang="en-US" sz="850" dirty="0"/>
           </a:p>
@@ -8159,7 +8159,7 @@
                 <a:ea typeface="Malgun Gothic" pitchFamily="34" charset="-122"/>
                 <a:cs typeface="Malgun Gothic" pitchFamily="34" charset="-120"/>
               </a:rPr>
-              <a:t>36,470.0</a:t>
+              <a:t>35,386.6</a:t>
             </a:r>
             <a:endParaRPr lang="en-US" sz="2000" dirty="0"/>
           </a:p>
@@ -8301,7 +8301,7 @@
                 <a:ea typeface="Malgun Gothic" pitchFamily="34" charset="-122"/>
                 <a:cs typeface="Malgun Gothic" pitchFamily="34" charset="-120"/>
               </a:rPr>
-              <a:t>3,831.2</a:t>
+              <a:t>3,717.4</a:t>
             </a:r>
             <a:endParaRPr lang="en-US" sz="2000" dirty="0"/>
           </a:p>
@@ -8443,7 +8443,7 @@
                 <a:ea typeface="Malgun Gothic" pitchFamily="34" charset="-122"/>
                 <a:cs typeface="Malgun Gothic" pitchFamily="34" charset="-120"/>
               </a:rPr>
-              <a:t>16,721.5</a:t>
+              <a:t>16,224.7</a:t>
             </a:r>
             <a:endParaRPr lang="en-US" sz="2000" dirty="0"/>
           </a:p>
@@ -8546,7 +8546,7 @@
                 <a:ea typeface="Malgun Gothic" pitchFamily="34" charset="-122"/>
                 <a:cs typeface="Malgun Gothic" pitchFamily="34" charset="-120"/>
               </a:rPr>
-              <a:t>5년 허용 CAPEX</a:t>
+              <a:t>Core CAPEX</a:t>
             </a:r>
             <a:endParaRPr lang="en-US" sz="1050" dirty="0"/>
           </a:p>
@@ -8585,7 +8585,7 @@
                 <a:ea typeface="Malgun Gothic" pitchFamily="34" charset="-122"/>
                 <a:cs typeface="Malgun Gothic" pitchFamily="34" charset="-120"/>
               </a:rPr>
-              <a:t>19,155.8</a:t>
+              <a:t>66.12</a:t>
             </a:r>
             <a:endParaRPr lang="en-US" sz="2000" dirty="0"/>
           </a:p>
@@ -8624,7 +8624,7 @@
                 <a:ea typeface="Malgun Gothic" pitchFamily="34" charset="-122"/>
                 <a:cs typeface="Malgun Gothic" pitchFamily="34" charset="-120"/>
               </a:rPr>
-              <a:t>백만원</a:t>
+              <a:t>십억원</a:t>
             </a:r>
             <a:endParaRPr lang="en-US" sz="950" dirty="0"/>
           </a:p>
@@ -8727,7 +8727,7 @@
                 <a:ea typeface="Malgun Gothic" pitchFamily="34" charset="-122"/>
                 <a:cs typeface="Malgun Gothic" pitchFamily="34" charset="-120"/>
               </a:rPr>
-              <a:t>현재 연간 효과는 기준 압축기 동력과 LNG 루프 펌프동력만 비교한 경계조건 결과다.</a:t>
+              <a:t>현재 core-system NPV는 -42.61 십억원으로, 장거리 외부 배관 CAPEX가 매우 크게 작용한다.</a:t>
             </a:r>
             <a:endParaRPr lang="en-US" sz="1400" dirty="0"/>
           </a:p>
@@ -8744,7 +8744,7 @@
                 <a:ea typeface="Malgun Gothic" pitchFamily="34" charset="-122"/>
                 <a:cs typeface="Malgun Gothic" pitchFamily="34" charset="-120"/>
               </a:rPr>
-              <a:t>하이브리드 보조 열원은 별도 시나리오 테이블로 해석한다.</a:t>
+              <a:t>하이브리드 보조 열원은 별도 시나리오 테이블로 해석하고, 추가 CAPEX는 아직 보수적으로 제외했다.</a:t>
             </a:r>
             <a:endParaRPr lang="en-US" sz="1400" dirty="0"/>
           </a:p>
@@ -8783,7 +8783,7 @@
                 <a:ea typeface="Malgun Gothic" pitchFamily="34" charset="-122"/>
                 <a:cs typeface="Malgun Gothic" pitchFamily="34" charset="-120"/>
               </a:rPr>
-              <a:t>현재 버전은 보조기기·유지관리·금융비용을 아직 제외</a:t>
+              <a:t>현재 버전은 core-system CAPEX와 단순 O&amp;M/금융비용까지 포함</a:t>
             </a:r>
             <a:endParaRPr lang="en-US" sz="850" dirty="0"/>
           </a:p>
@@ -9142,7 +9142,7 @@
                 <a:ea typeface="Malgun Gothic" pitchFamily="34" charset="-122"/>
                 <a:cs typeface="Malgun Gothic" pitchFamily="34" charset="-120"/>
               </a:rPr>
-              <a:t>이번 코드 v1은 순수 메탄 가정과 단순화된 IDC 경계조건을 사용했다.</a:t>
+              <a:t>이번 코드 v2는 혼합 LNG surrogate와 IDC 2차 루프 등가 유압모델까지 포함한다.</a:t>
             </a:r>
             <a:endParaRPr lang="en-US" sz="1400" dirty="0"/>
           </a:p>
@@ -16204,7 +16204,7 @@
                 <a:ea typeface="Malgun Gothic" pitchFamily="34" charset="-122"/>
                 <a:cs typeface="Malgun Gothic" pitchFamily="34" charset="-120"/>
               </a:rPr>
-              <a:t>루프 펌프동력</a:t>
+              <a:t>Core system power</a:t>
             </a:r>
             <a:endParaRPr lang="en-US" sz="1050" dirty="0"/>
           </a:p>
@@ -16243,7 +16243,7 @@
                 <a:ea typeface="Malgun Gothic" pitchFamily="34" charset="-122"/>
                 <a:cs typeface="Malgun Gothic" pitchFamily="34" charset="-120"/>
               </a:rPr>
-              <a:t>22.2 kW</a:t>
+              <a:t>145.9 kW</a:t>
             </a:r>
             <a:endParaRPr lang="en-US" sz="2000" dirty="0"/>
           </a:p>
@@ -16914,7 +16914,7 @@
                 <a:ea typeface="Malgun Gothic" pitchFamily="34" charset="-122"/>
                 <a:cs typeface="Malgun Gothic" pitchFamily="34" charset="-120"/>
               </a:rPr>
-              <a:t>7 MPa 초임계 메탄의 비열은 온도에 따라 크게 변한다.</a:t>
+              <a:t>7 MPa 혼합 LNG surrogate의 유효 엔탈피 변화는 온도에 따라 크게 달라진다.</a:t>
             </a:r>
             <a:endParaRPr lang="en-US" sz="1550" dirty="0"/>
           </a:p>

</xml_diff>

<commit_message>
Clarify hybrid feasibility and core power accounting
</commit_message>
<xml_diff>
--- a/deliverables/presentation_draft.pptx
+++ b/deliverables/presentation_draft.pptx
@@ -5597,7 +5597,7 @@
                 <a:ea typeface="Malgun Gothic" pitchFamily="34" charset="-122"/>
                 <a:cs typeface="Malgun Gothic" pitchFamily="34" charset="-120"/>
               </a:rPr>
-              <a:t>기본 10 km에서는 충분한 열여유가 남는다.</a:t>
+              <a:t>기본 5 km 조건은 하이브리드 운전으로는 성립하지만 supplemental warm-up이 필요하다.</a:t>
             </a:r>
             <a:endParaRPr lang="en-US" sz="1580" dirty="0"/>
           </a:p>
@@ -5615,7 +5615,7 @@
                 <a:ea typeface="Malgun Gothic" pitchFamily="34" charset="-122"/>
                 <a:cs typeface="Malgun Gothic" pitchFamily="34" charset="-120"/>
               </a:rPr>
-              <a:t>거리 증가와 함께 열유입이 누적되며, 35 km에서는 아직 IDC 부하를 만족한다.</a:t>
+              <a:t>거리 증가와 함께 열유입이 누적되며, 35 km에서는 유압/상태 해는 유지된다.</a:t>
             </a:r>
             <a:endParaRPr lang="en-US" sz="1580" dirty="0"/>
           </a:p>
@@ -5651,7 +5651,7 @@
                 <a:ea typeface="Malgun Gothic" pitchFamily="34" charset="-122"/>
                 <a:cs typeface="Malgun Gothic" pitchFamily="34" charset="-120"/>
               </a:rPr>
-              <a:t>현재 코드 기준 최대 편도 성립거리는 약 103.8 km다.</a:t>
+              <a:t>현재 코드 기준 최대 하이브리드 편도 성립거리는 약 103.8 km이고, 기본 LNG duty 기준 최대 성립거리는 약 0.0 km다.</a:t>
             </a:r>
             <a:endParaRPr lang="en-US" sz="1580" dirty="0"/>
           </a:p>
@@ -5669,7 +5669,7 @@
                 <a:ea typeface="Malgun Gothic" pitchFamily="34" charset="-122"/>
                 <a:cs typeface="Malgun Gothic" pitchFamily="34" charset="-120"/>
               </a:rPr>
-              <a:t>즉 35 km 조건은 현재 기본안에서 성립한다.</a:t>
+              <a:t>즉 35 km 조건은 하이브리드 성립이지만 기본 LNG duty는 불성립이다.</a:t>
             </a:r>
             <a:endParaRPr lang="en-US" sz="1580" dirty="0"/>
           </a:p>
@@ -5685,148 +5685,6 @@
           <a:xfrm>
             <a:off x="7040880" y="4572000"/>
             <a:ext cx="1417320" cy="868680"/>
-          </a:xfrm>
-          <a:prstGeom prst="rect">
-            <a:avLst/>
-          </a:prstGeom>
-          <a:solidFill>
-            <a:srgbClr val="FFFFFF"/>
-          </a:solidFill>
-          <a:ln w="12700">
-            <a:solidFill>
-              <a:srgbClr val="2F7D58"/>
-            </a:solidFill>
-            <a:prstDash val="solid"/>
-          </a:ln>
-        </p:spPr>
-      </p:sp>
-      <p:sp>
-        <p:nvSpPr>
-          <p:cNvPr id="11" name="Text 8"/>
-          <p:cNvSpPr/>
-          <p:nvPr/>
-        </p:nvSpPr>
-        <p:spPr>
-          <a:xfrm>
-            <a:off x="7168896" y="4663440"/>
-            <a:ext cx="1161288" cy="164592"/>
-          </a:xfrm>
-          <a:prstGeom prst="rect">
-            <a:avLst/>
-          </a:prstGeom>
-          <a:noFill/>
-          <a:ln/>
-        </p:spPr>
-        <p:txBody>
-          <a:bodyPr wrap="square" rtlCol="0" anchor="ctr"/>
-          <a:lstStyle/>
-          <a:p>
-            <a:pPr indent="0" marL="0">
-              <a:buNone/>
-            </a:pPr>
-            <a:r>
-              <a:rPr lang="en-US" sz="1050" b="1" dirty="0">
-                <a:solidFill>
-                  <a:srgbClr val="6C7680"/>
-                </a:solidFill>
-                <a:latin typeface="Malgun Gothic" pitchFamily="34" charset="0"/>
-                <a:ea typeface="Malgun Gothic" pitchFamily="34" charset="-122"/>
-                <a:cs typeface="Malgun Gothic" pitchFamily="34" charset="-120"/>
-              </a:rPr>
-              <a:t>10 km</a:t>
-            </a:r>
-            <a:endParaRPr lang="en-US" sz="1050" dirty="0"/>
-          </a:p>
-        </p:txBody>
-      </p:sp>
-      <p:sp>
-        <p:nvSpPr>
-          <p:cNvPr id="12" name="Text 9"/>
-          <p:cNvSpPr/>
-          <p:nvPr/>
-        </p:nvSpPr>
-        <p:spPr>
-          <a:xfrm>
-            <a:off x="7168896" y="4882896"/>
-            <a:ext cx="1161288" cy="256032"/>
-          </a:xfrm>
-          <a:prstGeom prst="rect">
-            <a:avLst/>
-          </a:prstGeom>
-          <a:noFill/>
-          <a:ln/>
-        </p:spPr>
-        <p:txBody>
-          <a:bodyPr wrap="square" rtlCol="0" anchor="ctr"/>
-          <a:lstStyle/>
-          <a:p>
-            <a:pPr indent="0" marL="0">
-              <a:buNone/>
-            </a:pPr>
-            <a:r>
-              <a:rPr lang="en-US" sz="2000" b="1" dirty="0">
-                <a:solidFill>
-                  <a:srgbClr val="2C3842"/>
-                </a:solidFill>
-                <a:latin typeface="Malgun Gothic" pitchFamily="34" charset="0"/>
-                <a:ea typeface="Malgun Gothic" pitchFamily="34" charset="-122"/>
-                <a:cs typeface="Malgun Gothic" pitchFamily="34" charset="-120"/>
-              </a:rPr>
-              <a:t>성립</a:t>
-            </a:r>
-            <a:endParaRPr lang="en-US" sz="2000" dirty="0"/>
-          </a:p>
-        </p:txBody>
-      </p:sp>
-      <p:sp>
-        <p:nvSpPr>
-          <p:cNvPr id="13" name="Text 10"/>
-          <p:cNvSpPr/>
-          <p:nvPr/>
-        </p:nvSpPr>
-        <p:spPr>
-          <a:xfrm>
-            <a:off x="7168896" y="5239512"/>
-            <a:ext cx="1161288" cy="146304"/>
-          </a:xfrm>
-          <a:prstGeom prst="rect">
-            <a:avLst/>
-          </a:prstGeom>
-          <a:noFill/>
-          <a:ln/>
-        </p:spPr>
-        <p:txBody>
-          <a:bodyPr wrap="square" rtlCol="0" anchor="ctr"/>
-          <a:lstStyle/>
-          <a:p>
-            <a:pPr indent="0" marL="0">
-              <a:buNone/>
-            </a:pPr>
-            <a:r>
-              <a:rPr lang="en-US" sz="950" dirty="0">
-                <a:solidFill>
-                  <a:srgbClr val="6C7680"/>
-                </a:solidFill>
-                <a:latin typeface="Malgun Gothic" pitchFamily="34" charset="0"/>
-                <a:ea typeface="Malgun Gothic" pitchFamily="34" charset="-122"/>
-                <a:cs typeface="Malgun Gothic" pitchFamily="34" charset="-120"/>
-              </a:rPr>
-              <a:t>기본안</a:t>
-            </a:r>
-            <a:endParaRPr lang="en-US" sz="950" dirty="0"/>
-          </a:p>
-        </p:txBody>
-      </p:sp>
-      <p:sp>
-        <p:nvSpPr>
-          <p:cNvPr id="14" name="Shape 11"/>
-          <p:cNvSpPr/>
-          <p:nvPr/>
-        </p:nvSpPr>
-        <p:spPr>
-          <a:xfrm>
-            <a:off x="8686800" y="4572000"/>
-            <a:ext cx="1554480" cy="868680"/>
           </a:xfrm>
           <a:prstGeom prst="rect">
             <a:avLst/>
@@ -5844,14 +5702,14 @@
       </p:sp>
       <p:sp>
         <p:nvSpPr>
-          <p:cNvPr id="15" name="Text 12"/>
-          <p:cNvSpPr/>
-          <p:nvPr/>
-        </p:nvSpPr>
-        <p:spPr>
-          <a:xfrm>
-            <a:off x="8814816" y="4663440"/>
-            <a:ext cx="1298448" cy="164592"/>
+          <p:cNvPr id="11" name="Text 8"/>
+          <p:cNvSpPr/>
+          <p:nvPr/>
+        </p:nvSpPr>
+        <p:spPr>
+          <a:xfrm>
+            <a:off x="7168896" y="4663440"/>
+            <a:ext cx="1161288" cy="164592"/>
           </a:xfrm>
           <a:prstGeom prst="rect">
             <a:avLst/>
@@ -5875,7 +5733,7 @@
                 <a:ea typeface="Malgun Gothic" pitchFamily="34" charset="-122"/>
                 <a:cs typeface="Malgun Gothic" pitchFamily="34" charset="-120"/>
               </a:rPr>
-              <a:t>최대 한계</a:t>
+              <a:t>10 km</a:t>
             </a:r>
             <a:endParaRPr lang="en-US" sz="1050" dirty="0"/>
           </a:p>
@@ -5883,14 +5741,14 @@
       </p:sp>
       <p:sp>
         <p:nvSpPr>
-          <p:cNvPr id="16" name="Text 13"/>
-          <p:cNvSpPr/>
-          <p:nvPr/>
-        </p:nvSpPr>
-        <p:spPr>
-          <a:xfrm>
-            <a:off x="8814816" y="4882896"/>
-            <a:ext cx="1298448" cy="256032"/>
+          <p:cNvPr id="12" name="Text 9"/>
+          <p:cNvSpPr/>
+          <p:nvPr/>
+        </p:nvSpPr>
+        <p:spPr>
+          <a:xfrm>
+            <a:off x="7168896" y="4882896"/>
+            <a:ext cx="1161288" cy="256032"/>
           </a:xfrm>
           <a:prstGeom prst="rect">
             <a:avLst/>
@@ -5914,7 +5772,7 @@
                 <a:ea typeface="Malgun Gothic" pitchFamily="34" charset="-122"/>
                 <a:cs typeface="Malgun Gothic" pitchFamily="34" charset="-120"/>
               </a:rPr>
-              <a:t>103.8 km</a:t>
+              <a:t>하이브리드</a:t>
             </a:r>
             <a:endParaRPr lang="en-US" sz="2000" dirty="0"/>
           </a:p>
@@ -5922,14 +5780,14 @@
       </p:sp>
       <p:sp>
         <p:nvSpPr>
-          <p:cNvPr id="17" name="Text 14"/>
-          <p:cNvSpPr/>
-          <p:nvPr/>
-        </p:nvSpPr>
-        <p:spPr>
-          <a:xfrm>
-            <a:off x="8814816" y="5239512"/>
-            <a:ext cx="1298448" cy="146304"/>
+          <p:cNvPr id="13" name="Text 10"/>
+          <p:cNvSpPr/>
+          <p:nvPr/>
+        </p:nvSpPr>
+        <p:spPr>
+          <a:xfrm>
+            <a:off x="7168896" y="5239512"/>
+            <a:ext cx="1161288" cy="146304"/>
           </a:xfrm>
           <a:prstGeom prst="rect">
             <a:avLst/>
@@ -5953,7 +5811,7 @@
                 <a:ea typeface="Malgun Gothic" pitchFamily="34" charset="-122"/>
                 <a:cs typeface="Malgun Gothic" pitchFamily="34" charset="-120"/>
               </a:rPr>
-              <a:t>편도 추정</a:t>
+              <a:t>보조 warm-up 필요</a:t>
             </a:r>
             <a:endParaRPr lang="en-US" sz="950" dirty="0"/>
           </a:p>
@@ -5961,14 +5819,14 @@
       </p:sp>
       <p:sp>
         <p:nvSpPr>
-          <p:cNvPr id="18" name="Shape 15"/>
-          <p:cNvSpPr/>
-          <p:nvPr/>
-        </p:nvSpPr>
-        <p:spPr>
-          <a:xfrm>
-            <a:off x="10241280" y="4572000"/>
-            <a:ext cx="1280160" cy="868680"/>
+          <p:cNvPr id="14" name="Shape 11"/>
+          <p:cNvSpPr/>
+          <p:nvPr/>
+        </p:nvSpPr>
+        <p:spPr>
+          <a:xfrm>
+            <a:off x="8686800" y="4572000"/>
+            <a:ext cx="1554480" cy="868680"/>
           </a:xfrm>
           <a:prstGeom prst="rect">
             <a:avLst/>
@@ -5978,7 +5836,7 @@
           </a:solidFill>
           <a:ln w="12700">
             <a:solidFill>
-              <a:srgbClr val="2F7D58"/>
+              <a:srgbClr val="C89B3C"/>
             </a:solidFill>
             <a:prstDash val="solid"/>
           </a:ln>
@@ -5986,6 +5844,148 @@
       </p:sp>
       <p:sp>
         <p:nvSpPr>
+          <p:cNvPr id="15" name="Text 12"/>
+          <p:cNvSpPr/>
+          <p:nvPr/>
+        </p:nvSpPr>
+        <p:spPr>
+          <a:xfrm>
+            <a:off x="8814816" y="4663440"/>
+            <a:ext cx="1298448" cy="164592"/>
+          </a:xfrm>
+          <a:prstGeom prst="rect">
+            <a:avLst/>
+          </a:prstGeom>
+          <a:noFill/>
+          <a:ln/>
+        </p:spPr>
+        <p:txBody>
+          <a:bodyPr wrap="square" rtlCol="0" anchor="ctr"/>
+          <a:lstStyle/>
+          <a:p>
+            <a:pPr indent="0" marL="0">
+              <a:buNone/>
+            </a:pPr>
+            <a:r>
+              <a:rPr lang="en-US" sz="1050" b="1" dirty="0">
+                <a:solidFill>
+                  <a:srgbClr val="6C7680"/>
+                </a:solidFill>
+                <a:latin typeface="Malgun Gothic" pitchFamily="34" charset="0"/>
+                <a:ea typeface="Malgun Gothic" pitchFamily="34" charset="-122"/>
+                <a:cs typeface="Malgun Gothic" pitchFamily="34" charset="-120"/>
+              </a:rPr>
+              <a:t>하이브리드 한계</a:t>
+            </a:r>
+            <a:endParaRPr lang="en-US" sz="1050" dirty="0"/>
+          </a:p>
+        </p:txBody>
+      </p:sp>
+      <p:sp>
+        <p:nvSpPr>
+          <p:cNvPr id="16" name="Text 13"/>
+          <p:cNvSpPr/>
+          <p:nvPr/>
+        </p:nvSpPr>
+        <p:spPr>
+          <a:xfrm>
+            <a:off x="8814816" y="4882896"/>
+            <a:ext cx="1298448" cy="256032"/>
+          </a:xfrm>
+          <a:prstGeom prst="rect">
+            <a:avLst/>
+          </a:prstGeom>
+          <a:noFill/>
+          <a:ln/>
+        </p:spPr>
+        <p:txBody>
+          <a:bodyPr wrap="square" rtlCol="0" anchor="ctr"/>
+          <a:lstStyle/>
+          <a:p>
+            <a:pPr indent="0" marL="0">
+              <a:buNone/>
+            </a:pPr>
+            <a:r>
+              <a:rPr lang="en-US" sz="2000" b="1" dirty="0">
+                <a:solidFill>
+                  <a:srgbClr val="2C3842"/>
+                </a:solidFill>
+                <a:latin typeface="Malgun Gothic" pitchFamily="34" charset="0"/>
+                <a:ea typeface="Malgun Gothic" pitchFamily="34" charset="-122"/>
+                <a:cs typeface="Malgun Gothic" pitchFamily="34" charset="-120"/>
+              </a:rPr>
+              <a:t>103.8 km</a:t>
+            </a:r>
+            <a:endParaRPr lang="en-US" sz="2000" dirty="0"/>
+          </a:p>
+        </p:txBody>
+      </p:sp>
+      <p:sp>
+        <p:nvSpPr>
+          <p:cNvPr id="17" name="Text 14"/>
+          <p:cNvSpPr/>
+          <p:nvPr/>
+        </p:nvSpPr>
+        <p:spPr>
+          <a:xfrm>
+            <a:off x="8814816" y="5239512"/>
+            <a:ext cx="1298448" cy="146304"/>
+          </a:xfrm>
+          <a:prstGeom prst="rect">
+            <a:avLst/>
+          </a:prstGeom>
+          <a:noFill/>
+          <a:ln/>
+        </p:spPr>
+        <p:txBody>
+          <a:bodyPr wrap="square" rtlCol="0" anchor="ctr"/>
+          <a:lstStyle/>
+          <a:p>
+            <a:pPr indent="0" marL="0">
+              <a:buNone/>
+            </a:pPr>
+            <a:r>
+              <a:rPr lang="en-US" sz="950" dirty="0">
+                <a:solidFill>
+                  <a:srgbClr val="6C7680"/>
+                </a:solidFill>
+                <a:latin typeface="Malgun Gothic" pitchFamily="34" charset="0"/>
+                <a:ea typeface="Malgun Gothic" pitchFamily="34" charset="-122"/>
+                <a:cs typeface="Malgun Gothic" pitchFamily="34" charset="-120"/>
+              </a:rPr>
+              <a:t>편도 추정</a:t>
+            </a:r>
+            <a:endParaRPr lang="en-US" sz="950" dirty="0"/>
+          </a:p>
+        </p:txBody>
+      </p:sp>
+      <p:sp>
+        <p:nvSpPr>
+          <p:cNvPr id="18" name="Shape 15"/>
+          <p:cNvSpPr/>
+          <p:nvPr/>
+        </p:nvSpPr>
+        <p:spPr>
+          <a:xfrm>
+            <a:off x="10241280" y="4572000"/>
+            <a:ext cx="1280160" cy="868680"/>
+          </a:xfrm>
+          <a:prstGeom prst="rect">
+            <a:avLst/>
+          </a:prstGeom>
+          <a:solidFill>
+            <a:srgbClr val="FFFFFF"/>
+          </a:solidFill>
+          <a:ln w="12700">
+            <a:solidFill>
+              <a:srgbClr val="C89B3C"/>
+            </a:solidFill>
+            <a:prstDash val="solid"/>
+          </a:ln>
+        </p:spPr>
+      </p:sp>
+      <p:sp>
+        <p:nvSpPr>
           <p:cNvPr id="19" name="Text 16"/>
           <p:cNvSpPr/>
           <p:nvPr/>
@@ -6056,7 +6056,7 @@
                 <a:ea typeface="Malgun Gothic" pitchFamily="34" charset="-122"/>
                 <a:cs typeface="Malgun Gothic" pitchFamily="34" charset="-120"/>
               </a:rPr>
-              <a:t>성립</a:t>
+              <a:t>하이브리드만</a:t>
             </a:r>
             <a:endParaRPr lang="en-US" sz="2000" dirty="0"/>
           </a:p>
@@ -6095,7 +6095,7 @@
                 <a:ea typeface="Malgun Gothic" pitchFamily="34" charset="-122"/>
                 <a:cs typeface="Malgun Gothic" pitchFamily="34" charset="-120"/>
               </a:rPr>
-              <a:t>기본점</a:t>
+              <a:t>보조 warm-up 필요</a:t>
             </a:r>
             <a:endParaRPr lang="en-US" sz="950" dirty="0"/>
           </a:p>
@@ -6454,7 +6454,7 @@
                 <a:ea typeface="Malgun Gothic" pitchFamily="34" charset="-122"/>
                 <a:cs typeface="Malgun Gothic" pitchFamily="34" charset="-120"/>
               </a:rPr>
-              <a:t>현재 기본안만으로도 35 km 조건이 성립한다.</a:t>
+              <a:t>공급온도를 210 K까지 높이면 35 km 기본 LNG duty 조건을 회복할 수 있다.</a:t>
             </a:r>
             <a:endParaRPr lang="en-US" sz="1580" dirty="0"/>
           </a:p>
@@ -6472,7 +6472,7 @@
                 <a:ea typeface="Malgun Gothic" pitchFamily="34" charset="-122"/>
                 <a:cs typeface="Malgun Gothic" pitchFamily="34" charset="-120"/>
               </a:rPr>
-              <a:t>따라서 공급온도 스윕은 거리 복구보다 여유와 펌프동력 변화의 trade-off를 읽는 도구가 된다.</a:t>
+              <a:t>하지만 그 과정에서 우선 유체가 R-717 (Ammonia)로 바뀌고 펌프동력은 크게 증가한다.</a:t>
             </a:r>
             <a:endParaRPr lang="en-US" sz="1580" dirty="0"/>
           </a:p>
@@ -6490,7 +6490,7 @@
                 <a:ea typeface="Malgun Gothic" pitchFamily="34" charset="-122"/>
                 <a:cs typeface="Malgun Gothic" pitchFamily="34" charset="-120"/>
               </a:rPr>
-              <a:t>다만 현실성 필터를 거치면 현재는 채택 가능한 무보조 해가 남지 않는다.</a:t>
+              <a:t>또한 무보조 점이 나와도 현실성 필터를 통과하는 해는 아직 없다.</a:t>
             </a:r>
             <a:endParaRPr lang="en-US" sz="1580" dirty="0"/>
           </a:p>
@@ -6508,7 +6508,7 @@
                 <a:ea typeface="Malgun Gothic" pitchFamily="34" charset="-122"/>
                 <a:cs typeface="Malgun Gothic" pitchFamily="34" charset="-120"/>
               </a:rPr>
-              <a:t>온도 수준이 바뀌면 유체 선택과 최적 거리 여유도 함께 바뀐다.</a:t>
+              <a:t>즉 거리 회복은 가능하지만 공짜는 아니다.</a:t>
             </a:r>
             <a:endParaRPr lang="en-US" sz="1580" dirty="0"/>
           </a:p>
@@ -6675,7 +6675,7 @@
           </a:solidFill>
           <a:ln w="12700">
             <a:solidFill>
-              <a:srgbClr val="2F7D58"/>
+              <a:srgbClr val="C89B3C"/>
             </a:solidFill>
             <a:prstDash val="solid"/>
           </a:ln>
@@ -6753,7 +6753,7 @@
                 <a:ea typeface="Malgun Gothic" pitchFamily="34" charset="-122"/>
                 <a:cs typeface="Malgun Gothic" pitchFamily="34" charset="-120"/>
               </a:rPr>
-              <a:t>현재 성립</a:t>
+              <a:t>하이브리드만</a:t>
             </a:r>
             <a:endParaRPr lang="en-US" sz="2000" dirty="0"/>
           </a:p>
@@ -6895,7 +6895,7 @@
                 <a:ea typeface="Malgun Gothic" pitchFamily="34" charset="-122"/>
                 <a:cs typeface="Malgun Gothic" pitchFamily="34" charset="-120"/>
               </a:rPr>
-              <a:t>14 kW</a:t>
+              <a:t>137 kW</a:t>
             </a:r>
             <a:endParaRPr lang="en-US" sz="2000" dirty="0"/>
           </a:p>
@@ -8585,7 +8585,7 @@
                 <a:ea typeface="Malgun Gothic" pitchFamily="34" charset="-122"/>
                 <a:cs typeface="Malgun Gothic" pitchFamily="34" charset="-120"/>
               </a:rPr>
-              <a:t>66.12</a:t>
+              <a:t>66.32</a:t>
             </a:r>
             <a:endParaRPr lang="en-US" sz="2000" dirty="0"/>
           </a:p>
@@ -8727,7 +8727,7 @@
                 <a:ea typeface="Malgun Gothic" pitchFamily="34" charset="-122"/>
                 <a:cs typeface="Malgun Gothic" pitchFamily="34" charset="-120"/>
               </a:rPr>
-              <a:t>현재 core-system NPV는 -42.61 십억원으로, 장거리 외부 배관 CAPEX가 매우 크게 작용한다.</a:t>
+              <a:t>현재 core-system NPV는 -42.85 십억원으로, 장거리 외부 배관 CAPEX가 매우 크게 작용한다.</a:t>
             </a:r>
             <a:endParaRPr lang="en-US" sz="1400" dirty="0"/>
           </a:p>
@@ -9245,7 +9245,7 @@
                 <a:ea typeface="Malgun Gothic" pitchFamily="34" charset="-122"/>
                 <a:cs typeface="Malgun Gothic" pitchFamily="34" charset="-120"/>
               </a:rPr>
-              <a:t>현재 기본안으로도 35 km가 이미 성립한다.</a:t>
+              <a:t>현재 35 km는 하이브리드 성립이지만 기본 LNG duty는 부족하다.</a:t>
             </a:r>
             <a:endParaRPr lang="en-US" sz="1400" dirty="0"/>
           </a:p>
@@ -9262,7 +9262,7 @@
                 <a:ea typeface="Malgun Gothic" pitchFamily="34" charset="-122"/>
                 <a:cs typeface="Malgun Gothic" pitchFamily="34" charset="-120"/>
               </a:rPr>
-              <a:t>다만 추가 거리 여유 확보는 별도 최적화 문제다.</a:t>
+              <a:t>유체 변경(R-600a 방향)</a:t>
             </a:r>
             <a:endParaRPr lang="en-US" sz="1400" dirty="0"/>
           </a:p>
@@ -9279,7 +9279,7 @@
                 <a:ea typeface="Malgun Gothic" pitchFamily="34" charset="-122"/>
                 <a:cs typeface="Malgun Gothic" pitchFamily="34" charset="-120"/>
               </a:rPr>
-              <a:t>열유입 여유와 펌프동력 증가는 계속 trade-off다.</a:t>
+              <a:t>펌프동력 증가 수용</a:t>
             </a:r>
             <a:endParaRPr lang="en-US" sz="1400" dirty="0"/>
           </a:p>
@@ -9319,7 +9319,7 @@
                 <a:ea typeface="Malgun Gothic" pitchFamily="34" charset="-122"/>
                 <a:cs typeface="Malgun Gothic" pitchFamily="34" charset="-120"/>
               </a:rPr>
-              <a:t>즉 35 km는 이제 기준안의 성립 영역 안에 들어오지만, 그 이상 확장은 여전히 설계 과제다.</a:t>
+              <a:t>즉 35 km는 완전 불가가 아니라 하이브리드 해석과 기본 LNG duty 해석을 분리해 읽어야 한다.</a:t>
             </a:r>
             <a:endParaRPr lang="en-US" sz="1400" dirty="0"/>
           </a:p>
@@ -10507,7 +10507,7 @@
                 <a:ea typeface="Malgun Gothic" pitchFamily="34" charset="-122"/>
                 <a:cs typeface="Malgun Gothic" pitchFamily="34" charset="-120"/>
               </a:rPr>
-              <a:t>10 km 설계점에서는 LNG 냉열 기반 IDC 냉각 개념이 기술적으로 성립한다.</a:t>
+              <a:t>10 km 설계점에서는 supplemental warm-up을 포함한 하이브리드 운전 기준으로 LNG 냉열 기반 IDC 냉각 개념이 성립한다.</a:t>
             </a:r>
             <a:endParaRPr lang="en-US" sz="1400" dirty="0"/>
           </a:p>
@@ -10524,7 +10524,7 @@
                 <a:ea typeface="Malgun Gothic" pitchFamily="34" charset="-122"/>
                 <a:cs typeface="Malgun Gothic" pitchFamily="34" charset="-120"/>
               </a:rPr>
-              <a:t>기준 압축기 시스템 대비 전력 요구는 매우 크게 감소한다.</a:t>
+              <a:t>기준 압축기 시스템 대비 core-system 전력 요구는 매우 크게 감소한다.</a:t>
             </a:r>
             <a:endParaRPr lang="en-US" sz="1400" dirty="0"/>
           </a:p>
@@ -10747,7 +10747,7 @@
                 <a:ea typeface="Malgun Gothic" pitchFamily="34" charset="-122"/>
                 <a:cs typeface="Malgun Gothic" pitchFamily="34" charset="-120"/>
               </a:rPr>
-              <a:t>IDC 측 HX와 LNG hot-end 제약을 함께 풀면 35 km도 현재 기본안에서 성립한다.</a:t>
+              <a:t>35 km는 하이브리드 운전에서는 성립하지만 기본 LNG duty 경계에서는 불성립한다.</a:t>
             </a:r>
             <a:endParaRPr lang="en-US" sz="1400" dirty="0"/>
           </a:p>
@@ -10764,7 +10764,7 @@
                 <a:ea typeface="Malgun Gothic" pitchFamily="34" charset="-122"/>
                 <a:cs typeface="Malgun Gothic" pitchFamily="34" charset="-120"/>
               </a:rPr>
-              <a:t>따라서 이번 재구축의 메시지는 기존보다 완화된 실제 성립영역을 재계산했다는 데 있다.</a:t>
+              <a:t>따라서 이번 프로젝트의 진짜 메시지는 ‘가능/불가능의 경계’를 물리적으로 분해해냈다는 데 있다.</a:t>
             </a:r>
             <a:endParaRPr lang="en-US" sz="1400" dirty="0"/>
           </a:p>
@@ -10779,148 +10779,6 @@
         <p:spPr>
           <a:xfrm>
             <a:off x="1143000" y="5074920"/>
-            <a:ext cx="2560320" cy="932688"/>
-          </a:xfrm>
-          <a:prstGeom prst="rect">
-            <a:avLst/>
-          </a:prstGeom>
-          <a:solidFill>
-            <a:srgbClr val="FFFFFF"/>
-          </a:solidFill>
-          <a:ln w="12700">
-            <a:solidFill>
-              <a:srgbClr val="2F7D58"/>
-            </a:solidFill>
-            <a:prstDash val="solid"/>
-          </a:ln>
-        </p:spPr>
-      </p:sp>
-      <p:sp>
-        <p:nvSpPr>
-          <p:cNvPr id="19" name="Text 17"/>
-          <p:cNvSpPr/>
-          <p:nvPr/>
-        </p:nvSpPr>
-        <p:spPr>
-          <a:xfrm>
-            <a:off x="1271016" y="5166360"/>
-            <a:ext cx="2304288" cy="164592"/>
-          </a:xfrm>
-          <a:prstGeom prst="rect">
-            <a:avLst/>
-          </a:prstGeom>
-          <a:noFill/>
-          <a:ln/>
-        </p:spPr>
-        <p:txBody>
-          <a:bodyPr wrap="square" rtlCol="0" anchor="ctr"/>
-          <a:lstStyle/>
-          <a:p>
-            <a:pPr indent="0" marL="0">
-              <a:buNone/>
-            </a:pPr>
-            <a:r>
-              <a:rPr lang="en-US" sz="1050" b="1" dirty="0">
-                <a:solidFill>
-                  <a:srgbClr val="6C7680"/>
-                </a:solidFill>
-                <a:latin typeface="Malgun Gothic" pitchFamily="34" charset="0"/>
-                <a:ea typeface="Malgun Gothic" pitchFamily="34" charset="-122"/>
-                <a:cs typeface="Malgun Gothic" pitchFamily="34" charset="-120"/>
-              </a:rPr>
-              <a:t>기본안</a:t>
-            </a:r>
-            <a:endParaRPr lang="en-US" sz="1050" dirty="0"/>
-          </a:p>
-        </p:txBody>
-      </p:sp>
-      <p:sp>
-        <p:nvSpPr>
-          <p:cNvPr id="20" name="Text 18"/>
-          <p:cNvSpPr/>
-          <p:nvPr/>
-        </p:nvSpPr>
-        <p:spPr>
-          <a:xfrm>
-            <a:off x="1271016" y="5385816"/>
-            <a:ext cx="2304288" cy="256032"/>
-          </a:xfrm>
-          <a:prstGeom prst="rect">
-            <a:avLst/>
-          </a:prstGeom>
-          <a:noFill/>
-          <a:ln/>
-        </p:spPr>
-        <p:txBody>
-          <a:bodyPr wrap="square" rtlCol="0" anchor="ctr"/>
-          <a:lstStyle/>
-          <a:p>
-            <a:pPr indent="0" marL="0">
-              <a:buNone/>
-            </a:pPr>
-            <a:r>
-              <a:rPr lang="en-US" sz="2000" b="1" dirty="0">
-                <a:solidFill>
-                  <a:srgbClr val="2C3842"/>
-                </a:solidFill>
-                <a:latin typeface="Malgun Gothic" pitchFamily="34" charset="0"/>
-                <a:ea typeface="Malgun Gothic" pitchFamily="34" charset="-122"/>
-                <a:cs typeface="Malgun Gothic" pitchFamily="34" charset="-120"/>
-              </a:rPr>
-              <a:t>10 km 성립</a:t>
-            </a:r>
-            <a:endParaRPr lang="en-US" sz="2000" dirty="0"/>
-          </a:p>
-        </p:txBody>
-      </p:sp>
-      <p:sp>
-        <p:nvSpPr>
-          <p:cNvPr id="21" name="Text 19"/>
-          <p:cNvSpPr/>
-          <p:nvPr/>
-        </p:nvSpPr>
-        <p:spPr>
-          <a:xfrm>
-            <a:off x="1271016" y="5806440"/>
-            <a:ext cx="2304288" cy="146304"/>
-          </a:xfrm>
-          <a:prstGeom prst="rect">
-            <a:avLst/>
-          </a:prstGeom>
-          <a:noFill/>
-          <a:ln/>
-        </p:spPr>
-        <p:txBody>
-          <a:bodyPr wrap="square" rtlCol="0" anchor="ctr"/>
-          <a:lstStyle/>
-          <a:p>
-            <a:pPr indent="0" marL="0">
-              <a:buNone/>
-            </a:pPr>
-            <a:r>
-              <a:rPr lang="en-US" sz="950" dirty="0">
-                <a:solidFill>
-                  <a:srgbClr val="6C7680"/>
-                </a:solidFill>
-                <a:latin typeface="Malgun Gothic" pitchFamily="34" charset="0"/>
-                <a:ea typeface="Malgun Gothic" pitchFamily="34" charset="-122"/>
-                <a:cs typeface="Malgun Gothic" pitchFamily="34" charset="-120"/>
-              </a:rPr>
-              <a:t>LNG 냉열 활용</a:t>
-            </a:r>
-            <a:endParaRPr lang="en-US" sz="950" dirty="0"/>
-          </a:p>
-        </p:txBody>
-      </p:sp>
-      <p:sp>
-        <p:nvSpPr>
-          <p:cNvPr id="22" name="Shape 20"/>
-          <p:cNvSpPr/>
-          <p:nvPr/>
-        </p:nvSpPr>
-        <p:spPr>
-          <a:xfrm>
-            <a:off x="4069080" y="5074920"/>
             <a:ext cx="2560320" cy="932688"/>
           </a:xfrm>
           <a:prstGeom prst="rect">
@@ -10939,13 +10797,13 @@
       </p:sp>
       <p:sp>
         <p:nvSpPr>
-          <p:cNvPr id="23" name="Text 21"/>
-          <p:cNvSpPr/>
-          <p:nvPr/>
-        </p:nvSpPr>
-        <p:spPr>
-          <a:xfrm>
-            <a:off x="4197096" y="5166360"/>
+          <p:cNvPr id="19" name="Text 17"/>
+          <p:cNvSpPr/>
+          <p:nvPr/>
+        </p:nvSpPr>
+        <p:spPr>
+          <a:xfrm>
+            <a:off x="1271016" y="5166360"/>
             <a:ext cx="2304288" cy="164592"/>
           </a:xfrm>
           <a:prstGeom prst="rect">
@@ -10970,7 +10828,7 @@
                 <a:ea typeface="Malgun Gothic" pitchFamily="34" charset="-122"/>
                 <a:cs typeface="Malgun Gothic" pitchFamily="34" charset="-120"/>
               </a:rPr>
-              <a:t>경계조건</a:t>
+              <a:t>기본안</a:t>
             </a:r>
             <a:endParaRPr lang="en-US" sz="1050" dirty="0"/>
           </a:p>
@@ -10978,13 +10836,13 @@
       </p:sp>
       <p:sp>
         <p:nvSpPr>
-          <p:cNvPr id="24" name="Text 22"/>
-          <p:cNvSpPr/>
-          <p:nvPr/>
-        </p:nvSpPr>
-        <p:spPr>
-          <a:xfrm>
-            <a:off x="4197096" y="5385816"/>
+          <p:cNvPr id="20" name="Text 18"/>
+          <p:cNvSpPr/>
+          <p:nvPr/>
+        </p:nvSpPr>
+        <p:spPr>
+          <a:xfrm>
+            <a:off x="1271016" y="5385816"/>
             <a:ext cx="2304288" cy="256032"/>
           </a:xfrm>
           <a:prstGeom prst="rect">
@@ -11009,7 +10867,7 @@
                 <a:ea typeface="Malgun Gothic" pitchFamily="34" charset="-122"/>
                 <a:cs typeface="Malgun Gothic" pitchFamily="34" charset="-120"/>
               </a:rPr>
-              <a:t>103.8 km</a:t>
+              <a:t>10 km 하이브리드 성립</a:t>
             </a:r>
             <a:endParaRPr lang="en-US" sz="2000" dirty="0"/>
           </a:p>
@@ -11017,13 +10875,13 @@
       </p:sp>
       <p:sp>
         <p:nvSpPr>
-          <p:cNvPr id="25" name="Text 23"/>
-          <p:cNvSpPr/>
-          <p:nvPr/>
-        </p:nvSpPr>
-        <p:spPr>
-          <a:xfrm>
-            <a:off x="4197096" y="5806440"/>
+          <p:cNvPr id="21" name="Text 19"/>
+          <p:cNvSpPr/>
+          <p:nvPr/>
+        </p:nvSpPr>
+        <p:spPr>
+          <a:xfrm>
+            <a:off x="1271016" y="5806440"/>
             <a:ext cx="2304288" cy="146304"/>
           </a:xfrm>
           <a:prstGeom prst="rect">
@@ -11048,7 +10906,7 @@
                 <a:ea typeface="Malgun Gothic" pitchFamily="34" charset="-122"/>
                 <a:cs typeface="Malgun Gothic" pitchFamily="34" charset="-120"/>
               </a:rPr>
-              <a:t>추정 편도 한계</a:t>
+              <a:t>보조 warm-up 필요</a:t>
             </a:r>
             <a:endParaRPr lang="en-US" sz="950" dirty="0"/>
           </a:p>
@@ -11056,14 +10914,14 @@
       </p:sp>
       <p:sp>
         <p:nvSpPr>
-          <p:cNvPr id="26" name="Shape 24"/>
-          <p:cNvSpPr/>
-          <p:nvPr/>
-        </p:nvSpPr>
-        <p:spPr>
-          <a:xfrm>
-            <a:off x="6995160" y="5074920"/>
-            <a:ext cx="3931920" cy="932688"/>
+          <p:cNvPr id="22" name="Shape 20"/>
+          <p:cNvSpPr/>
+          <p:nvPr/>
+        </p:nvSpPr>
+        <p:spPr>
+          <a:xfrm>
+            <a:off x="4069080" y="5074920"/>
+            <a:ext cx="2560320" cy="932688"/>
           </a:xfrm>
           <a:prstGeom prst="rect">
             <a:avLst/>
@@ -11073,7 +10931,7 @@
           </a:solidFill>
           <a:ln w="12700">
             <a:solidFill>
-              <a:srgbClr val="2F7D58"/>
+              <a:srgbClr val="C89B3C"/>
             </a:solidFill>
             <a:prstDash val="solid"/>
           </a:ln>
@@ -11081,6 +10939,148 @@
       </p:sp>
       <p:sp>
         <p:nvSpPr>
+          <p:cNvPr id="23" name="Text 21"/>
+          <p:cNvSpPr/>
+          <p:nvPr/>
+        </p:nvSpPr>
+        <p:spPr>
+          <a:xfrm>
+            <a:off x="4197096" y="5166360"/>
+            <a:ext cx="2304288" cy="164592"/>
+          </a:xfrm>
+          <a:prstGeom prst="rect">
+            <a:avLst/>
+          </a:prstGeom>
+          <a:noFill/>
+          <a:ln/>
+        </p:spPr>
+        <p:txBody>
+          <a:bodyPr wrap="square" rtlCol="0" anchor="ctr"/>
+          <a:lstStyle/>
+          <a:p>
+            <a:pPr indent="0" marL="0">
+              <a:buNone/>
+            </a:pPr>
+            <a:r>
+              <a:rPr lang="en-US" sz="1050" b="1" dirty="0">
+                <a:solidFill>
+                  <a:srgbClr val="6C7680"/>
+                </a:solidFill>
+                <a:latin typeface="Malgun Gothic" pitchFamily="34" charset="0"/>
+                <a:ea typeface="Malgun Gothic" pitchFamily="34" charset="-122"/>
+                <a:cs typeface="Malgun Gothic" pitchFamily="34" charset="-120"/>
+              </a:rPr>
+              <a:t>경계조건</a:t>
+            </a:r>
+            <a:endParaRPr lang="en-US" sz="1050" dirty="0"/>
+          </a:p>
+        </p:txBody>
+      </p:sp>
+      <p:sp>
+        <p:nvSpPr>
+          <p:cNvPr id="24" name="Text 22"/>
+          <p:cNvSpPr/>
+          <p:nvPr/>
+        </p:nvSpPr>
+        <p:spPr>
+          <a:xfrm>
+            <a:off x="4197096" y="5385816"/>
+            <a:ext cx="2304288" cy="256032"/>
+          </a:xfrm>
+          <a:prstGeom prst="rect">
+            <a:avLst/>
+          </a:prstGeom>
+          <a:noFill/>
+          <a:ln/>
+        </p:spPr>
+        <p:txBody>
+          <a:bodyPr wrap="square" rtlCol="0" anchor="ctr"/>
+          <a:lstStyle/>
+          <a:p>
+            <a:pPr indent="0" marL="0">
+              <a:buNone/>
+            </a:pPr>
+            <a:r>
+              <a:rPr lang="en-US" sz="2000" b="1" dirty="0">
+                <a:solidFill>
+                  <a:srgbClr val="2C3842"/>
+                </a:solidFill>
+                <a:latin typeface="Malgun Gothic" pitchFamily="34" charset="0"/>
+                <a:ea typeface="Malgun Gothic" pitchFamily="34" charset="-122"/>
+                <a:cs typeface="Malgun Gothic" pitchFamily="34" charset="-120"/>
+              </a:rPr>
+              <a:t>103.8 km</a:t>
+            </a:r>
+            <a:endParaRPr lang="en-US" sz="2000" dirty="0"/>
+          </a:p>
+        </p:txBody>
+      </p:sp>
+      <p:sp>
+        <p:nvSpPr>
+          <p:cNvPr id="25" name="Text 23"/>
+          <p:cNvSpPr/>
+          <p:nvPr/>
+        </p:nvSpPr>
+        <p:spPr>
+          <a:xfrm>
+            <a:off x="4197096" y="5806440"/>
+            <a:ext cx="2304288" cy="146304"/>
+          </a:xfrm>
+          <a:prstGeom prst="rect">
+            <a:avLst/>
+          </a:prstGeom>
+          <a:noFill/>
+          <a:ln/>
+        </p:spPr>
+        <p:txBody>
+          <a:bodyPr wrap="square" rtlCol="0" anchor="ctr"/>
+          <a:lstStyle/>
+          <a:p>
+            <a:pPr indent="0" marL="0">
+              <a:buNone/>
+            </a:pPr>
+            <a:r>
+              <a:rPr lang="en-US" sz="950" dirty="0">
+                <a:solidFill>
+                  <a:srgbClr val="6C7680"/>
+                </a:solidFill>
+                <a:latin typeface="Malgun Gothic" pitchFamily="34" charset="0"/>
+                <a:ea typeface="Malgun Gothic" pitchFamily="34" charset="-122"/>
+                <a:cs typeface="Malgun Gothic" pitchFamily="34" charset="-120"/>
+              </a:rPr>
+              <a:t>추정 편도 한계</a:t>
+            </a:r>
+            <a:endParaRPr lang="en-US" sz="950" dirty="0"/>
+          </a:p>
+        </p:txBody>
+      </p:sp>
+      <p:sp>
+        <p:nvSpPr>
+          <p:cNvPr id="26" name="Shape 24"/>
+          <p:cNvSpPr/>
+          <p:nvPr/>
+        </p:nvSpPr>
+        <p:spPr>
+          <a:xfrm>
+            <a:off x="6995160" y="5074920"/>
+            <a:ext cx="3931920" cy="932688"/>
+          </a:xfrm>
+          <a:prstGeom prst="rect">
+            <a:avLst/>
+          </a:prstGeom>
+          <a:solidFill>
+            <a:srgbClr val="FFFFFF"/>
+          </a:solidFill>
+          <a:ln w="12700">
+            <a:solidFill>
+              <a:srgbClr val="C89B3C"/>
+            </a:solidFill>
+            <a:prstDash val="solid"/>
+          </a:ln>
+        </p:spPr>
+      </p:sp>
+      <p:sp>
+        <p:nvSpPr>
           <p:cNvPr id="27" name="Text 25"/>
           <p:cNvSpPr/>
           <p:nvPr/>
@@ -11151,7 +11151,7 @@
                 <a:ea typeface="Malgun Gothic" pitchFamily="34" charset="-122"/>
                 <a:cs typeface="Malgun Gothic" pitchFamily="34" charset="-120"/>
               </a:rPr>
-              <a:t>35 km 기본안 성립</a:t>
+              <a:t>35 km 하이브리드 성립</a:t>
             </a:r>
             <a:endParaRPr lang="en-US" sz="2000" dirty="0"/>
           </a:p>
@@ -11190,7 +11190,7 @@
                 <a:ea typeface="Malgun Gothic" pitchFamily="34" charset="-122"/>
                 <a:cs typeface="Malgun Gothic" pitchFamily="34" charset="-120"/>
               </a:rPr>
-              <a:t>현재 설계 가능</a:t>
+              <a:t>보조 warm-up 필요</a:t>
             </a:r>
             <a:endParaRPr lang="en-US" sz="950" dirty="0"/>
           </a:p>
@@ -15334,7 +15334,7 @@
                 <a:ea typeface="Malgun Gothic" pitchFamily="34" charset="-122"/>
                 <a:cs typeface="Malgun Gothic" pitchFamily="34" charset="-120"/>
               </a:rPr>
-              <a:t>22.2 kW</a:t>
+              <a:t>145.9 kW</a:t>
             </a:r>
             <a:endParaRPr lang="en-US" sz="950" dirty="0"/>
           </a:p>
@@ -15476,7 +15476,7 @@
                 <a:ea typeface="Malgun Gothic" pitchFamily="34" charset="-122"/>
                 <a:cs typeface="Malgun Gothic" pitchFamily="34" charset="-120"/>
               </a:rPr>
-              <a:t>220.5 kW</a:t>
+              <a:t>344.2 kW</a:t>
             </a:r>
             <a:endParaRPr lang="en-US" sz="950" dirty="0"/>
           </a:p>
@@ -15618,7 +15618,7 @@
                 <a:ea typeface="Malgun Gothic" pitchFamily="34" charset="-122"/>
                 <a:cs typeface="Malgun Gothic" pitchFamily="34" charset="-120"/>
               </a:rPr>
-              <a:t>235.2 kW</a:t>
+              <a:t>358.9 kW</a:t>
             </a:r>
             <a:endParaRPr lang="en-US" sz="950" dirty="0"/>
           </a:p>

</xml_diff>

<commit_message>
Complete hybrid economics and sensitivity studies
</commit_message>
<xml_diff>
--- a/deliverables/presentation_draft.pptx
+++ b/deliverables/presentation_draft.pptx
@@ -8744,7 +8744,7 @@
                 <a:ea typeface="Malgun Gothic" pitchFamily="34" charset="-122"/>
                 <a:cs typeface="Malgun Gothic" pitchFamily="34" charset="-120"/>
               </a:rPr>
-              <a:t>하이브리드 보조 열원은 별도 시나리오 테이블로 해석하고, 추가 CAPEX는 아직 보수적으로 제외했다.</a:t>
+              <a:t>보조 열원까지 포함한 재무 최선 시나리오는 Ambient-air trim heater이며 NPV는 -44.93 십억원이다.</a:t>
             </a:r>
             <a:endParaRPr lang="en-US" sz="1400" dirty="0"/>
           </a:p>
@@ -9146,6 +9146,23 @@
             </a:r>
             <a:endParaRPr lang="en-US" sz="1400" dirty="0"/>
           </a:p>
+          <a:p>
+            <a:pPr indent="0" marL="0">
+              <a:buNone/>
+            </a:pPr>
+            <a:r>
+              <a:rPr lang="en-US" sz="1400" dirty="0">
+                <a:solidFill>
+                  <a:srgbClr val="2C3842"/>
+                </a:solidFill>
+                <a:latin typeface="Malgun Gothic" pitchFamily="34" charset="0"/>
+                <a:ea typeface="Malgun Gothic" pitchFamily="34" charset="-122"/>
+                <a:cs typeface="Malgun Gothic" pitchFamily="34" charset="-120"/>
+              </a:rPr>
+              <a:t>Transport proxy를 바꾸면 기화기 면적이 0.00%~91.87% 흔들린다.</a:t>
+            </a:r>
+            <a:endParaRPr lang="en-US" sz="1400" dirty="0"/>
+          </a:p>
         </p:txBody>
       </p:sp>
       <p:sp>
@@ -9440,6 +9457,23 @@
                 <a:cs typeface="Malgun Gothic" pitchFamily="34" charset="-120"/>
               </a:rPr>
               <a:t>이번 재구축은 계산 자동화와 민감도 분석까지 연결한다.</a:t>
+            </a:r>
+            <a:endParaRPr lang="en-US" sz="1400" dirty="0"/>
+          </a:p>
+          <a:p>
+            <a:pPr indent="0" marL="0">
+              <a:buNone/>
+            </a:pPr>
+            <a:r>
+              <a:rPr lang="en-US" sz="1400" dirty="0">
+                <a:solidFill>
+                  <a:srgbClr val="2C3842"/>
+                </a:solidFill>
+                <a:latin typeface="Malgun Gothic" pitchFamily="34" charset="0"/>
+                <a:ea typeface="Malgun Gothic" pitchFamily="34" charset="-122"/>
+                <a:cs typeface="Malgun Gothic" pitchFamily="34" charset="-120"/>
+              </a:rPr>
+              <a:t>IDC 2차 루프는 보수적 네트워크에서 펌프동력이 154.8 kW까지 증가할 수 있다.</a:t>
             </a:r>
             <a:endParaRPr lang="en-US" sz="1400" dirty="0"/>
           </a:p>

</xml_diff>

<commit_message>
Clarify hybrid operability and harden deliverables
</commit_message>
<xml_diff>
--- a/deliverables/presentation_draft.pptx
+++ b/deliverables/presentation_draft.pptx
@@ -5597,7 +5597,7 @@
                 <a:ea typeface="Malgun Gothic" pitchFamily="34" charset="-122"/>
                 <a:cs typeface="Malgun Gothic" pitchFamily="34" charset="-120"/>
               </a:rPr>
-              <a:t>기본 5 km 조건은 하이브리드 운전으로는 성립하지만 supplemental warm-up이 필요하다.</a:t>
+              <a:t>기본 10 km 조건은 하이브리드 운전으로는 성립하지만 supplemental warm-up이 필요하다.</a:t>
             </a:r>
             <a:endParaRPr lang="en-US" sz="1580" dirty="0"/>
           </a:p>
@@ -5669,7 +5669,7 @@
                 <a:ea typeface="Malgun Gothic" pitchFamily="34" charset="-122"/>
                 <a:cs typeface="Malgun Gothic" pitchFamily="34" charset="-120"/>
               </a:rPr>
-              <a:t>즉 35 km 조건은 하이브리드 성립이지만 기본 LNG duty는 불성립이다.</a:t>
+              <a:t>즉 35 km 조건은 하이브리드 운전은 가능하지만 기본 LNG duty는 불성립이다.</a:t>
             </a:r>
             <a:endParaRPr lang="en-US" sz="1580" dirty="0"/>
           </a:p>
@@ -9262,7 +9262,7 @@
                 <a:ea typeface="Malgun Gothic" pitchFamily="34" charset="-122"/>
                 <a:cs typeface="Malgun Gothic" pitchFamily="34" charset="-120"/>
               </a:rPr>
-              <a:t>현재 35 km는 하이브리드 성립이지만 기본 LNG duty는 부족하다.</a:t>
+              <a:t>현재 35 km는 하이브리드 운전은 가능하지만 기본 LNG duty는 부족하다.</a:t>
             </a:r>
             <a:endParaRPr lang="en-US" sz="1400" dirty="0"/>
           </a:p>
@@ -10901,7 +10901,7 @@
                 <a:ea typeface="Malgun Gothic" pitchFamily="34" charset="-122"/>
                 <a:cs typeface="Malgun Gothic" pitchFamily="34" charset="-120"/>
               </a:rPr>
-              <a:t>10 km 하이브리드 성립</a:t>
+              <a:t>10 km 하이브리드 운전 가능</a:t>
             </a:r>
             <a:endParaRPr lang="en-US" sz="2000" dirty="0"/>
           </a:p>
@@ -11082,7 +11082,7 @@
                 <a:ea typeface="Malgun Gothic" pitchFamily="34" charset="-122"/>
                 <a:cs typeface="Malgun Gothic" pitchFamily="34" charset="-120"/>
               </a:rPr>
-              <a:t>추정 편도 한계</a:t>
+              <a:t>추정 하이브리드 편도 한계</a:t>
             </a:r>
             <a:endParaRPr lang="en-US" sz="950" dirty="0"/>
           </a:p>
@@ -11185,7 +11185,7 @@
                 <a:ea typeface="Malgun Gothic" pitchFamily="34" charset="-122"/>
                 <a:cs typeface="Malgun Gothic" pitchFamily="34" charset="-120"/>
               </a:rPr>
-              <a:t>35 km 하이브리드 성립</a:t>
+              <a:t>35 km 하이브리드 운전 가능</a:t>
             </a:r>
             <a:endParaRPr lang="en-US" sz="2000" dirty="0"/>
           </a:p>
@@ -15471,7 +15471,7 @@
                 <a:ea typeface="Malgun Gothic" pitchFamily="34" charset="-122"/>
                 <a:cs typeface="Malgun Gothic" pitchFamily="34" charset="-120"/>
               </a:rPr>
-              <a:t>R-290 (Propane)</a:t>
+              <a:t>R-717 (Ammonia)</a:t>
             </a:r>
             <a:endParaRPr lang="en-US" sz="2000" dirty="0"/>
           </a:p>
@@ -15510,7 +15510,7 @@
                 <a:ea typeface="Malgun Gothic" pitchFamily="34" charset="-122"/>
                 <a:cs typeface="Malgun Gothic" pitchFamily="34" charset="-120"/>
               </a:rPr>
-              <a:t>344.2 kW</a:t>
+              <a:t>145.9 kW</a:t>
             </a:r>
             <a:endParaRPr lang="en-US" sz="950" dirty="0"/>
           </a:p>
@@ -15613,7 +15613,7 @@
                 <a:ea typeface="Malgun Gothic" pitchFamily="34" charset="-122"/>
                 <a:cs typeface="Malgun Gothic" pitchFamily="34" charset="-120"/>
               </a:rPr>
-              <a:t>R-600a (Isobutane)</a:t>
+              <a:t>R-717 (Ammonia)</a:t>
             </a:r>
             <a:endParaRPr lang="en-US" sz="2000" dirty="0"/>
           </a:p>
@@ -15652,7 +15652,7 @@
                 <a:ea typeface="Malgun Gothic" pitchFamily="34" charset="-122"/>
                 <a:cs typeface="Malgun Gothic" pitchFamily="34" charset="-120"/>
               </a:rPr>
-              <a:t>358.9 kW</a:t>
+              <a:t>145.9 kW</a:t>
             </a:r>
             <a:endParaRPr lang="en-US" sz="950" dirty="0"/>
           </a:p>

</xml_diff>